<commit_message>
Phone preview: calls handled by the AI alone; group-only column subtitles
Co-Authored-By: Claude Opus 5.5 <noreply@anthropic.com>
Claude-Session: https://claude.ai/code/session_01Xa4nFVxuQGXmHARGph9WhS
</commit_message>
<xml_diff>
--- a/day2-deck/decks/Phone Handling - Preview.pptx
+++ b/day2-deck/decks/Phone Handling - Preview.pptx
@@ -503,7 +503,7 @@
           <a:p>
             <a:r>
               <a:rPr lang="en-US" dirty="0"/>
-              <a:t>Source: Flai voice AI dashboard, Service view, standings export, Jul 26 - Oct 26, 2026 (93 days). Flai's location names (26 with calls). Pickup rate and resolution as Flai reports them. Flai's estimated savings, revenue and profit are not used. Not picked up = transfers x (1 - pickup rate), from Flai's group figures.</a:t>
+              <a:t>Source: Flai voice AI dashboard, Service view, standings export, Jul 26 - Oct 26, 2026 (93 days). Flai's location names (26 with calls). Pickup rate and resolution as Flai reports them. Flai's estimated savings, revenue and profit are not used. Handled by the AI alone = calls - transfers (the export has no separate column for it). Not picked up = transfers x (1 - pickup rate), from Flai's group figures.</a:t>
             </a:r>
             <a:endParaRPr lang="en-US" dirty="0"/>
           </a:p>
@@ -1436,7 +1436,7 @@
             <a:avLst/>
           </a:prstGeom>
           <a:solidFill>
-            <a:srgbClr val="2587C5"/>
+            <a:srgbClr val="12A566"/>
           </a:solidFill>
           <a:ln/>
         </p:spPr>
@@ -1474,7 +1474,7 @@
                 <a:ea typeface="Inter" pitchFamily="34" charset="-122"/>
                 <a:cs typeface="Inter" pitchFamily="34" charset="-120"/>
               </a:rPr>
-              <a:t>HANDED TO A PERSON</a:t>
+              <a:t>HANDLED BY THE AI ALONE</a:t>
             </a:r>
             <a:endParaRPr lang="en-US" sz="1400" dirty="0"/>
           </a:p>
@@ -1509,13 +1509,13 @@
             <a:r>
               <a:rPr lang="en-US" sz="3600" b="1" dirty="0">
                 <a:solidFill>
-                  <a:srgbClr val="0B2C4A"/>
-                </a:solidFill>
-                <a:latin typeface="Inter" pitchFamily="34" charset="0"/>
-                <a:ea typeface="Inter" pitchFamily="34" charset="-122"/>
-                <a:cs typeface="Inter" pitchFamily="34" charset="-120"/>
-              </a:rPr>
-              <a:t>53.5%</a:t>
+                  <a:srgbClr val="0B7A4A"/>
+                </a:solidFill>
+                <a:latin typeface="Inter" pitchFamily="34" charset="0"/>
+                <a:ea typeface="Inter" pitchFamily="34" charset="-122"/>
+                <a:cs typeface="Inter" pitchFamily="34" charset="-120"/>
+              </a:rPr>
+              <a:t>22,749</a:t>
             </a:r>
             <a:endParaRPr lang="en-US" sz="3600" dirty="0"/>
           </a:p>
@@ -1554,7 +1554,7 @@
                 <a:ea typeface="Inter" pitchFamily="34" charset="-122"/>
                 <a:cs typeface="Inter" pitchFamily="34" charset="-120"/>
               </a:rPr>
-              <a:t>26,215 calls transferred to the store.</a:t>
+              <a:t>46.5% of calls, start to finish. The other 26,215 (53.5%) were transferred to the store.</a:t>
             </a:r>
             <a:endParaRPr lang="en-US" sz="1400" dirty="0"/>
           </a:p>
@@ -1811,7 +1811,7 @@
                 <a:ea typeface="Inter" pitchFamily="34" charset="-122"/>
                 <a:cs typeface="Inter" pitchFamily="34" charset="-120"/>
               </a:rPr>
-              <a:t>More than half of all calls come back to the store, and fewer than half of those reach a person. Every unanswered transfer is a customer we already had.</a:t>
+              <a:t>The AI finishes 46.5% of calls on its own. The rest come back to the store, and fewer than half of those reach a person. Every unanswered transfer is a customer we already had.</a:t>
             </a:r>
             <a:endParaRPr lang="en-US" sz="1600" dirty="0"/>
           </a:p>
@@ -2039,7 +2039,7 @@
                 <a:ea typeface="Inter" pitchFamily="34" charset="-122"/>
                 <a:cs typeface="Inter" pitchFamily="34" charset="-120"/>
               </a:rPr>
-              <a:t>booked ÷ bookable · group 72%</a:t>
+              <a:t>Group 72%</a:t>
             </a:r>
             <a:endParaRPr lang="en-US" sz="1400" dirty="0"/>
           </a:p>
@@ -3425,7 +3425,7 @@
                 <a:ea typeface="Inter" pitchFamily="34" charset="-122"/>
                 <a:cs typeface="Inter" pitchFamily="34" charset="-120"/>
               </a:rPr>
-              <a:t>transfers picked up · group 47.7%</a:t>
+              <a:t>Group 47.7%</a:t>
             </a:r>
             <a:endParaRPr lang="en-US" sz="1400" dirty="0"/>
           </a:p>
@@ -4811,7 +4811,7 @@
                 <a:ea typeface="Inter" pitchFamily="34" charset="-122"/>
                 <a:cs typeface="Inter" pitchFamily="34" charset="-120"/>
               </a:rPr>
-              <a:t>callbacks closed · group 98.2%</a:t>
+              <a:t>Group 98.2%</a:t>
             </a:r>
             <a:endParaRPr lang="en-US" sz="1400" dirty="0"/>
           </a:p>

</xml_diff>

<commit_message>
Phone preview: swap AI-alone and appointments tiles; callbacks closed in the Flai dashboard
Co-Authored-By: Claude Opus 5.5 <noreply@anthropic.com>
Claude-Session: https://claude.ai/code/session_01Xa4nFVxuQGXmHARGph9WhS
</commit_message>
<xml_diff>
--- a/day2-deck/decks/Phone Handling - Preview.pptx
+++ b/day2-deck/decks/Phone Handling - Preview.pptx
@@ -1315,7 +1315,7 @@
                 <a:ea typeface="Inter" pitchFamily="34" charset="-122"/>
                 <a:cs typeface="Inter" pitchFamily="34" charset="-120"/>
               </a:rPr>
-              <a:t>APPOINTMENTS BOOKED</a:t>
+              <a:t>HANDLED BY THE AI ALONE</a:t>
             </a:r>
             <a:endParaRPr lang="en-US" sz="1400" dirty="0"/>
           </a:p>
@@ -1356,7 +1356,7 @@
                 <a:ea typeface="Inter" pitchFamily="34" charset="-122"/>
                 <a:cs typeface="Inter" pitchFamily="34" charset="-120"/>
               </a:rPr>
-              <a:t>10,841</a:t>
+              <a:t>22,749</a:t>
             </a:r>
             <a:endParaRPr lang="en-US" sz="3600" dirty="0"/>
           </a:p>
@@ -1395,7 +1395,7 @@
                 <a:ea typeface="Inter" pitchFamily="34" charset="-122"/>
                 <a:cs typeface="Inter" pitchFamily="34" charset="-120"/>
               </a:rPr>
-              <a:t>72% of the 15,051 calls that could book an appointment.</a:t>
+              <a:t>46.5% of calls, start to finish. The other 26,215 (53.5%) were transferred to the store.</a:t>
             </a:r>
             <a:endParaRPr lang="en-US" sz="1400" dirty="0"/>
           </a:p>
@@ -1474,7 +1474,7 @@
                 <a:ea typeface="Inter" pitchFamily="34" charset="-122"/>
                 <a:cs typeface="Inter" pitchFamily="34" charset="-120"/>
               </a:rPr>
-              <a:t>HANDLED BY THE AI ALONE</a:t>
+              <a:t>APPOINTMENTS BOOKED</a:t>
             </a:r>
             <a:endParaRPr lang="en-US" sz="1400" dirty="0"/>
           </a:p>
@@ -1515,7 +1515,7 @@
                 <a:ea typeface="Inter" pitchFamily="34" charset="-122"/>
                 <a:cs typeface="Inter" pitchFamily="34" charset="-120"/>
               </a:rPr>
-              <a:t>22,749</a:t>
+              <a:t>10,841</a:t>
             </a:r>
             <a:endParaRPr lang="en-US" sz="3600" dirty="0"/>
           </a:p>
@@ -1554,7 +1554,7 @@
                 <a:ea typeface="Inter" pitchFamily="34" charset="-122"/>
                 <a:cs typeface="Inter" pitchFamily="34" charset="-120"/>
               </a:rPr>
-              <a:t>46.5% of calls, start to finish. The other 26,215 (53.5%) were transferred to the store.</a:t>
+              <a:t>72% of the 15,051 calls that could book an appointment.</a:t>
             </a:r>
             <a:endParaRPr lang="en-US" sz="1400" dirty="0"/>
           </a:p>
@@ -1752,7 +1752,7 @@
                 <a:ea typeface="Inter" pitchFamily="34" charset="-122"/>
                 <a:cs typeface="Inter" pitchFamily="34" charset="-120"/>
               </a:rPr>
-              <a:t>484 callbacks still open. The AI books and routes the call; the store still has to answer the transfer and close the callback.</a:t>
+              <a:t>The AI books and routes the call; the store still has to answer the transfer and close every callback in the Flai dashboard.</a:t>
             </a:r>
             <a:endParaRPr lang="en-US" sz="1700" dirty="0"/>
           </a:p>

</xml_diff>

<commit_message>
Phone preview: column heads instead of per-row units
Co-Authored-By: Claude Opus 5.5 <noreply@anthropic.com>
Claude-Session: https://claude.ai/code/session_01Xa4nFVxuQGXmHARGph9WhS
</commit_message>
<xml_diff>
--- a/day2-deck/decks/Phone Handling - Preview.pptx
+++ b/day2-deck/decks/Phone Handling - Preview.pptx
@@ -2112,6 +2112,84 @@
         </p:nvSpPr>
         <p:spPr>
           <a:xfrm>
+            <a:off x="2313432" y="1938528"/>
+            <a:ext cx="731520" cy="219456"/>
+          </a:xfrm>
+          <a:prstGeom prst="rect">
+            <a:avLst/>
+          </a:prstGeom>
+          <a:noFill/>
+          <a:ln/>
+        </p:spPr>
+        <p:txBody>
+          <a:bodyPr wrap="square" lIns="0" tIns="0" rIns="0" bIns="0" rtlCol="0" anchor="ctr"/>
+          <a:lstStyle/>
+          <a:p>
+            <a:pPr algn="r" indent="0" marL="0">
+              <a:buNone/>
+            </a:pPr>
+            <a:r>
+              <a:rPr lang="en-US" sz="1400" b="1" dirty="0">
+                <a:solidFill>
+                  <a:srgbClr val="595959"/>
+                </a:solidFill>
+                <a:latin typeface="Inter" pitchFamily="34" charset="0"/>
+                <a:ea typeface="Inter" pitchFamily="34" charset="-122"/>
+                <a:cs typeface="Inter" pitchFamily="34" charset="-120"/>
+              </a:rPr>
+              <a:t>Rate</a:t>
+            </a:r>
+            <a:endParaRPr lang="en-US" sz="1400" dirty="0"/>
+          </a:p>
+        </p:txBody>
+      </p:sp>
+      <p:sp>
+        <p:nvSpPr>
+          <p:cNvPr id="11" name="Text 9"/>
+          <p:cNvSpPr txBox="1"/>
+          <p:nvPr/>
+        </p:nvSpPr>
+        <p:spPr>
+          <a:xfrm>
+            <a:off x="3063240" y="1938528"/>
+            <a:ext cx="914400" cy="219456"/>
+          </a:xfrm>
+          <a:prstGeom prst="rect">
+            <a:avLst/>
+          </a:prstGeom>
+          <a:noFill/>
+          <a:ln/>
+        </p:spPr>
+        <p:txBody>
+          <a:bodyPr wrap="square" lIns="0" tIns="0" rIns="0" bIns="0" rtlCol="0" anchor="ctr"/>
+          <a:lstStyle/>
+          <a:p>
+            <a:pPr algn="r" indent="0" marL="0">
+              <a:buNone/>
+            </a:pPr>
+            <a:r>
+              <a:rPr lang="en-US" sz="1400" b="1" dirty="0">
+                <a:solidFill>
+                  <a:srgbClr val="595959"/>
+                </a:solidFill>
+                <a:latin typeface="Inter" pitchFamily="34" charset="0"/>
+                <a:ea typeface="Inter" pitchFamily="34" charset="-122"/>
+                <a:cs typeface="Inter" pitchFamily="34" charset="-120"/>
+              </a:rPr>
+              <a:t>Calls</a:t>
+            </a:r>
+            <a:endParaRPr lang="en-US" sz="1400" dirty="0"/>
+          </a:p>
+        </p:txBody>
+      </p:sp>
+      <p:sp>
+        <p:nvSpPr>
+          <p:cNvPr id="12" name="Text 10"/>
+          <p:cNvSpPr txBox="1"/>
+          <p:nvPr/>
+        </p:nvSpPr>
+        <p:spPr>
+          <a:xfrm>
             <a:off x="621792" y="2167128"/>
             <a:ext cx="1673352" cy="345643"/>
           </a:xfrm>
@@ -2145,7 +2223,7 @@
       </p:sp>
       <p:sp>
         <p:nvSpPr>
-          <p:cNvPr id="11" name="Text 9"/>
+          <p:cNvPr id="13" name="Text 11"/>
           <p:cNvSpPr txBox="1"/>
           <p:nvPr/>
         </p:nvSpPr>
@@ -2184,7 +2262,7 @@
       </p:sp>
       <p:sp>
         <p:nvSpPr>
-          <p:cNvPr id="12" name="Text 10"/>
+          <p:cNvPr id="14" name="Text 12"/>
           <p:cNvSpPr txBox="1"/>
           <p:nvPr/>
         </p:nvSpPr>
@@ -2215,7 +2293,7 @@
                 <a:ea typeface="Inter" pitchFamily="34" charset="-122"/>
                 <a:cs typeface="Inter" pitchFamily="34" charset="-120"/>
               </a:rPr>
-              <a:t>1,030 calls</a:t>
+              <a:t>1,030</a:t>
             </a:r>
             <a:endParaRPr lang="en-US" sz="1200" dirty="0"/>
           </a:p>
@@ -2223,7 +2301,7 @@
       </p:sp>
       <p:sp>
         <p:nvSpPr>
-          <p:cNvPr id="13" name="Text 11"/>
+          <p:cNvPr id="15" name="Text 13"/>
           <p:cNvSpPr txBox="1"/>
           <p:nvPr/>
         </p:nvSpPr>
@@ -2262,7 +2340,7 @@
       </p:sp>
       <p:sp>
         <p:nvSpPr>
-          <p:cNvPr id="14" name="Text 12"/>
+          <p:cNvPr id="16" name="Text 14"/>
           <p:cNvSpPr txBox="1"/>
           <p:nvPr/>
         </p:nvSpPr>
@@ -2301,7 +2379,7 @@
       </p:sp>
       <p:sp>
         <p:nvSpPr>
-          <p:cNvPr id="15" name="Text 13"/>
+          <p:cNvPr id="17" name="Text 15"/>
           <p:cNvSpPr txBox="1"/>
           <p:nvPr/>
         </p:nvSpPr>
@@ -2332,7 +2410,7 @@
                 <a:ea typeface="Inter" pitchFamily="34" charset="-122"/>
                 <a:cs typeface="Inter" pitchFamily="34" charset="-120"/>
               </a:rPr>
-              <a:t>4,349 calls</a:t>
+              <a:t>4,349</a:t>
             </a:r>
             <a:endParaRPr lang="en-US" sz="1200" dirty="0"/>
           </a:p>
@@ -2340,7 +2418,7 @@
       </p:sp>
       <p:sp>
         <p:nvSpPr>
-          <p:cNvPr id="16" name="Text 14"/>
+          <p:cNvPr id="18" name="Text 16"/>
           <p:cNvSpPr txBox="1"/>
           <p:nvPr/>
         </p:nvSpPr>
@@ -2379,7 +2457,7 @@
       </p:sp>
       <p:sp>
         <p:nvSpPr>
-          <p:cNvPr id="17" name="Text 15"/>
+          <p:cNvPr id="19" name="Text 17"/>
           <p:cNvSpPr txBox="1"/>
           <p:nvPr/>
         </p:nvSpPr>
@@ -2418,7 +2496,7 @@
       </p:sp>
       <p:sp>
         <p:nvSpPr>
-          <p:cNvPr id="18" name="Text 16"/>
+          <p:cNvPr id="20" name="Text 18"/>
           <p:cNvSpPr txBox="1"/>
           <p:nvPr/>
         </p:nvSpPr>
@@ -2449,7 +2527,7 @@
                 <a:ea typeface="Inter" pitchFamily="34" charset="-122"/>
                 <a:cs typeface="Inter" pitchFamily="34" charset="-120"/>
               </a:rPr>
-              <a:t>696 calls</a:t>
+              <a:t>696</a:t>
             </a:r>
             <a:endParaRPr lang="en-US" sz="1200" dirty="0"/>
           </a:p>
@@ -2457,7 +2535,7 @@
       </p:sp>
       <p:sp>
         <p:nvSpPr>
-          <p:cNvPr id="19" name="Text 17"/>
+          <p:cNvPr id="21" name="Text 19"/>
           <p:cNvSpPr txBox="1"/>
           <p:nvPr/>
         </p:nvSpPr>
@@ -2496,7 +2574,7 @@
       </p:sp>
       <p:sp>
         <p:nvSpPr>
-          <p:cNvPr id="20" name="Text 18"/>
+          <p:cNvPr id="22" name="Text 20"/>
           <p:cNvSpPr txBox="1"/>
           <p:nvPr/>
         </p:nvSpPr>
@@ -2535,7 +2613,7 @@
       </p:sp>
       <p:sp>
         <p:nvSpPr>
-          <p:cNvPr id="21" name="Text 19"/>
+          <p:cNvPr id="23" name="Text 21"/>
           <p:cNvSpPr txBox="1"/>
           <p:nvPr/>
         </p:nvSpPr>
@@ -2566,7 +2644,7 @@
                 <a:ea typeface="Inter" pitchFamily="34" charset="-122"/>
                 <a:cs typeface="Inter" pitchFamily="34" charset="-120"/>
               </a:rPr>
-              <a:t>876 calls</a:t>
+              <a:t>876</a:t>
             </a:r>
             <a:endParaRPr lang="en-US" sz="1200" dirty="0"/>
           </a:p>
@@ -2574,7 +2652,7 @@
       </p:sp>
       <p:sp>
         <p:nvSpPr>
-          <p:cNvPr id="22" name="Text 20"/>
+          <p:cNvPr id="24" name="Text 22"/>
           <p:cNvSpPr txBox="1"/>
           <p:nvPr/>
         </p:nvSpPr>
@@ -2613,7 +2691,7 @@
       </p:sp>
       <p:sp>
         <p:nvSpPr>
-          <p:cNvPr id="23" name="Text 21"/>
+          <p:cNvPr id="25" name="Text 23"/>
           <p:cNvSpPr txBox="1"/>
           <p:nvPr/>
         </p:nvSpPr>
@@ -2652,7 +2730,7 @@
       </p:sp>
       <p:sp>
         <p:nvSpPr>
-          <p:cNvPr id="24" name="Text 22"/>
+          <p:cNvPr id="26" name="Text 24"/>
           <p:cNvSpPr txBox="1"/>
           <p:nvPr/>
         </p:nvSpPr>
@@ -2683,7 +2761,7 @@
                 <a:ea typeface="Inter" pitchFamily="34" charset="-122"/>
                 <a:cs typeface="Inter" pitchFamily="34" charset="-120"/>
               </a:rPr>
-              <a:t>6,915 calls</a:t>
+              <a:t>6,915</a:t>
             </a:r>
             <a:endParaRPr lang="en-US" sz="1200" dirty="0"/>
           </a:p>
@@ -2691,7 +2769,7 @@
       </p:sp>
       <p:sp>
         <p:nvSpPr>
-          <p:cNvPr id="25" name="Shape 23"/>
+          <p:cNvPr id="27" name="Shape 25"/>
           <p:cNvSpPr/>
           <p:nvPr/>
         </p:nvSpPr>
@@ -2711,7 +2789,7 @@
       </p:sp>
       <p:sp>
         <p:nvSpPr>
-          <p:cNvPr id="26" name="Text 24"/>
+          <p:cNvPr id="28" name="Text 26"/>
           <p:cNvSpPr txBox="1"/>
           <p:nvPr/>
         </p:nvSpPr>
@@ -2750,7 +2828,85 @@
       </p:sp>
       <p:sp>
         <p:nvSpPr>
-          <p:cNvPr id="27" name="Text 25"/>
+          <p:cNvPr id="29" name="Text 27"/>
+          <p:cNvSpPr txBox="1"/>
+          <p:nvPr/>
+        </p:nvSpPr>
+        <p:spPr>
+          <a:xfrm>
+            <a:off x="2313432" y="3941064"/>
+            <a:ext cx="731520" cy="219456"/>
+          </a:xfrm>
+          <a:prstGeom prst="rect">
+            <a:avLst/>
+          </a:prstGeom>
+          <a:noFill/>
+          <a:ln/>
+        </p:spPr>
+        <p:txBody>
+          <a:bodyPr wrap="square" lIns="0" tIns="0" rIns="0" bIns="0" rtlCol="0" anchor="ctr"/>
+          <a:lstStyle/>
+          <a:p>
+            <a:pPr algn="r" indent="0" marL="0">
+              <a:buNone/>
+            </a:pPr>
+            <a:r>
+              <a:rPr lang="en-US" sz="1400" b="1" dirty="0">
+                <a:solidFill>
+                  <a:srgbClr val="595959"/>
+                </a:solidFill>
+                <a:latin typeface="Inter" pitchFamily="34" charset="0"/>
+                <a:ea typeface="Inter" pitchFamily="34" charset="-122"/>
+                <a:cs typeface="Inter" pitchFamily="34" charset="-120"/>
+              </a:rPr>
+              <a:t>Rate</a:t>
+            </a:r>
+            <a:endParaRPr lang="en-US" sz="1400" dirty="0"/>
+          </a:p>
+        </p:txBody>
+      </p:sp>
+      <p:sp>
+        <p:nvSpPr>
+          <p:cNvPr id="30" name="Text 28"/>
+          <p:cNvSpPr txBox="1"/>
+          <p:nvPr/>
+        </p:nvSpPr>
+        <p:spPr>
+          <a:xfrm>
+            <a:off x="3063240" y="3941064"/>
+            <a:ext cx="914400" cy="219456"/>
+          </a:xfrm>
+          <a:prstGeom prst="rect">
+            <a:avLst/>
+          </a:prstGeom>
+          <a:noFill/>
+          <a:ln/>
+        </p:spPr>
+        <p:txBody>
+          <a:bodyPr wrap="square" lIns="0" tIns="0" rIns="0" bIns="0" rtlCol="0" anchor="ctr"/>
+          <a:lstStyle/>
+          <a:p>
+            <a:pPr algn="r" indent="0" marL="0">
+              <a:buNone/>
+            </a:pPr>
+            <a:r>
+              <a:rPr lang="en-US" sz="1400" b="1" dirty="0">
+                <a:solidFill>
+                  <a:srgbClr val="595959"/>
+                </a:solidFill>
+                <a:latin typeface="Inter" pitchFamily="34" charset="0"/>
+                <a:ea typeface="Inter" pitchFamily="34" charset="-122"/>
+                <a:cs typeface="Inter" pitchFamily="34" charset="-120"/>
+              </a:rPr>
+              <a:t>Calls</a:t>
+            </a:r>
+            <a:endParaRPr lang="en-US" sz="1400" dirty="0"/>
+          </a:p>
+        </p:txBody>
+      </p:sp>
+      <p:sp>
+        <p:nvSpPr>
+          <p:cNvPr id="31" name="Text 29"/>
           <p:cNvSpPr txBox="1"/>
           <p:nvPr/>
         </p:nvSpPr>
@@ -2789,7 +2945,7 @@
       </p:sp>
       <p:sp>
         <p:nvSpPr>
-          <p:cNvPr id="28" name="Text 26"/>
+          <p:cNvPr id="32" name="Text 30"/>
           <p:cNvSpPr txBox="1"/>
           <p:nvPr/>
         </p:nvSpPr>
@@ -2828,7 +2984,7 @@
       </p:sp>
       <p:sp>
         <p:nvSpPr>
-          <p:cNvPr id="29" name="Text 27"/>
+          <p:cNvPr id="33" name="Text 31"/>
           <p:cNvSpPr txBox="1"/>
           <p:nvPr/>
         </p:nvSpPr>
@@ -2859,7 +3015,7 @@
                 <a:ea typeface="Inter" pitchFamily="34" charset="-122"/>
                 <a:cs typeface="Inter" pitchFamily="34" charset="-120"/>
               </a:rPr>
-              <a:t>2,247 calls</a:t>
+              <a:t>2,247</a:t>
             </a:r>
             <a:endParaRPr lang="en-US" sz="1200" dirty="0"/>
           </a:p>
@@ -2867,7 +3023,7 @@
       </p:sp>
       <p:sp>
         <p:nvSpPr>
-          <p:cNvPr id="30" name="Text 28"/>
+          <p:cNvPr id="34" name="Text 32"/>
           <p:cNvSpPr txBox="1"/>
           <p:nvPr/>
         </p:nvSpPr>
@@ -2906,7 +3062,7 @@
       </p:sp>
       <p:sp>
         <p:nvSpPr>
-          <p:cNvPr id="31" name="Text 29"/>
+          <p:cNvPr id="35" name="Text 33"/>
           <p:cNvSpPr txBox="1"/>
           <p:nvPr/>
         </p:nvSpPr>
@@ -2945,7 +3101,7 @@
       </p:sp>
       <p:sp>
         <p:nvSpPr>
-          <p:cNvPr id="32" name="Text 30"/>
+          <p:cNvPr id="36" name="Text 34"/>
           <p:cNvSpPr txBox="1"/>
           <p:nvPr/>
         </p:nvSpPr>
@@ -2976,7 +3132,7 @@
                 <a:ea typeface="Inter" pitchFamily="34" charset="-122"/>
                 <a:cs typeface="Inter" pitchFamily="34" charset="-120"/>
               </a:rPr>
-              <a:t>896 calls</a:t>
+              <a:t>896</a:t>
             </a:r>
             <a:endParaRPr lang="en-US" sz="1200" dirty="0"/>
           </a:p>
@@ -2984,7 +3140,7 @@
       </p:sp>
       <p:sp>
         <p:nvSpPr>
-          <p:cNvPr id="33" name="Text 31"/>
+          <p:cNvPr id="37" name="Text 35"/>
           <p:cNvSpPr txBox="1"/>
           <p:nvPr/>
         </p:nvSpPr>
@@ -3023,7 +3179,7 @@
       </p:sp>
       <p:sp>
         <p:nvSpPr>
-          <p:cNvPr id="34" name="Text 32"/>
+          <p:cNvPr id="38" name="Text 36"/>
           <p:cNvSpPr txBox="1"/>
           <p:nvPr/>
         </p:nvSpPr>
@@ -3062,7 +3218,7 @@
       </p:sp>
       <p:sp>
         <p:nvSpPr>
-          <p:cNvPr id="35" name="Text 33"/>
+          <p:cNvPr id="39" name="Text 37"/>
           <p:cNvSpPr txBox="1"/>
           <p:nvPr/>
         </p:nvSpPr>
@@ -3093,7 +3249,7 @@
                 <a:ea typeface="Inter" pitchFamily="34" charset="-122"/>
                 <a:cs typeface="Inter" pitchFamily="34" charset="-120"/>
               </a:rPr>
-              <a:t>1,120 calls</a:t>
+              <a:t>1,120</a:t>
             </a:r>
             <a:endParaRPr lang="en-US" sz="1200" dirty="0"/>
           </a:p>
@@ -3101,7 +3257,7 @@
       </p:sp>
       <p:sp>
         <p:nvSpPr>
-          <p:cNvPr id="36" name="Text 34"/>
+          <p:cNvPr id="40" name="Text 38"/>
           <p:cNvSpPr txBox="1"/>
           <p:nvPr/>
         </p:nvSpPr>
@@ -3140,7 +3296,7 @@
       </p:sp>
       <p:sp>
         <p:nvSpPr>
-          <p:cNvPr id="37" name="Text 35"/>
+          <p:cNvPr id="41" name="Text 39"/>
           <p:cNvSpPr txBox="1"/>
           <p:nvPr/>
         </p:nvSpPr>
@@ -3179,7 +3335,7 @@
       </p:sp>
       <p:sp>
         <p:nvSpPr>
-          <p:cNvPr id="38" name="Text 36"/>
+          <p:cNvPr id="42" name="Text 40"/>
           <p:cNvSpPr txBox="1"/>
           <p:nvPr/>
         </p:nvSpPr>
@@ -3210,7 +3366,7 @@
                 <a:ea typeface="Inter" pitchFamily="34" charset="-122"/>
                 <a:cs typeface="Inter" pitchFamily="34" charset="-120"/>
               </a:rPr>
-              <a:t>1,075 calls</a:t>
+              <a:t>1,075</a:t>
             </a:r>
             <a:endParaRPr lang="en-US" sz="1200" dirty="0"/>
           </a:p>
@@ -3218,7 +3374,7 @@
       </p:sp>
       <p:sp>
         <p:nvSpPr>
-          <p:cNvPr id="39" name="Text 37"/>
+          <p:cNvPr id="43" name="Text 41"/>
           <p:cNvSpPr txBox="1"/>
           <p:nvPr/>
         </p:nvSpPr>
@@ -3257,7 +3413,7 @@
       </p:sp>
       <p:sp>
         <p:nvSpPr>
-          <p:cNvPr id="40" name="Text 38"/>
+          <p:cNvPr id="44" name="Text 42"/>
           <p:cNvSpPr txBox="1"/>
           <p:nvPr/>
         </p:nvSpPr>
@@ -3296,7 +3452,7 @@
       </p:sp>
       <p:sp>
         <p:nvSpPr>
-          <p:cNvPr id="41" name="Text 39"/>
+          <p:cNvPr id="45" name="Text 43"/>
           <p:cNvSpPr txBox="1"/>
           <p:nvPr/>
         </p:nvSpPr>
@@ -3327,7 +3483,7 @@
                 <a:ea typeface="Inter" pitchFamily="34" charset="-122"/>
                 <a:cs typeface="Inter" pitchFamily="34" charset="-120"/>
               </a:rPr>
-              <a:t>1,171 calls</a:t>
+              <a:t>1,171</a:t>
             </a:r>
             <a:endParaRPr lang="en-US" sz="1200" dirty="0"/>
           </a:p>
@@ -3335,7 +3491,7 @@
       </p:sp>
       <p:sp>
         <p:nvSpPr>
-          <p:cNvPr id="42" name="Shape 40"/>
+          <p:cNvPr id="46" name="Shape 44"/>
           <p:cNvSpPr/>
           <p:nvPr/>
         </p:nvSpPr>
@@ -3355,7 +3511,7 @@
       </p:sp>
       <p:sp>
         <p:nvSpPr>
-          <p:cNvPr id="43" name="Text 41"/>
+          <p:cNvPr id="47" name="Text 45"/>
           <p:cNvSpPr txBox="1"/>
           <p:nvPr/>
         </p:nvSpPr>
@@ -3394,7 +3550,7 @@
       </p:sp>
       <p:sp>
         <p:nvSpPr>
-          <p:cNvPr id="44" name="Text 42"/>
+          <p:cNvPr id="48" name="Text 46"/>
           <p:cNvSpPr txBox="1"/>
           <p:nvPr/>
         </p:nvSpPr>
@@ -3433,7 +3589,7 @@
       </p:sp>
       <p:sp>
         <p:nvSpPr>
-          <p:cNvPr id="45" name="Shape 43"/>
+          <p:cNvPr id="49" name="Shape 47"/>
           <p:cNvSpPr/>
           <p:nvPr/>
         </p:nvSpPr>
@@ -3453,7 +3609,7 @@
       </p:sp>
       <p:sp>
         <p:nvSpPr>
-          <p:cNvPr id="46" name="Text 44"/>
+          <p:cNvPr id="50" name="Text 48"/>
           <p:cNvSpPr txBox="1"/>
           <p:nvPr/>
         </p:nvSpPr>
@@ -3492,7 +3648,85 @@
       </p:sp>
       <p:sp>
         <p:nvSpPr>
-          <p:cNvPr id="47" name="Text 45"/>
+          <p:cNvPr id="51" name="Text 49"/>
+          <p:cNvSpPr txBox="1"/>
+          <p:nvPr/>
+        </p:nvSpPr>
+        <p:spPr>
+          <a:xfrm>
+            <a:off x="6108192" y="1938528"/>
+            <a:ext cx="731520" cy="219456"/>
+          </a:xfrm>
+          <a:prstGeom prst="rect">
+            <a:avLst/>
+          </a:prstGeom>
+          <a:noFill/>
+          <a:ln/>
+        </p:spPr>
+        <p:txBody>
+          <a:bodyPr wrap="square" lIns="0" tIns="0" rIns="0" bIns="0" rtlCol="0" anchor="ctr"/>
+          <a:lstStyle/>
+          <a:p>
+            <a:pPr algn="r" indent="0" marL="0">
+              <a:buNone/>
+            </a:pPr>
+            <a:r>
+              <a:rPr lang="en-US" sz="1400" b="1" dirty="0">
+                <a:solidFill>
+                  <a:srgbClr val="595959"/>
+                </a:solidFill>
+                <a:latin typeface="Inter" pitchFamily="34" charset="0"/>
+                <a:ea typeface="Inter" pitchFamily="34" charset="-122"/>
+                <a:cs typeface="Inter" pitchFamily="34" charset="-120"/>
+              </a:rPr>
+              <a:t>Rate</a:t>
+            </a:r>
+            <a:endParaRPr lang="en-US" sz="1400" dirty="0"/>
+          </a:p>
+        </p:txBody>
+      </p:sp>
+      <p:sp>
+        <p:nvSpPr>
+          <p:cNvPr id="52" name="Text 50"/>
+          <p:cNvSpPr txBox="1"/>
+          <p:nvPr/>
+        </p:nvSpPr>
+        <p:spPr>
+          <a:xfrm>
+            <a:off x="6858000" y="1938528"/>
+            <a:ext cx="914400" cy="219456"/>
+          </a:xfrm>
+          <a:prstGeom prst="rect">
+            <a:avLst/>
+          </a:prstGeom>
+          <a:noFill/>
+          <a:ln/>
+        </p:spPr>
+        <p:txBody>
+          <a:bodyPr wrap="square" lIns="0" tIns="0" rIns="0" bIns="0" rtlCol="0" anchor="ctr"/>
+          <a:lstStyle/>
+          <a:p>
+            <a:pPr algn="r" indent="0" marL="0">
+              <a:buNone/>
+            </a:pPr>
+            <a:r>
+              <a:rPr lang="en-US" sz="1400" b="1" dirty="0">
+                <a:solidFill>
+                  <a:srgbClr val="595959"/>
+                </a:solidFill>
+                <a:latin typeface="Inter" pitchFamily="34" charset="0"/>
+                <a:ea typeface="Inter" pitchFamily="34" charset="-122"/>
+                <a:cs typeface="Inter" pitchFamily="34" charset="-120"/>
+              </a:rPr>
+              <a:t>Calls</a:t>
+            </a:r>
+            <a:endParaRPr lang="en-US" sz="1400" dirty="0"/>
+          </a:p>
+        </p:txBody>
+      </p:sp>
+      <p:sp>
+        <p:nvSpPr>
+          <p:cNvPr id="53" name="Text 51"/>
           <p:cNvSpPr txBox="1"/>
           <p:nvPr/>
         </p:nvSpPr>
@@ -3531,7 +3765,7 @@
       </p:sp>
       <p:sp>
         <p:nvSpPr>
-          <p:cNvPr id="48" name="Text 46"/>
+          <p:cNvPr id="54" name="Text 52"/>
           <p:cNvSpPr txBox="1"/>
           <p:nvPr/>
         </p:nvSpPr>
@@ -3570,7 +3804,7 @@
       </p:sp>
       <p:sp>
         <p:nvSpPr>
-          <p:cNvPr id="49" name="Text 47"/>
+          <p:cNvPr id="55" name="Text 53"/>
           <p:cNvSpPr txBox="1"/>
           <p:nvPr/>
         </p:nvSpPr>
@@ -3601,7 +3835,7 @@
                 <a:ea typeface="Inter" pitchFamily="34" charset="-122"/>
                 <a:cs typeface="Inter" pitchFamily="34" charset="-120"/>
               </a:rPr>
-              <a:t>876 calls</a:t>
+              <a:t>876</a:t>
             </a:r>
             <a:endParaRPr lang="en-US" sz="1200" dirty="0"/>
           </a:p>
@@ -3609,7 +3843,7 @@
       </p:sp>
       <p:sp>
         <p:nvSpPr>
-          <p:cNvPr id="50" name="Text 48"/>
+          <p:cNvPr id="56" name="Text 54"/>
           <p:cNvSpPr txBox="1"/>
           <p:nvPr/>
         </p:nvSpPr>
@@ -3648,7 +3882,7 @@
       </p:sp>
       <p:sp>
         <p:nvSpPr>
-          <p:cNvPr id="51" name="Text 49"/>
+          <p:cNvPr id="57" name="Text 55"/>
           <p:cNvSpPr txBox="1"/>
           <p:nvPr/>
         </p:nvSpPr>
@@ -3687,7 +3921,7 @@
       </p:sp>
       <p:sp>
         <p:nvSpPr>
-          <p:cNvPr id="52" name="Text 50"/>
+          <p:cNvPr id="58" name="Text 56"/>
           <p:cNvSpPr txBox="1"/>
           <p:nvPr/>
         </p:nvSpPr>
@@ -3718,7 +3952,7 @@
                 <a:ea typeface="Inter" pitchFamily="34" charset="-122"/>
                 <a:cs typeface="Inter" pitchFamily="34" charset="-120"/>
               </a:rPr>
-              <a:t>6,915 calls</a:t>
+              <a:t>6,915</a:t>
             </a:r>
             <a:endParaRPr lang="en-US" sz="1200" dirty="0"/>
           </a:p>
@@ -3726,7 +3960,7 @@
       </p:sp>
       <p:sp>
         <p:nvSpPr>
-          <p:cNvPr id="53" name="Text 51"/>
+          <p:cNvPr id="59" name="Text 57"/>
           <p:cNvSpPr txBox="1"/>
           <p:nvPr/>
         </p:nvSpPr>
@@ -3765,7 +3999,7 @@
       </p:sp>
       <p:sp>
         <p:nvSpPr>
-          <p:cNvPr id="54" name="Text 52"/>
+          <p:cNvPr id="60" name="Text 58"/>
           <p:cNvSpPr txBox="1"/>
           <p:nvPr/>
         </p:nvSpPr>
@@ -3804,7 +4038,7 @@
       </p:sp>
       <p:sp>
         <p:nvSpPr>
-          <p:cNvPr id="55" name="Text 53"/>
+          <p:cNvPr id="61" name="Text 59"/>
           <p:cNvSpPr txBox="1"/>
           <p:nvPr/>
         </p:nvSpPr>
@@ -3835,7 +4069,7 @@
                 <a:ea typeface="Inter" pitchFamily="34" charset="-122"/>
                 <a:cs typeface="Inter" pitchFamily="34" charset="-120"/>
               </a:rPr>
-              <a:t>1,030 calls</a:t>
+              <a:t>1,030</a:t>
             </a:r>
             <a:endParaRPr lang="en-US" sz="1200" dirty="0"/>
           </a:p>
@@ -3843,7 +4077,7 @@
       </p:sp>
       <p:sp>
         <p:nvSpPr>
-          <p:cNvPr id="56" name="Text 54"/>
+          <p:cNvPr id="62" name="Text 60"/>
           <p:cNvSpPr txBox="1"/>
           <p:nvPr/>
         </p:nvSpPr>
@@ -3882,7 +4116,7 @@
       </p:sp>
       <p:sp>
         <p:nvSpPr>
-          <p:cNvPr id="57" name="Text 55"/>
+          <p:cNvPr id="63" name="Text 61"/>
           <p:cNvSpPr txBox="1"/>
           <p:nvPr/>
         </p:nvSpPr>
@@ -3921,7 +4155,7 @@
       </p:sp>
       <p:sp>
         <p:nvSpPr>
-          <p:cNvPr id="58" name="Text 56"/>
+          <p:cNvPr id="64" name="Text 62"/>
           <p:cNvSpPr txBox="1"/>
           <p:nvPr/>
         </p:nvSpPr>
@@ -3952,7 +4186,7 @@
                 <a:ea typeface="Inter" pitchFamily="34" charset="-122"/>
                 <a:cs typeface="Inter" pitchFamily="34" charset="-120"/>
               </a:rPr>
-              <a:t>696 calls</a:t>
+              <a:t>696</a:t>
             </a:r>
             <a:endParaRPr lang="en-US" sz="1200" dirty="0"/>
           </a:p>
@@ -3960,7 +4194,7 @@
       </p:sp>
       <p:sp>
         <p:nvSpPr>
-          <p:cNvPr id="59" name="Text 57"/>
+          <p:cNvPr id="65" name="Text 63"/>
           <p:cNvSpPr txBox="1"/>
           <p:nvPr/>
         </p:nvSpPr>
@@ -3999,7 +4233,7 @@
       </p:sp>
       <p:sp>
         <p:nvSpPr>
-          <p:cNvPr id="60" name="Text 58"/>
+          <p:cNvPr id="66" name="Text 64"/>
           <p:cNvSpPr txBox="1"/>
           <p:nvPr/>
         </p:nvSpPr>
@@ -4038,7 +4272,7 @@
       </p:sp>
       <p:sp>
         <p:nvSpPr>
-          <p:cNvPr id="61" name="Text 59"/>
+          <p:cNvPr id="67" name="Text 65"/>
           <p:cNvSpPr txBox="1"/>
           <p:nvPr/>
         </p:nvSpPr>
@@ -4069,7 +4303,7 @@
                 <a:ea typeface="Inter" pitchFamily="34" charset="-122"/>
                 <a:cs typeface="Inter" pitchFamily="34" charset="-120"/>
               </a:rPr>
-              <a:t>1,171 calls</a:t>
+              <a:t>1,171</a:t>
             </a:r>
             <a:endParaRPr lang="en-US" sz="1200" dirty="0"/>
           </a:p>
@@ -4077,7 +4311,7 @@
       </p:sp>
       <p:sp>
         <p:nvSpPr>
-          <p:cNvPr id="62" name="Shape 60"/>
+          <p:cNvPr id="68" name="Shape 66"/>
           <p:cNvSpPr/>
           <p:nvPr/>
         </p:nvSpPr>
@@ -4097,7 +4331,7 @@
       </p:sp>
       <p:sp>
         <p:nvSpPr>
-          <p:cNvPr id="63" name="Text 61"/>
+          <p:cNvPr id="69" name="Text 67"/>
           <p:cNvSpPr txBox="1"/>
           <p:nvPr/>
         </p:nvSpPr>
@@ -4136,7 +4370,85 @@
       </p:sp>
       <p:sp>
         <p:nvSpPr>
-          <p:cNvPr id="64" name="Text 62"/>
+          <p:cNvPr id="70" name="Text 68"/>
+          <p:cNvSpPr txBox="1"/>
+          <p:nvPr/>
+        </p:nvSpPr>
+        <p:spPr>
+          <a:xfrm>
+            <a:off x="6108192" y="3941064"/>
+            <a:ext cx="731520" cy="219456"/>
+          </a:xfrm>
+          <a:prstGeom prst="rect">
+            <a:avLst/>
+          </a:prstGeom>
+          <a:noFill/>
+          <a:ln/>
+        </p:spPr>
+        <p:txBody>
+          <a:bodyPr wrap="square" lIns="0" tIns="0" rIns="0" bIns="0" rtlCol="0" anchor="ctr"/>
+          <a:lstStyle/>
+          <a:p>
+            <a:pPr algn="r" indent="0" marL="0">
+              <a:buNone/>
+            </a:pPr>
+            <a:r>
+              <a:rPr lang="en-US" sz="1400" b="1" dirty="0">
+                <a:solidFill>
+                  <a:srgbClr val="595959"/>
+                </a:solidFill>
+                <a:latin typeface="Inter" pitchFamily="34" charset="0"/>
+                <a:ea typeface="Inter" pitchFamily="34" charset="-122"/>
+                <a:cs typeface="Inter" pitchFamily="34" charset="-120"/>
+              </a:rPr>
+              <a:t>Rate</a:t>
+            </a:r>
+            <a:endParaRPr lang="en-US" sz="1400" dirty="0"/>
+          </a:p>
+        </p:txBody>
+      </p:sp>
+      <p:sp>
+        <p:nvSpPr>
+          <p:cNvPr id="71" name="Text 69"/>
+          <p:cNvSpPr txBox="1"/>
+          <p:nvPr/>
+        </p:nvSpPr>
+        <p:spPr>
+          <a:xfrm>
+            <a:off x="6858000" y="3941064"/>
+            <a:ext cx="914400" cy="219456"/>
+          </a:xfrm>
+          <a:prstGeom prst="rect">
+            <a:avLst/>
+          </a:prstGeom>
+          <a:noFill/>
+          <a:ln/>
+        </p:spPr>
+        <p:txBody>
+          <a:bodyPr wrap="square" lIns="0" tIns="0" rIns="0" bIns="0" rtlCol="0" anchor="ctr"/>
+          <a:lstStyle/>
+          <a:p>
+            <a:pPr algn="r" indent="0" marL="0">
+              <a:buNone/>
+            </a:pPr>
+            <a:r>
+              <a:rPr lang="en-US" sz="1400" b="1" dirty="0">
+                <a:solidFill>
+                  <a:srgbClr val="595959"/>
+                </a:solidFill>
+                <a:latin typeface="Inter" pitchFamily="34" charset="0"/>
+                <a:ea typeface="Inter" pitchFamily="34" charset="-122"/>
+                <a:cs typeface="Inter" pitchFamily="34" charset="-120"/>
+              </a:rPr>
+              <a:t>Calls</a:t>
+            </a:r>
+            <a:endParaRPr lang="en-US" sz="1400" dirty="0"/>
+          </a:p>
+        </p:txBody>
+      </p:sp>
+      <p:sp>
+        <p:nvSpPr>
+          <p:cNvPr id="72" name="Text 70"/>
           <p:cNvSpPr txBox="1"/>
           <p:nvPr/>
         </p:nvSpPr>
@@ -4175,7 +4487,7 @@
       </p:sp>
       <p:sp>
         <p:nvSpPr>
-          <p:cNvPr id="65" name="Text 63"/>
+          <p:cNvPr id="73" name="Text 71"/>
           <p:cNvSpPr txBox="1"/>
           <p:nvPr/>
         </p:nvSpPr>
@@ -4214,7 +4526,7 @@
       </p:sp>
       <p:sp>
         <p:nvSpPr>
-          <p:cNvPr id="66" name="Text 64"/>
+          <p:cNvPr id="74" name="Text 72"/>
           <p:cNvSpPr txBox="1"/>
           <p:nvPr/>
         </p:nvSpPr>
@@ -4245,7 +4557,7 @@
                 <a:ea typeface="Inter" pitchFamily="34" charset="-122"/>
                 <a:cs typeface="Inter" pitchFamily="34" charset="-120"/>
               </a:rPr>
-              <a:t>1,075 calls</a:t>
+              <a:t>1,075</a:t>
             </a:r>
             <a:endParaRPr lang="en-US" sz="1200" dirty="0"/>
           </a:p>
@@ -4253,7 +4565,7 @@
       </p:sp>
       <p:sp>
         <p:nvSpPr>
-          <p:cNvPr id="67" name="Text 65"/>
+          <p:cNvPr id="75" name="Text 73"/>
           <p:cNvSpPr txBox="1"/>
           <p:nvPr/>
         </p:nvSpPr>
@@ -4292,7 +4604,7 @@
       </p:sp>
       <p:sp>
         <p:nvSpPr>
-          <p:cNvPr id="68" name="Text 66"/>
+          <p:cNvPr id="76" name="Text 74"/>
           <p:cNvSpPr txBox="1"/>
           <p:nvPr/>
         </p:nvSpPr>
@@ -4331,7 +4643,7 @@
       </p:sp>
       <p:sp>
         <p:nvSpPr>
-          <p:cNvPr id="69" name="Text 67"/>
+          <p:cNvPr id="77" name="Text 75"/>
           <p:cNvSpPr txBox="1"/>
           <p:nvPr/>
         </p:nvSpPr>
@@ -4362,7 +4674,7 @@
                 <a:ea typeface="Inter" pitchFamily="34" charset="-122"/>
                 <a:cs typeface="Inter" pitchFamily="34" charset="-120"/>
               </a:rPr>
-              <a:t>1,809 calls</a:t>
+              <a:t>1,809</a:t>
             </a:r>
             <a:endParaRPr lang="en-US" sz="1200" dirty="0"/>
           </a:p>
@@ -4370,7 +4682,7 @@
       </p:sp>
       <p:sp>
         <p:nvSpPr>
-          <p:cNvPr id="70" name="Text 68"/>
+          <p:cNvPr id="78" name="Text 76"/>
           <p:cNvSpPr txBox="1"/>
           <p:nvPr/>
         </p:nvSpPr>
@@ -4409,7 +4721,7 @@
       </p:sp>
       <p:sp>
         <p:nvSpPr>
-          <p:cNvPr id="71" name="Text 69"/>
+          <p:cNvPr id="79" name="Text 77"/>
           <p:cNvSpPr txBox="1"/>
           <p:nvPr/>
         </p:nvSpPr>
@@ -4448,7 +4760,7 @@
       </p:sp>
       <p:sp>
         <p:nvSpPr>
-          <p:cNvPr id="72" name="Text 70"/>
+          <p:cNvPr id="80" name="Text 78"/>
           <p:cNvSpPr txBox="1"/>
           <p:nvPr/>
         </p:nvSpPr>
@@ -4479,7 +4791,7 @@
                 <a:ea typeface="Inter" pitchFamily="34" charset="-122"/>
                 <a:cs typeface="Inter" pitchFamily="34" charset="-120"/>
               </a:rPr>
-              <a:t>5,450 calls</a:t>
+              <a:t>5,450</a:t>
             </a:r>
             <a:endParaRPr lang="en-US" sz="1200" dirty="0"/>
           </a:p>
@@ -4487,7 +4799,7 @@
       </p:sp>
       <p:sp>
         <p:nvSpPr>
-          <p:cNvPr id="73" name="Text 71"/>
+          <p:cNvPr id="81" name="Text 79"/>
           <p:cNvSpPr txBox="1"/>
           <p:nvPr/>
         </p:nvSpPr>
@@ -4526,7 +4838,7 @@
       </p:sp>
       <p:sp>
         <p:nvSpPr>
-          <p:cNvPr id="74" name="Text 72"/>
+          <p:cNvPr id="82" name="Text 80"/>
           <p:cNvSpPr txBox="1"/>
           <p:nvPr/>
         </p:nvSpPr>
@@ -4565,7 +4877,7 @@
       </p:sp>
       <p:sp>
         <p:nvSpPr>
-          <p:cNvPr id="75" name="Text 73"/>
+          <p:cNvPr id="83" name="Text 81"/>
           <p:cNvSpPr txBox="1"/>
           <p:nvPr/>
         </p:nvSpPr>
@@ -4596,7 +4908,7 @@
                 <a:ea typeface="Inter" pitchFamily="34" charset="-122"/>
                 <a:cs typeface="Inter" pitchFamily="34" charset="-120"/>
               </a:rPr>
-              <a:t>2,247 calls</a:t>
+              <a:t>2,247</a:t>
             </a:r>
             <a:endParaRPr lang="en-US" sz="1200" dirty="0"/>
           </a:p>
@@ -4604,7 +4916,7 @@
       </p:sp>
       <p:sp>
         <p:nvSpPr>
-          <p:cNvPr id="76" name="Text 74"/>
+          <p:cNvPr id="84" name="Text 82"/>
           <p:cNvSpPr txBox="1"/>
           <p:nvPr/>
         </p:nvSpPr>
@@ -4643,7 +4955,7 @@
       </p:sp>
       <p:sp>
         <p:nvSpPr>
-          <p:cNvPr id="77" name="Text 75"/>
+          <p:cNvPr id="85" name="Text 83"/>
           <p:cNvSpPr txBox="1"/>
           <p:nvPr/>
         </p:nvSpPr>
@@ -4682,7 +4994,7 @@
       </p:sp>
       <p:sp>
         <p:nvSpPr>
-          <p:cNvPr id="78" name="Text 76"/>
+          <p:cNvPr id="86" name="Text 84"/>
           <p:cNvSpPr txBox="1"/>
           <p:nvPr/>
         </p:nvSpPr>
@@ -4713,7 +5025,7 @@
                 <a:ea typeface="Inter" pitchFamily="34" charset="-122"/>
                 <a:cs typeface="Inter" pitchFamily="34" charset="-120"/>
               </a:rPr>
-              <a:t>896 calls</a:t>
+              <a:t>896</a:t>
             </a:r>
             <a:endParaRPr lang="en-US" sz="1200" dirty="0"/>
           </a:p>
@@ -4721,7 +5033,7 @@
       </p:sp>
       <p:sp>
         <p:nvSpPr>
-          <p:cNvPr id="79" name="Shape 77"/>
+          <p:cNvPr id="87" name="Shape 85"/>
           <p:cNvSpPr/>
           <p:nvPr/>
         </p:nvSpPr>
@@ -4741,7 +5053,7 @@
       </p:sp>
       <p:sp>
         <p:nvSpPr>
-          <p:cNvPr id="80" name="Text 78"/>
+          <p:cNvPr id="88" name="Text 86"/>
           <p:cNvSpPr txBox="1"/>
           <p:nvPr/>
         </p:nvSpPr>
@@ -4780,7 +5092,7 @@
       </p:sp>
       <p:sp>
         <p:nvSpPr>
-          <p:cNvPr id="81" name="Text 79"/>
+          <p:cNvPr id="89" name="Text 87"/>
           <p:cNvSpPr txBox="1"/>
           <p:nvPr/>
         </p:nvSpPr>
@@ -4819,7 +5131,7 @@
       </p:sp>
       <p:sp>
         <p:nvSpPr>
-          <p:cNvPr id="82" name="Shape 80"/>
+          <p:cNvPr id="90" name="Shape 88"/>
           <p:cNvSpPr/>
           <p:nvPr/>
         </p:nvSpPr>
@@ -4839,7 +5151,7 @@
       </p:sp>
       <p:sp>
         <p:nvSpPr>
-          <p:cNvPr id="83" name="Text 81"/>
+          <p:cNvPr id="91" name="Text 89"/>
           <p:cNvSpPr txBox="1"/>
           <p:nvPr/>
         </p:nvSpPr>
@@ -4878,7 +5190,85 @@
       </p:sp>
       <p:sp>
         <p:nvSpPr>
-          <p:cNvPr id="84" name="Text 82"/>
+          <p:cNvPr id="92" name="Text 90"/>
+          <p:cNvSpPr txBox="1"/>
+          <p:nvPr/>
+        </p:nvSpPr>
+        <p:spPr>
+          <a:xfrm>
+            <a:off x="9902952" y="1938528"/>
+            <a:ext cx="731520" cy="219456"/>
+          </a:xfrm>
+          <a:prstGeom prst="rect">
+            <a:avLst/>
+          </a:prstGeom>
+          <a:noFill/>
+          <a:ln/>
+        </p:spPr>
+        <p:txBody>
+          <a:bodyPr wrap="square" lIns="0" tIns="0" rIns="0" bIns="0" rtlCol="0" anchor="ctr"/>
+          <a:lstStyle/>
+          <a:p>
+            <a:pPr algn="r" indent="0" marL="0">
+              <a:buNone/>
+            </a:pPr>
+            <a:r>
+              <a:rPr lang="en-US" sz="1400" b="1" dirty="0">
+                <a:solidFill>
+                  <a:srgbClr val="595959"/>
+                </a:solidFill>
+                <a:latin typeface="Inter" pitchFamily="34" charset="0"/>
+                <a:ea typeface="Inter" pitchFamily="34" charset="-122"/>
+                <a:cs typeface="Inter" pitchFamily="34" charset="-120"/>
+              </a:rPr>
+              <a:t>Rate</a:t>
+            </a:r>
+            <a:endParaRPr lang="en-US" sz="1400" dirty="0"/>
+          </a:p>
+        </p:txBody>
+      </p:sp>
+      <p:sp>
+        <p:nvSpPr>
+          <p:cNvPr id="93" name="Text 91"/>
+          <p:cNvSpPr txBox="1"/>
+          <p:nvPr/>
+        </p:nvSpPr>
+        <p:spPr>
+          <a:xfrm>
+            <a:off x="10652760" y="1938528"/>
+            <a:ext cx="914400" cy="219456"/>
+          </a:xfrm>
+          <a:prstGeom prst="rect">
+            <a:avLst/>
+          </a:prstGeom>
+          <a:noFill/>
+          <a:ln/>
+        </p:spPr>
+        <p:txBody>
+          <a:bodyPr wrap="square" lIns="0" tIns="0" rIns="0" bIns="0" rtlCol="0" anchor="ctr"/>
+          <a:lstStyle/>
+          <a:p>
+            <a:pPr algn="r" indent="0" marL="0">
+              <a:buNone/>
+            </a:pPr>
+            <a:r>
+              <a:rPr lang="en-US" sz="1400" b="1" dirty="0">
+                <a:solidFill>
+                  <a:srgbClr val="595959"/>
+                </a:solidFill>
+                <a:latin typeface="Inter" pitchFamily="34" charset="0"/>
+                <a:ea typeface="Inter" pitchFamily="34" charset="-122"/>
+                <a:cs typeface="Inter" pitchFamily="34" charset="-120"/>
+              </a:rPr>
+              <a:t>Open</a:t>
+            </a:r>
+            <a:endParaRPr lang="en-US" sz="1400" dirty="0"/>
+          </a:p>
+        </p:txBody>
+      </p:sp>
+      <p:sp>
+        <p:nvSpPr>
+          <p:cNvPr id="94" name="Text 92"/>
           <p:cNvSpPr txBox="1"/>
           <p:nvPr/>
         </p:nvSpPr>
@@ -4917,7 +5307,7 @@
       </p:sp>
       <p:sp>
         <p:nvSpPr>
-          <p:cNvPr id="85" name="Text 83"/>
+          <p:cNvPr id="95" name="Text 93"/>
           <p:cNvSpPr txBox="1"/>
           <p:nvPr/>
         </p:nvSpPr>
@@ -4956,7 +5346,7 @@
       </p:sp>
       <p:sp>
         <p:nvSpPr>
-          <p:cNvPr id="86" name="Text 84"/>
+          <p:cNvPr id="96" name="Text 94"/>
           <p:cNvSpPr txBox="1"/>
           <p:nvPr/>
         </p:nvSpPr>
@@ -4987,7 +5377,7 @@
                 <a:ea typeface="Inter" pitchFamily="34" charset="-122"/>
                 <a:cs typeface="Inter" pitchFamily="34" charset="-120"/>
               </a:rPr>
-              <a:t>0 open</a:t>
+              <a:t>0</a:t>
             </a:r>
             <a:endParaRPr lang="en-US" sz="1200" dirty="0"/>
           </a:p>
@@ -4995,7 +5385,7 @@
       </p:sp>
       <p:sp>
         <p:nvSpPr>
-          <p:cNvPr id="87" name="Text 85"/>
+          <p:cNvPr id="97" name="Text 95"/>
           <p:cNvSpPr txBox="1"/>
           <p:nvPr/>
         </p:nvSpPr>
@@ -5034,7 +5424,7 @@
       </p:sp>
       <p:sp>
         <p:nvSpPr>
-          <p:cNvPr id="88" name="Text 86"/>
+          <p:cNvPr id="98" name="Text 96"/>
           <p:cNvSpPr txBox="1"/>
           <p:nvPr/>
         </p:nvSpPr>
@@ -5073,7 +5463,7 @@
       </p:sp>
       <p:sp>
         <p:nvSpPr>
-          <p:cNvPr id="89" name="Text 87"/>
+          <p:cNvPr id="99" name="Text 97"/>
           <p:cNvSpPr txBox="1"/>
           <p:nvPr/>
         </p:nvSpPr>
@@ -5104,7 +5494,7 @@
                 <a:ea typeface="Inter" pitchFamily="34" charset="-122"/>
                 <a:cs typeface="Inter" pitchFamily="34" charset="-120"/>
               </a:rPr>
-              <a:t>0 open</a:t>
+              <a:t>0</a:t>
             </a:r>
             <a:endParaRPr lang="en-US" sz="1200" dirty="0"/>
           </a:p>
@@ -5112,7 +5502,7 @@
       </p:sp>
       <p:sp>
         <p:nvSpPr>
-          <p:cNvPr id="90" name="Text 88"/>
+          <p:cNvPr id="100" name="Text 98"/>
           <p:cNvSpPr txBox="1"/>
           <p:nvPr/>
         </p:nvSpPr>
@@ -5151,7 +5541,7 @@
       </p:sp>
       <p:sp>
         <p:nvSpPr>
-          <p:cNvPr id="91" name="Text 89"/>
+          <p:cNvPr id="101" name="Text 99"/>
           <p:cNvSpPr txBox="1"/>
           <p:nvPr/>
         </p:nvSpPr>
@@ -5190,7 +5580,7 @@
       </p:sp>
       <p:sp>
         <p:nvSpPr>
-          <p:cNvPr id="92" name="Text 90"/>
+          <p:cNvPr id="102" name="Text 100"/>
           <p:cNvSpPr txBox="1"/>
           <p:nvPr/>
         </p:nvSpPr>
@@ -5221,7 +5611,7 @@
                 <a:ea typeface="Inter" pitchFamily="34" charset="-122"/>
                 <a:cs typeface="Inter" pitchFamily="34" charset="-120"/>
               </a:rPr>
-              <a:t>0 open</a:t>
+              <a:t>0</a:t>
             </a:r>
             <a:endParaRPr lang="en-US" sz="1200" dirty="0"/>
           </a:p>
@@ -5229,7 +5619,7 @@
       </p:sp>
       <p:sp>
         <p:nvSpPr>
-          <p:cNvPr id="93" name="Text 91"/>
+          <p:cNvPr id="103" name="Text 101"/>
           <p:cNvSpPr txBox="1"/>
           <p:nvPr/>
         </p:nvSpPr>
@@ -5268,7 +5658,7 @@
       </p:sp>
       <p:sp>
         <p:nvSpPr>
-          <p:cNvPr id="94" name="Text 92"/>
+          <p:cNvPr id="104" name="Text 102"/>
           <p:cNvSpPr txBox="1"/>
           <p:nvPr/>
         </p:nvSpPr>
@@ -5307,7 +5697,7 @@
       </p:sp>
       <p:sp>
         <p:nvSpPr>
-          <p:cNvPr id="95" name="Text 93"/>
+          <p:cNvPr id="105" name="Text 103"/>
           <p:cNvSpPr txBox="1"/>
           <p:nvPr/>
         </p:nvSpPr>
@@ -5338,7 +5728,7 @@
                 <a:ea typeface="Inter" pitchFamily="34" charset="-122"/>
                 <a:cs typeface="Inter" pitchFamily="34" charset="-120"/>
               </a:rPr>
-              <a:t>0 open</a:t>
+              <a:t>0</a:t>
             </a:r>
             <a:endParaRPr lang="en-US" sz="1200" dirty="0"/>
           </a:p>
@@ -5346,7 +5736,7 @@
       </p:sp>
       <p:sp>
         <p:nvSpPr>
-          <p:cNvPr id="96" name="Text 94"/>
+          <p:cNvPr id="106" name="Text 104"/>
           <p:cNvSpPr txBox="1"/>
           <p:nvPr/>
         </p:nvSpPr>
@@ -5385,7 +5775,7 @@
       </p:sp>
       <p:sp>
         <p:nvSpPr>
-          <p:cNvPr id="97" name="Text 95"/>
+          <p:cNvPr id="107" name="Text 105"/>
           <p:cNvSpPr txBox="1"/>
           <p:nvPr/>
         </p:nvSpPr>
@@ -5424,7 +5814,7 @@
       </p:sp>
       <p:sp>
         <p:nvSpPr>
-          <p:cNvPr id="98" name="Text 96"/>
+          <p:cNvPr id="108" name="Text 106"/>
           <p:cNvSpPr txBox="1"/>
           <p:nvPr/>
         </p:nvSpPr>
@@ -5455,7 +5845,7 @@
                 <a:ea typeface="Inter" pitchFamily="34" charset="-122"/>
                 <a:cs typeface="Inter" pitchFamily="34" charset="-120"/>
               </a:rPr>
-              <a:t>0 open</a:t>
+              <a:t>0</a:t>
             </a:r>
             <a:endParaRPr lang="en-US" sz="1200" dirty="0"/>
           </a:p>
@@ -5463,7 +5853,7 @@
       </p:sp>
       <p:sp>
         <p:nvSpPr>
-          <p:cNvPr id="99" name="Shape 97"/>
+          <p:cNvPr id="109" name="Shape 107"/>
           <p:cNvSpPr/>
           <p:nvPr/>
         </p:nvSpPr>
@@ -5483,7 +5873,7 @@
       </p:sp>
       <p:sp>
         <p:nvSpPr>
-          <p:cNvPr id="100" name="Text 98"/>
+          <p:cNvPr id="110" name="Text 108"/>
           <p:cNvSpPr txBox="1"/>
           <p:nvPr/>
         </p:nvSpPr>
@@ -5522,7 +5912,85 @@
       </p:sp>
       <p:sp>
         <p:nvSpPr>
-          <p:cNvPr id="101" name="Text 99"/>
+          <p:cNvPr id="111" name="Text 109"/>
+          <p:cNvSpPr txBox="1"/>
+          <p:nvPr/>
+        </p:nvSpPr>
+        <p:spPr>
+          <a:xfrm>
+            <a:off x="9902952" y="3941064"/>
+            <a:ext cx="731520" cy="219456"/>
+          </a:xfrm>
+          <a:prstGeom prst="rect">
+            <a:avLst/>
+          </a:prstGeom>
+          <a:noFill/>
+          <a:ln/>
+        </p:spPr>
+        <p:txBody>
+          <a:bodyPr wrap="square" lIns="0" tIns="0" rIns="0" bIns="0" rtlCol="0" anchor="ctr"/>
+          <a:lstStyle/>
+          <a:p>
+            <a:pPr algn="r" indent="0" marL="0">
+              <a:buNone/>
+            </a:pPr>
+            <a:r>
+              <a:rPr lang="en-US" sz="1400" b="1" dirty="0">
+                <a:solidFill>
+                  <a:srgbClr val="595959"/>
+                </a:solidFill>
+                <a:latin typeface="Inter" pitchFamily="34" charset="0"/>
+                <a:ea typeface="Inter" pitchFamily="34" charset="-122"/>
+                <a:cs typeface="Inter" pitchFamily="34" charset="-120"/>
+              </a:rPr>
+              <a:t>Rate</a:t>
+            </a:r>
+            <a:endParaRPr lang="en-US" sz="1400" dirty="0"/>
+          </a:p>
+        </p:txBody>
+      </p:sp>
+      <p:sp>
+        <p:nvSpPr>
+          <p:cNvPr id="112" name="Text 110"/>
+          <p:cNvSpPr txBox="1"/>
+          <p:nvPr/>
+        </p:nvSpPr>
+        <p:spPr>
+          <a:xfrm>
+            <a:off x="10652760" y="3941064"/>
+            <a:ext cx="914400" cy="219456"/>
+          </a:xfrm>
+          <a:prstGeom prst="rect">
+            <a:avLst/>
+          </a:prstGeom>
+          <a:noFill/>
+          <a:ln/>
+        </p:spPr>
+        <p:txBody>
+          <a:bodyPr wrap="square" lIns="0" tIns="0" rIns="0" bIns="0" rtlCol="0" anchor="ctr"/>
+          <a:lstStyle/>
+          <a:p>
+            <a:pPr algn="r" indent="0" marL="0">
+              <a:buNone/>
+            </a:pPr>
+            <a:r>
+              <a:rPr lang="en-US" sz="1400" b="1" dirty="0">
+                <a:solidFill>
+                  <a:srgbClr val="595959"/>
+                </a:solidFill>
+                <a:latin typeface="Inter" pitchFamily="34" charset="0"/>
+                <a:ea typeface="Inter" pitchFamily="34" charset="-122"/>
+                <a:cs typeface="Inter" pitchFamily="34" charset="-120"/>
+              </a:rPr>
+              <a:t>Open</a:t>
+            </a:r>
+            <a:endParaRPr lang="en-US" sz="1400" dirty="0"/>
+          </a:p>
+        </p:txBody>
+      </p:sp>
+      <p:sp>
+        <p:nvSpPr>
+          <p:cNvPr id="113" name="Text 111"/>
           <p:cNvSpPr txBox="1"/>
           <p:nvPr/>
         </p:nvSpPr>
@@ -5561,7 +6029,7 @@
       </p:sp>
       <p:sp>
         <p:nvSpPr>
-          <p:cNvPr id="102" name="Text 100"/>
+          <p:cNvPr id="114" name="Text 112"/>
           <p:cNvSpPr txBox="1"/>
           <p:nvPr/>
         </p:nvSpPr>
@@ -5600,7 +6068,7 @@
       </p:sp>
       <p:sp>
         <p:nvSpPr>
-          <p:cNvPr id="103" name="Text 101"/>
+          <p:cNvPr id="115" name="Text 113"/>
           <p:cNvSpPr txBox="1"/>
           <p:nvPr/>
         </p:nvSpPr>
@@ -5631,7 +6099,7 @@
                 <a:ea typeface="Inter" pitchFamily="34" charset="-122"/>
                 <a:cs typeface="Inter" pitchFamily="34" charset="-120"/>
               </a:rPr>
-              <a:t>158 open</a:t>
+              <a:t>158</a:t>
             </a:r>
             <a:endParaRPr lang="en-US" sz="1200" dirty="0"/>
           </a:p>
@@ -5639,7 +6107,7 @@
       </p:sp>
       <p:sp>
         <p:nvSpPr>
-          <p:cNvPr id="104" name="Text 102"/>
+          <p:cNvPr id="116" name="Text 114"/>
           <p:cNvSpPr txBox="1"/>
           <p:nvPr/>
         </p:nvSpPr>
@@ -5678,7 +6146,7 @@
       </p:sp>
       <p:sp>
         <p:nvSpPr>
-          <p:cNvPr id="105" name="Text 103"/>
+          <p:cNvPr id="117" name="Text 115"/>
           <p:cNvSpPr txBox="1"/>
           <p:nvPr/>
         </p:nvSpPr>
@@ -5717,7 +6185,7 @@
       </p:sp>
       <p:sp>
         <p:nvSpPr>
-          <p:cNvPr id="106" name="Text 104"/>
+          <p:cNvPr id="118" name="Text 116"/>
           <p:cNvSpPr txBox="1"/>
           <p:nvPr/>
         </p:nvSpPr>
@@ -5748,7 +6216,7 @@
                 <a:ea typeface="Inter" pitchFamily="34" charset="-122"/>
                 <a:cs typeface="Inter" pitchFamily="34" charset="-120"/>
               </a:rPr>
-              <a:t>114 open</a:t>
+              <a:t>114</a:t>
             </a:r>
             <a:endParaRPr lang="en-US" sz="1200" dirty="0"/>
           </a:p>
@@ -5756,7 +6224,7 @@
       </p:sp>
       <p:sp>
         <p:nvSpPr>
-          <p:cNvPr id="107" name="Text 105"/>
+          <p:cNvPr id="119" name="Text 117"/>
           <p:cNvSpPr txBox="1"/>
           <p:nvPr/>
         </p:nvSpPr>
@@ -5795,7 +6263,7 @@
       </p:sp>
       <p:sp>
         <p:nvSpPr>
-          <p:cNvPr id="108" name="Text 106"/>
+          <p:cNvPr id="120" name="Text 118"/>
           <p:cNvSpPr txBox="1"/>
           <p:nvPr/>
         </p:nvSpPr>
@@ -5834,7 +6302,7 @@
       </p:sp>
       <p:sp>
         <p:nvSpPr>
-          <p:cNvPr id="109" name="Text 107"/>
+          <p:cNvPr id="121" name="Text 119"/>
           <p:cNvSpPr txBox="1"/>
           <p:nvPr/>
         </p:nvSpPr>
@@ -5865,7 +6333,7 @@
                 <a:ea typeface="Inter" pitchFamily="34" charset="-122"/>
                 <a:cs typeface="Inter" pitchFamily="34" charset="-120"/>
               </a:rPr>
-              <a:t>57 open</a:t>
+              <a:t>57</a:t>
             </a:r>
             <a:endParaRPr lang="en-US" sz="1200" dirty="0"/>
           </a:p>
@@ -5873,7 +6341,7 @@
       </p:sp>
       <p:sp>
         <p:nvSpPr>
-          <p:cNvPr id="110" name="Text 108"/>
+          <p:cNvPr id="122" name="Text 120"/>
           <p:cNvSpPr txBox="1"/>
           <p:nvPr/>
         </p:nvSpPr>
@@ -5912,7 +6380,7 @@
       </p:sp>
       <p:sp>
         <p:nvSpPr>
-          <p:cNvPr id="111" name="Text 109"/>
+          <p:cNvPr id="123" name="Text 121"/>
           <p:cNvSpPr txBox="1"/>
           <p:nvPr/>
         </p:nvSpPr>
@@ -5951,7 +6419,7 @@
       </p:sp>
       <p:sp>
         <p:nvSpPr>
-          <p:cNvPr id="112" name="Text 110"/>
+          <p:cNvPr id="124" name="Text 122"/>
           <p:cNvSpPr txBox="1"/>
           <p:nvPr/>
         </p:nvSpPr>
@@ -5982,7 +6450,7 @@
                 <a:ea typeface="Inter" pitchFamily="34" charset="-122"/>
                 <a:cs typeface="Inter" pitchFamily="34" charset="-120"/>
               </a:rPr>
-              <a:t>30 open</a:t>
+              <a:t>30</a:t>
             </a:r>
             <a:endParaRPr lang="en-US" sz="1200" dirty="0"/>
           </a:p>
@@ -5990,7 +6458,7 @@
       </p:sp>
       <p:sp>
         <p:nvSpPr>
-          <p:cNvPr id="113" name="Text 111"/>
+          <p:cNvPr id="125" name="Text 123"/>
           <p:cNvSpPr txBox="1"/>
           <p:nvPr/>
         </p:nvSpPr>
@@ -6029,7 +6497,7 @@
       </p:sp>
       <p:sp>
         <p:nvSpPr>
-          <p:cNvPr id="114" name="Text 112"/>
+          <p:cNvPr id="126" name="Text 124"/>
           <p:cNvSpPr txBox="1"/>
           <p:nvPr/>
         </p:nvSpPr>
@@ -6068,7 +6536,7 @@
       </p:sp>
       <p:sp>
         <p:nvSpPr>
-          <p:cNvPr id="115" name="Text 113"/>
+          <p:cNvPr id="127" name="Text 125"/>
           <p:cNvSpPr txBox="1"/>
           <p:nvPr/>
         </p:nvSpPr>
@@ -6099,7 +6567,7 @@
                 <a:ea typeface="Inter" pitchFamily="34" charset="-122"/>
                 <a:cs typeface="Inter" pitchFamily="34" charset="-120"/>
               </a:rPr>
-              <a:t>3 open</a:t>
+              <a:t>3</a:t>
             </a:r>
             <a:endParaRPr lang="en-US" sz="1200" dirty="0"/>
           </a:p>
@@ -6107,7 +6575,7 @@
       </p:sp>
       <p:sp>
         <p:nvSpPr>
-          <p:cNvPr id="116" name="Shape 114"/>
+          <p:cNvPr id="128" name="Shape 126"/>
           <p:cNvSpPr/>
           <p:nvPr/>
         </p:nvSpPr>
@@ -6127,7 +6595,7 @@
       </p:sp>
       <p:sp>
         <p:nvSpPr>
-          <p:cNvPr id="117" name="Text 115"/>
+          <p:cNvPr id="129" name="Text 127"/>
           <p:cNvSpPr txBox="1"/>
           <p:nvPr/>
         </p:nvSpPr>

</xml_diff>

<commit_message>
Phone preview: Voice AI / Flai titles and description
Co-Authored-By: Claude Opus 5.5 <noreply@anthropic.com>
Claude-Session: https://claude.ai/code/session_01Xa4nFVxuQGXmHARGph9WhS
</commit_message>
<xml_diff>
--- a/day2-deck/decks/Phone Handling - Preview.pptx
+++ b/day2-deck/decks/Phone Handling - Preview.pptx
@@ -1018,7 +1018,7 @@
                 <a:ea typeface="Inter" pitchFamily="34" charset="-122"/>
                 <a:cs typeface="Inter" pitchFamily="34" charset="-120"/>
               </a:rPr>
-              <a:t>THE PHONE</a:t>
+              <a:t>VOICE AI · FLAI</a:t>
             </a:r>
             <a:endParaRPr lang="en-US" sz="1400" dirty="0"/>
           </a:p>
@@ -1057,7 +1057,7 @@
                 <a:ea typeface="Inter" pitchFamily="34" charset="-122"/>
                 <a:cs typeface="Inter" pitchFamily="34" charset="-120"/>
               </a:rPr>
-              <a:t>Every Call Is a Customer</a:t>
+              <a:t>Voice AI: Every Call Is a Customer</a:t>
             </a:r>
             <a:endParaRPr lang="en-US" sz="2800" dirty="0"/>
           </a:p>
@@ -1752,7 +1752,7 @@
                 <a:ea typeface="Inter" pitchFamily="34" charset="-122"/>
                 <a:cs typeface="Inter" pitchFamily="34" charset="-120"/>
               </a:rPr>
-              <a:t>The AI books and routes the call; the store still has to answer the transfer and close every callback in the Flai dashboard.</a:t>
+              <a:t>Service calls answered by Flai, our voice AI, Jul 26 – Oct 26, 2026. The AI books and routes the call; the store still has to answer the transfer and close every callback in the Flai dashboard.</a:t>
             </a:r>
             <a:endParaRPr lang="en-US" sz="1700" dirty="0"/>
           </a:p>
@@ -1902,7 +1902,7 @@
                 <a:ea typeface="Inter" pitchFamily="34" charset="-122"/>
                 <a:cs typeface="Inter" pitchFamily="34" charset="-120"/>
               </a:rPr>
-              <a:t>THE PHONE</a:t>
+              <a:t>VOICE AI · FLAI</a:t>
             </a:r>
             <a:endParaRPr lang="en-US" sz="1400" dirty="0"/>
           </a:p>
@@ -1941,7 +1941,7 @@
                 <a:ea typeface="Inter" pitchFamily="34" charset="-122"/>
                 <a:cs typeface="Inter" pitchFamily="34" charset="-120"/>
               </a:rPr>
-              <a:t>Who Handles the Phone Well</a:t>
+              <a:t>Store Voice AI Metrics</a:t>
             </a:r>
             <a:endParaRPr lang="en-US" sz="2800" dirty="0"/>
           </a:p>

</xml_diff>

<commit_message>
Phone preview: last 90 days on both slides
Co-Authored-By: Claude Opus 5.5 <noreply@anthropic.com>
Claude-Session: https://claude.ai/code/session_01Xa4nFVxuQGXmHARGph9WhS
</commit_message>
<xml_diff>
--- a/day2-deck/decks/Phone Handling - Preview.pptx
+++ b/day2-deck/decks/Phone Handling - Preview.pptx
@@ -1018,7 +1018,7 @@
                 <a:ea typeface="Inter" pitchFamily="34" charset="-122"/>
                 <a:cs typeface="Inter" pitchFamily="34" charset="-120"/>
               </a:rPr>
-              <a:t>VOICE AI · FLAI</a:t>
+              <a:t>VOICE AI · FLAI · LAST 90 DAYS</a:t>
             </a:r>
             <a:endParaRPr lang="en-US" sz="1400" dirty="0"/>
           </a:p>
@@ -1752,7 +1752,7 @@
                 <a:ea typeface="Inter" pitchFamily="34" charset="-122"/>
                 <a:cs typeface="Inter" pitchFamily="34" charset="-120"/>
               </a:rPr>
-              <a:t>Service calls answered by Flai, our voice AI, Jul 26 – Oct 26, 2026. The AI books and routes the call; the store still has to answer the transfer and close every callback in the Flai dashboard.</a:t>
+              <a:t>Service calls answered by Flai, our voice AI, over the last 90 days (Jul 26 – Oct 26, 2026). The AI books and routes the call; the store still has to answer the transfer and close every callback in the Flai dashboard.</a:t>
             </a:r>
             <a:endParaRPr lang="en-US" sz="1700" dirty="0"/>
           </a:p>
@@ -1902,7 +1902,7 @@
                 <a:ea typeface="Inter" pitchFamily="34" charset="-122"/>
                 <a:cs typeface="Inter" pitchFamily="34" charset="-120"/>
               </a:rPr>
-              <a:t>VOICE AI · FLAI</a:t>
+              <a:t>VOICE AI · FLAI · LAST 90 DAYS</a:t>
             </a:r>
             <a:endParaRPr lang="en-US" sz="1400" dirty="0"/>
           </a:p>

</xml_diff>

<commit_message>
Phone preview: stores at 100% callback resolution; green bar for repeat top stores
Co-Authored-By: Claude Opus 5.5 <noreply@anthropic.com>
Claude-Session: https://claude.ai/code/session_01Xa4nFVxuQGXmHARGph9WhS
</commit_message>
<xml_diff>
--- a/day2-deck/decks/Phone Handling - Preview.pptx
+++ b/day2-deck/decks/Phone Handling - Preview.pptx
@@ -591,7 +591,7 @@
           <a:p>
             <a:r>
               <a:rPr lang="en-US" dirty="0"/>
-              <a:t>Source: Flai voice AI dashboard, Service view, standings export, Jul 26 - Oct 26, 2026 (93 days). Flai's location names (26 with calls). Pickup rate and resolution as Flai reports them. Flai's estimated savings, revenue and profit are not used. Ranked among the 23 locations with 300+ calls (Subaru St George, Land Rover Henderson, Jaguar Land Rover Las Vegas have fewer). Honda Spokane shows no calls in the period.Talk track: the voice AI answers every call, books what it can and hands the rest to the store. What happens next is ours: someone has to pick up the transfer, and every callback has to be closed. A store that doesn't pick up is sending a customer it already has to voicemail.
+              <a:t>Source: Flai voice AI dashboard, Service view, standings export, Jul 26 - Oct 26, 2026 (93 days). Flai's location names (26 with calls). Pickup rate and resolution as Flai reports them. Flai's estimated savings, revenue and profit are not used. Green bar: the store is in more than one top list. Ranked among the 23 locations with 300+ calls (Subaru St George, Land Rover Henderson, Jaguar Land Rover Las Vegas have fewer). Honda Spokane shows no calls in the period.Talk track: the voice AI answers every call, books what it can and hands the rest to the store. What happens next is ours: someone has to pick up the transfer, and every callback has to be closed. A store that doesn't pick up is sending a customer it already has to voicemail.
 Definitions to confirm against Flai: pickup rate is read as the share of transferred calls a person picked up; resolution as the share of callback requests closed. Resolve time in the export runs to weeks at some locations and is not shown.</a:t>
             </a:r>
             <a:endParaRPr lang="en-US" dirty="0"/>
@@ -2191,7 +2191,7 @@
         <p:spPr>
           <a:xfrm>
             <a:off x="621792" y="2167128"/>
-            <a:ext cx="1673352" cy="345643"/>
+            <a:ext cx="1673352" cy="314221"/>
           </a:xfrm>
           <a:prstGeom prst="rect">
             <a:avLst/>
@@ -2230,7 +2230,7 @@
         <p:spPr>
           <a:xfrm>
             <a:off x="2313432" y="2167128"/>
-            <a:ext cx="731520" cy="345643"/>
+            <a:ext cx="731520" cy="314221"/>
           </a:xfrm>
           <a:prstGeom prst="rect">
             <a:avLst/>
@@ -2269,7 +2269,7 @@
         <p:spPr>
           <a:xfrm>
             <a:off x="3063240" y="2167128"/>
-            <a:ext cx="914400" cy="345643"/>
+            <a:ext cx="914400" cy="314221"/>
           </a:xfrm>
           <a:prstGeom prst="rect">
             <a:avLst/>
@@ -2301,14 +2301,34 @@
       </p:sp>
       <p:sp>
         <p:nvSpPr>
-          <p:cNvPr id="15" name="Text 13"/>
-          <p:cNvSpPr txBox="1"/>
-          <p:nvPr/>
-        </p:nvSpPr>
-        <p:spPr>
-          <a:xfrm>
-            <a:off x="621792" y="2512771"/>
-            <a:ext cx="1673352" cy="345643"/>
+          <p:cNvPr id="15" name="Shape 13"/>
+          <p:cNvSpPr/>
+          <p:nvPr/>
+        </p:nvSpPr>
+        <p:spPr>
+          <a:xfrm>
+            <a:off x="4023360" y="2203704"/>
+            <a:ext cx="54864" cy="241069"/>
+          </a:xfrm>
+          <a:prstGeom prst="rect">
+            <a:avLst/>
+          </a:prstGeom>
+          <a:solidFill>
+            <a:srgbClr val="12A566"/>
+          </a:solidFill>
+          <a:ln/>
+        </p:spPr>
+      </p:sp>
+      <p:sp>
+        <p:nvSpPr>
+          <p:cNvPr id="16" name="Text 14"/>
+          <p:cNvSpPr txBox="1"/>
+          <p:nvPr/>
+        </p:nvSpPr>
+        <p:spPr>
+          <a:xfrm>
+            <a:off x="621792" y="2481349"/>
+            <a:ext cx="1673352" cy="314221"/>
           </a:xfrm>
           <a:prstGeom prst="rect">
             <a:avLst/>
@@ -2340,14 +2360,14 @@
       </p:sp>
       <p:sp>
         <p:nvSpPr>
-          <p:cNvPr id="16" name="Text 14"/>
-          <p:cNvSpPr txBox="1"/>
-          <p:nvPr/>
-        </p:nvSpPr>
-        <p:spPr>
-          <a:xfrm>
-            <a:off x="2313432" y="2512771"/>
-            <a:ext cx="731520" cy="345643"/>
+          <p:cNvPr id="17" name="Text 15"/>
+          <p:cNvSpPr txBox="1"/>
+          <p:nvPr/>
+        </p:nvSpPr>
+        <p:spPr>
+          <a:xfrm>
+            <a:off x="2313432" y="2481349"/>
+            <a:ext cx="731520" cy="314221"/>
           </a:xfrm>
           <a:prstGeom prst="rect">
             <a:avLst/>
@@ -2379,14 +2399,14 @@
       </p:sp>
       <p:sp>
         <p:nvSpPr>
-          <p:cNvPr id="17" name="Text 15"/>
-          <p:cNvSpPr txBox="1"/>
-          <p:nvPr/>
-        </p:nvSpPr>
-        <p:spPr>
-          <a:xfrm>
-            <a:off x="3063240" y="2512771"/>
-            <a:ext cx="914400" cy="345643"/>
+          <p:cNvPr id="18" name="Text 16"/>
+          <p:cNvSpPr txBox="1"/>
+          <p:nvPr/>
+        </p:nvSpPr>
+        <p:spPr>
+          <a:xfrm>
+            <a:off x="3063240" y="2481349"/>
+            <a:ext cx="914400" cy="314221"/>
           </a:xfrm>
           <a:prstGeom prst="rect">
             <a:avLst/>
@@ -2418,14 +2438,14 @@
       </p:sp>
       <p:sp>
         <p:nvSpPr>
-          <p:cNvPr id="18" name="Text 16"/>
-          <p:cNvSpPr txBox="1"/>
-          <p:nvPr/>
-        </p:nvSpPr>
-        <p:spPr>
-          <a:xfrm>
-            <a:off x="621792" y="2858414"/>
-            <a:ext cx="1673352" cy="345643"/>
+          <p:cNvPr id="19" name="Text 17"/>
+          <p:cNvSpPr txBox="1"/>
+          <p:nvPr/>
+        </p:nvSpPr>
+        <p:spPr>
+          <a:xfrm>
+            <a:off x="621792" y="2795570"/>
+            <a:ext cx="1673352" cy="314221"/>
           </a:xfrm>
           <a:prstGeom prst="rect">
             <a:avLst/>
@@ -2457,14 +2477,14 @@
       </p:sp>
       <p:sp>
         <p:nvSpPr>
-          <p:cNvPr id="19" name="Text 17"/>
-          <p:cNvSpPr txBox="1"/>
-          <p:nvPr/>
-        </p:nvSpPr>
-        <p:spPr>
-          <a:xfrm>
-            <a:off x="2313432" y="2858414"/>
-            <a:ext cx="731520" cy="345643"/>
+          <p:cNvPr id="20" name="Text 18"/>
+          <p:cNvSpPr txBox="1"/>
+          <p:nvPr/>
+        </p:nvSpPr>
+        <p:spPr>
+          <a:xfrm>
+            <a:off x="2313432" y="2795570"/>
+            <a:ext cx="731520" cy="314221"/>
           </a:xfrm>
           <a:prstGeom prst="rect">
             <a:avLst/>
@@ -2496,14 +2516,14 @@
       </p:sp>
       <p:sp>
         <p:nvSpPr>
-          <p:cNvPr id="20" name="Text 18"/>
-          <p:cNvSpPr txBox="1"/>
-          <p:nvPr/>
-        </p:nvSpPr>
-        <p:spPr>
-          <a:xfrm>
-            <a:off x="3063240" y="2858414"/>
-            <a:ext cx="914400" cy="345643"/>
+          <p:cNvPr id="21" name="Text 19"/>
+          <p:cNvSpPr txBox="1"/>
+          <p:nvPr/>
+        </p:nvSpPr>
+        <p:spPr>
+          <a:xfrm>
+            <a:off x="3063240" y="2795570"/>
+            <a:ext cx="914400" cy="314221"/>
           </a:xfrm>
           <a:prstGeom prst="rect">
             <a:avLst/>
@@ -2535,14 +2555,34 @@
       </p:sp>
       <p:sp>
         <p:nvSpPr>
-          <p:cNvPr id="21" name="Text 19"/>
-          <p:cNvSpPr txBox="1"/>
-          <p:nvPr/>
-        </p:nvSpPr>
-        <p:spPr>
-          <a:xfrm>
-            <a:off x="621792" y="3204058"/>
-            <a:ext cx="1673352" cy="345643"/>
+          <p:cNvPr id="22" name="Shape 20"/>
+          <p:cNvSpPr/>
+          <p:nvPr/>
+        </p:nvSpPr>
+        <p:spPr>
+          <a:xfrm>
+            <a:off x="4023360" y="2832146"/>
+            <a:ext cx="54864" cy="241069"/>
+          </a:xfrm>
+          <a:prstGeom prst="rect">
+            <a:avLst/>
+          </a:prstGeom>
+          <a:solidFill>
+            <a:srgbClr val="12A566"/>
+          </a:solidFill>
+          <a:ln/>
+        </p:spPr>
+      </p:sp>
+      <p:sp>
+        <p:nvSpPr>
+          <p:cNvPr id="23" name="Text 21"/>
+          <p:cNvSpPr txBox="1"/>
+          <p:nvPr/>
+        </p:nvSpPr>
+        <p:spPr>
+          <a:xfrm>
+            <a:off x="621792" y="3109791"/>
+            <a:ext cx="1673352" cy="314221"/>
           </a:xfrm>
           <a:prstGeom prst="rect">
             <a:avLst/>
@@ -2574,14 +2614,14 @@
       </p:sp>
       <p:sp>
         <p:nvSpPr>
-          <p:cNvPr id="22" name="Text 20"/>
-          <p:cNvSpPr txBox="1"/>
-          <p:nvPr/>
-        </p:nvSpPr>
-        <p:spPr>
-          <a:xfrm>
-            <a:off x="2313432" y="3204058"/>
-            <a:ext cx="731520" cy="345643"/>
+          <p:cNvPr id="24" name="Text 22"/>
+          <p:cNvSpPr txBox="1"/>
+          <p:nvPr/>
+        </p:nvSpPr>
+        <p:spPr>
+          <a:xfrm>
+            <a:off x="2313432" y="3109791"/>
+            <a:ext cx="731520" cy="314221"/>
           </a:xfrm>
           <a:prstGeom prst="rect">
             <a:avLst/>
@@ -2613,14 +2653,14 @@
       </p:sp>
       <p:sp>
         <p:nvSpPr>
-          <p:cNvPr id="23" name="Text 21"/>
-          <p:cNvSpPr txBox="1"/>
-          <p:nvPr/>
-        </p:nvSpPr>
-        <p:spPr>
-          <a:xfrm>
-            <a:off x="3063240" y="3204058"/>
-            <a:ext cx="914400" cy="345643"/>
+          <p:cNvPr id="25" name="Text 23"/>
+          <p:cNvSpPr txBox="1"/>
+          <p:nvPr/>
+        </p:nvSpPr>
+        <p:spPr>
+          <a:xfrm>
+            <a:off x="3063240" y="3109791"/>
+            <a:ext cx="914400" cy="314221"/>
           </a:xfrm>
           <a:prstGeom prst="rect">
             <a:avLst/>
@@ -2652,14 +2692,34 @@
       </p:sp>
       <p:sp>
         <p:nvSpPr>
-          <p:cNvPr id="24" name="Text 22"/>
-          <p:cNvSpPr txBox="1"/>
-          <p:nvPr/>
-        </p:nvSpPr>
-        <p:spPr>
-          <a:xfrm>
-            <a:off x="621792" y="3549701"/>
-            <a:ext cx="1673352" cy="345643"/>
+          <p:cNvPr id="26" name="Shape 24"/>
+          <p:cNvSpPr/>
+          <p:nvPr/>
+        </p:nvSpPr>
+        <p:spPr>
+          <a:xfrm>
+            <a:off x="4023360" y="3146367"/>
+            <a:ext cx="54864" cy="241069"/>
+          </a:xfrm>
+          <a:prstGeom prst="rect">
+            <a:avLst/>
+          </a:prstGeom>
+          <a:solidFill>
+            <a:srgbClr val="12A566"/>
+          </a:solidFill>
+          <a:ln/>
+        </p:spPr>
+      </p:sp>
+      <p:sp>
+        <p:nvSpPr>
+          <p:cNvPr id="27" name="Text 25"/>
+          <p:cNvSpPr txBox="1"/>
+          <p:nvPr/>
+        </p:nvSpPr>
+        <p:spPr>
+          <a:xfrm>
+            <a:off x="621792" y="3424012"/>
+            <a:ext cx="1673352" cy="314221"/>
           </a:xfrm>
           <a:prstGeom prst="rect">
             <a:avLst/>
@@ -2691,14 +2751,14 @@
       </p:sp>
       <p:sp>
         <p:nvSpPr>
-          <p:cNvPr id="25" name="Text 23"/>
-          <p:cNvSpPr txBox="1"/>
-          <p:nvPr/>
-        </p:nvSpPr>
-        <p:spPr>
-          <a:xfrm>
-            <a:off x="2313432" y="3549701"/>
-            <a:ext cx="731520" cy="345643"/>
+          <p:cNvPr id="28" name="Text 26"/>
+          <p:cNvSpPr txBox="1"/>
+          <p:nvPr/>
+        </p:nvSpPr>
+        <p:spPr>
+          <a:xfrm>
+            <a:off x="2313432" y="3424012"/>
+            <a:ext cx="731520" cy="314221"/>
           </a:xfrm>
           <a:prstGeom prst="rect">
             <a:avLst/>
@@ -2730,14 +2790,14 @@
       </p:sp>
       <p:sp>
         <p:nvSpPr>
-          <p:cNvPr id="26" name="Text 24"/>
-          <p:cNvSpPr txBox="1"/>
-          <p:nvPr/>
-        </p:nvSpPr>
-        <p:spPr>
-          <a:xfrm>
-            <a:off x="3063240" y="3549701"/>
-            <a:ext cx="914400" cy="345643"/>
+          <p:cNvPr id="29" name="Text 27"/>
+          <p:cNvSpPr txBox="1"/>
+          <p:nvPr/>
+        </p:nvSpPr>
+        <p:spPr>
+          <a:xfrm>
+            <a:off x="3063240" y="3424012"/>
+            <a:ext cx="914400" cy="314221"/>
           </a:xfrm>
           <a:prstGeom prst="rect">
             <a:avLst/>
@@ -2769,13 +2829,33 @@
       </p:sp>
       <p:sp>
         <p:nvSpPr>
-          <p:cNvPr id="27" name="Shape 25"/>
+          <p:cNvPr id="30" name="Shape 28"/>
           <p:cNvSpPr/>
           <p:nvPr/>
         </p:nvSpPr>
         <p:spPr>
           <a:xfrm>
-            <a:off x="621792" y="3913632"/>
+            <a:off x="4023360" y="3460588"/>
+            <a:ext cx="54864" cy="241069"/>
+          </a:xfrm>
+          <a:prstGeom prst="rect">
+            <a:avLst/>
+          </a:prstGeom>
+          <a:solidFill>
+            <a:srgbClr val="12A566"/>
+          </a:solidFill>
+          <a:ln/>
+        </p:spPr>
+      </p:sp>
+      <p:sp>
+        <p:nvSpPr>
+          <p:cNvPr id="31" name="Shape 29"/>
+          <p:cNvSpPr/>
+          <p:nvPr/>
+        </p:nvSpPr>
+        <p:spPr>
+          <a:xfrm>
+            <a:off x="621792" y="4070743"/>
             <a:ext cx="3355848" cy="22860"/>
           </a:xfrm>
           <a:prstGeom prst="rect">
@@ -2789,13 +2869,13 @@
       </p:sp>
       <p:sp>
         <p:nvSpPr>
-          <p:cNvPr id="28" name="Text 26"/>
-          <p:cNvSpPr txBox="1"/>
-          <p:nvPr/>
-        </p:nvSpPr>
-        <p:spPr>
-          <a:xfrm>
-            <a:off x="621792" y="3941064"/>
+          <p:cNvPr id="32" name="Text 30"/>
+          <p:cNvSpPr txBox="1"/>
+          <p:nvPr/>
+        </p:nvSpPr>
+        <p:spPr>
+          <a:xfrm>
+            <a:off x="621792" y="4098175"/>
             <a:ext cx="1828800" cy="219456"/>
           </a:xfrm>
           <a:prstGeom prst="rect">
@@ -2828,13 +2908,13 @@
       </p:sp>
       <p:sp>
         <p:nvSpPr>
-          <p:cNvPr id="29" name="Text 27"/>
-          <p:cNvSpPr txBox="1"/>
-          <p:nvPr/>
-        </p:nvSpPr>
-        <p:spPr>
-          <a:xfrm>
-            <a:off x="2313432" y="3941064"/>
+          <p:cNvPr id="33" name="Text 31"/>
+          <p:cNvSpPr txBox="1"/>
+          <p:nvPr/>
+        </p:nvSpPr>
+        <p:spPr>
+          <a:xfrm>
+            <a:off x="2313432" y="4098175"/>
             <a:ext cx="731520" cy="219456"/>
           </a:xfrm>
           <a:prstGeom prst="rect">
@@ -2867,13 +2947,13 @@
       </p:sp>
       <p:sp>
         <p:nvSpPr>
-          <p:cNvPr id="30" name="Text 28"/>
-          <p:cNvSpPr txBox="1"/>
-          <p:nvPr/>
-        </p:nvSpPr>
-        <p:spPr>
-          <a:xfrm>
-            <a:off x="3063240" y="3941064"/>
+          <p:cNvPr id="34" name="Text 32"/>
+          <p:cNvSpPr txBox="1"/>
+          <p:nvPr/>
+        </p:nvSpPr>
+        <p:spPr>
+          <a:xfrm>
+            <a:off x="3063240" y="4098175"/>
             <a:ext cx="914400" cy="219456"/>
           </a:xfrm>
           <a:prstGeom prst="rect">
@@ -2906,14 +2986,14 @@
       </p:sp>
       <p:sp>
         <p:nvSpPr>
-          <p:cNvPr id="31" name="Text 29"/>
-          <p:cNvSpPr txBox="1"/>
-          <p:nvPr/>
-        </p:nvSpPr>
-        <p:spPr>
-          <a:xfrm>
-            <a:off x="621792" y="4169664"/>
-            <a:ext cx="1673352" cy="345643"/>
+          <p:cNvPr id="35" name="Text 33"/>
+          <p:cNvSpPr txBox="1"/>
+          <p:nvPr/>
+        </p:nvSpPr>
+        <p:spPr>
+          <a:xfrm>
+            <a:off x="621792" y="4326775"/>
+            <a:ext cx="1673352" cy="314221"/>
           </a:xfrm>
           <a:prstGeom prst="rect">
             <a:avLst/>
@@ -2945,14 +3025,14 @@
       </p:sp>
       <p:sp>
         <p:nvSpPr>
-          <p:cNvPr id="32" name="Text 30"/>
-          <p:cNvSpPr txBox="1"/>
-          <p:nvPr/>
-        </p:nvSpPr>
-        <p:spPr>
-          <a:xfrm>
-            <a:off x="2313432" y="4169664"/>
-            <a:ext cx="731520" cy="345643"/>
+          <p:cNvPr id="36" name="Text 34"/>
+          <p:cNvSpPr txBox="1"/>
+          <p:nvPr/>
+        </p:nvSpPr>
+        <p:spPr>
+          <a:xfrm>
+            <a:off x="2313432" y="4326775"/>
+            <a:ext cx="731520" cy="314221"/>
           </a:xfrm>
           <a:prstGeom prst="rect">
             <a:avLst/>
@@ -2984,14 +3064,14 @@
       </p:sp>
       <p:sp>
         <p:nvSpPr>
-          <p:cNvPr id="33" name="Text 31"/>
-          <p:cNvSpPr txBox="1"/>
-          <p:nvPr/>
-        </p:nvSpPr>
-        <p:spPr>
-          <a:xfrm>
-            <a:off x="3063240" y="4169664"/>
-            <a:ext cx="914400" cy="345643"/>
+          <p:cNvPr id="37" name="Text 35"/>
+          <p:cNvSpPr txBox="1"/>
+          <p:nvPr/>
+        </p:nvSpPr>
+        <p:spPr>
+          <a:xfrm>
+            <a:off x="3063240" y="4326775"/>
+            <a:ext cx="914400" cy="314221"/>
           </a:xfrm>
           <a:prstGeom prst="rect">
             <a:avLst/>
@@ -3023,14 +3103,14 @@
       </p:sp>
       <p:sp>
         <p:nvSpPr>
-          <p:cNvPr id="34" name="Text 32"/>
-          <p:cNvSpPr txBox="1"/>
-          <p:nvPr/>
-        </p:nvSpPr>
-        <p:spPr>
-          <a:xfrm>
-            <a:off x="621792" y="4515307"/>
-            <a:ext cx="1673352" cy="345643"/>
+          <p:cNvPr id="38" name="Text 36"/>
+          <p:cNvSpPr txBox="1"/>
+          <p:nvPr/>
+        </p:nvSpPr>
+        <p:spPr>
+          <a:xfrm>
+            <a:off x="621792" y="4640996"/>
+            <a:ext cx="1673352" cy="314221"/>
           </a:xfrm>
           <a:prstGeom prst="rect">
             <a:avLst/>
@@ -3062,14 +3142,14 @@
       </p:sp>
       <p:sp>
         <p:nvSpPr>
-          <p:cNvPr id="35" name="Text 33"/>
-          <p:cNvSpPr txBox="1"/>
-          <p:nvPr/>
-        </p:nvSpPr>
-        <p:spPr>
-          <a:xfrm>
-            <a:off x="2313432" y="4515307"/>
-            <a:ext cx="731520" cy="345643"/>
+          <p:cNvPr id="39" name="Text 37"/>
+          <p:cNvSpPr txBox="1"/>
+          <p:nvPr/>
+        </p:nvSpPr>
+        <p:spPr>
+          <a:xfrm>
+            <a:off x="2313432" y="4640996"/>
+            <a:ext cx="731520" cy="314221"/>
           </a:xfrm>
           <a:prstGeom prst="rect">
             <a:avLst/>
@@ -3101,14 +3181,14 @@
       </p:sp>
       <p:sp>
         <p:nvSpPr>
-          <p:cNvPr id="36" name="Text 34"/>
-          <p:cNvSpPr txBox="1"/>
-          <p:nvPr/>
-        </p:nvSpPr>
-        <p:spPr>
-          <a:xfrm>
-            <a:off x="3063240" y="4515307"/>
-            <a:ext cx="914400" cy="345643"/>
+          <p:cNvPr id="40" name="Text 38"/>
+          <p:cNvSpPr txBox="1"/>
+          <p:nvPr/>
+        </p:nvSpPr>
+        <p:spPr>
+          <a:xfrm>
+            <a:off x="3063240" y="4640996"/>
+            <a:ext cx="914400" cy="314221"/>
           </a:xfrm>
           <a:prstGeom prst="rect">
             <a:avLst/>
@@ -3140,14 +3220,14 @@
       </p:sp>
       <p:sp>
         <p:nvSpPr>
-          <p:cNvPr id="37" name="Text 35"/>
-          <p:cNvSpPr txBox="1"/>
-          <p:nvPr/>
-        </p:nvSpPr>
-        <p:spPr>
-          <a:xfrm>
-            <a:off x="621792" y="4860950"/>
-            <a:ext cx="1673352" cy="345643"/>
+          <p:cNvPr id="41" name="Text 39"/>
+          <p:cNvSpPr txBox="1"/>
+          <p:nvPr/>
+        </p:nvSpPr>
+        <p:spPr>
+          <a:xfrm>
+            <a:off x="621792" y="4955217"/>
+            <a:ext cx="1673352" cy="314221"/>
           </a:xfrm>
           <a:prstGeom prst="rect">
             <a:avLst/>
@@ -3179,14 +3259,14 @@
       </p:sp>
       <p:sp>
         <p:nvSpPr>
-          <p:cNvPr id="38" name="Text 36"/>
-          <p:cNvSpPr txBox="1"/>
-          <p:nvPr/>
-        </p:nvSpPr>
-        <p:spPr>
-          <a:xfrm>
-            <a:off x="2313432" y="4860950"/>
-            <a:ext cx="731520" cy="345643"/>
+          <p:cNvPr id="42" name="Text 40"/>
+          <p:cNvSpPr txBox="1"/>
+          <p:nvPr/>
+        </p:nvSpPr>
+        <p:spPr>
+          <a:xfrm>
+            <a:off x="2313432" y="4955217"/>
+            <a:ext cx="731520" cy="314221"/>
           </a:xfrm>
           <a:prstGeom prst="rect">
             <a:avLst/>
@@ -3218,14 +3298,14 @@
       </p:sp>
       <p:sp>
         <p:nvSpPr>
-          <p:cNvPr id="39" name="Text 37"/>
-          <p:cNvSpPr txBox="1"/>
-          <p:nvPr/>
-        </p:nvSpPr>
-        <p:spPr>
-          <a:xfrm>
-            <a:off x="3063240" y="4860950"/>
-            <a:ext cx="914400" cy="345643"/>
+          <p:cNvPr id="43" name="Text 41"/>
+          <p:cNvSpPr txBox="1"/>
+          <p:nvPr/>
+        </p:nvSpPr>
+        <p:spPr>
+          <a:xfrm>
+            <a:off x="3063240" y="4955217"/>
+            <a:ext cx="914400" cy="314221"/>
           </a:xfrm>
           <a:prstGeom prst="rect">
             <a:avLst/>
@@ -3257,14 +3337,14 @@
       </p:sp>
       <p:sp>
         <p:nvSpPr>
-          <p:cNvPr id="40" name="Text 38"/>
-          <p:cNvSpPr txBox="1"/>
-          <p:nvPr/>
-        </p:nvSpPr>
-        <p:spPr>
-          <a:xfrm>
-            <a:off x="621792" y="5206594"/>
-            <a:ext cx="1673352" cy="345643"/>
+          <p:cNvPr id="44" name="Text 42"/>
+          <p:cNvSpPr txBox="1"/>
+          <p:nvPr/>
+        </p:nvSpPr>
+        <p:spPr>
+          <a:xfrm>
+            <a:off x="621792" y="5269438"/>
+            <a:ext cx="1673352" cy="314221"/>
           </a:xfrm>
           <a:prstGeom prst="rect">
             <a:avLst/>
@@ -3296,14 +3376,14 @@
       </p:sp>
       <p:sp>
         <p:nvSpPr>
-          <p:cNvPr id="41" name="Text 39"/>
-          <p:cNvSpPr txBox="1"/>
-          <p:nvPr/>
-        </p:nvSpPr>
-        <p:spPr>
-          <a:xfrm>
-            <a:off x="2313432" y="5206594"/>
-            <a:ext cx="731520" cy="345643"/>
+          <p:cNvPr id="45" name="Text 43"/>
+          <p:cNvSpPr txBox="1"/>
+          <p:nvPr/>
+        </p:nvSpPr>
+        <p:spPr>
+          <a:xfrm>
+            <a:off x="2313432" y="5269438"/>
+            <a:ext cx="731520" cy="314221"/>
           </a:xfrm>
           <a:prstGeom prst="rect">
             <a:avLst/>
@@ -3335,14 +3415,14 @@
       </p:sp>
       <p:sp>
         <p:nvSpPr>
-          <p:cNvPr id="42" name="Text 40"/>
-          <p:cNvSpPr txBox="1"/>
-          <p:nvPr/>
-        </p:nvSpPr>
-        <p:spPr>
-          <a:xfrm>
-            <a:off x="3063240" y="5206594"/>
-            <a:ext cx="914400" cy="345643"/>
+          <p:cNvPr id="46" name="Text 44"/>
+          <p:cNvSpPr txBox="1"/>
+          <p:nvPr/>
+        </p:nvSpPr>
+        <p:spPr>
+          <a:xfrm>
+            <a:off x="3063240" y="5269438"/>
+            <a:ext cx="914400" cy="314221"/>
           </a:xfrm>
           <a:prstGeom prst="rect">
             <a:avLst/>
@@ -3374,14 +3454,14 @@
       </p:sp>
       <p:sp>
         <p:nvSpPr>
-          <p:cNvPr id="43" name="Text 41"/>
-          <p:cNvSpPr txBox="1"/>
-          <p:nvPr/>
-        </p:nvSpPr>
-        <p:spPr>
-          <a:xfrm>
-            <a:off x="621792" y="5552237"/>
-            <a:ext cx="1673352" cy="345643"/>
+          <p:cNvPr id="47" name="Text 45"/>
+          <p:cNvSpPr txBox="1"/>
+          <p:nvPr/>
+        </p:nvSpPr>
+        <p:spPr>
+          <a:xfrm>
+            <a:off x="621792" y="5583659"/>
+            <a:ext cx="1673352" cy="314221"/>
           </a:xfrm>
           <a:prstGeom prst="rect">
             <a:avLst/>
@@ -3413,14 +3493,14 @@
       </p:sp>
       <p:sp>
         <p:nvSpPr>
-          <p:cNvPr id="44" name="Text 42"/>
-          <p:cNvSpPr txBox="1"/>
-          <p:nvPr/>
-        </p:nvSpPr>
-        <p:spPr>
-          <a:xfrm>
-            <a:off x="2313432" y="5552237"/>
-            <a:ext cx="731520" cy="345643"/>
+          <p:cNvPr id="48" name="Text 46"/>
+          <p:cNvSpPr txBox="1"/>
+          <p:nvPr/>
+        </p:nvSpPr>
+        <p:spPr>
+          <a:xfrm>
+            <a:off x="2313432" y="5583659"/>
+            <a:ext cx="731520" cy="314221"/>
           </a:xfrm>
           <a:prstGeom prst="rect">
             <a:avLst/>
@@ -3452,14 +3532,14 @@
       </p:sp>
       <p:sp>
         <p:nvSpPr>
-          <p:cNvPr id="45" name="Text 43"/>
-          <p:cNvSpPr txBox="1"/>
-          <p:nvPr/>
-        </p:nvSpPr>
-        <p:spPr>
-          <a:xfrm>
-            <a:off x="3063240" y="5552237"/>
-            <a:ext cx="914400" cy="345643"/>
+          <p:cNvPr id="49" name="Text 47"/>
+          <p:cNvSpPr txBox="1"/>
+          <p:nvPr/>
+        </p:nvSpPr>
+        <p:spPr>
+          <a:xfrm>
+            <a:off x="3063240" y="5583659"/>
+            <a:ext cx="914400" cy="314221"/>
           </a:xfrm>
           <a:prstGeom prst="rect">
             <a:avLst/>
@@ -3491,7 +3571,7 @@
       </p:sp>
       <p:sp>
         <p:nvSpPr>
-          <p:cNvPr id="46" name="Shape 44"/>
+          <p:cNvPr id="50" name="Shape 48"/>
           <p:cNvSpPr/>
           <p:nvPr/>
         </p:nvSpPr>
@@ -3511,7 +3591,7 @@
       </p:sp>
       <p:sp>
         <p:nvSpPr>
-          <p:cNvPr id="47" name="Text 45"/>
+          <p:cNvPr id="51" name="Text 49"/>
           <p:cNvSpPr txBox="1"/>
           <p:nvPr/>
         </p:nvSpPr>
@@ -3550,7 +3630,7 @@
       </p:sp>
       <p:sp>
         <p:nvSpPr>
-          <p:cNvPr id="48" name="Text 46"/>
+          <p:cNvPr id="52" name="Text 50"/>
           <p:cNvSpPr txBox="1"/>
           <p:nvPr/>
         </p:nvSpPr>
@@ -3589,7 +3669,7 @@
       </p:sp>
       <p:sp>
         <p:nvSpPr>
-          <p:cNvPr id="49" name="Shape 47"/>
+          <p:cNvPr id="53" name="Shape 51"/>
           <p:cNvSpPr/>
           <p:nvPr/>
         </p:nvSpPr>
@@ -3609,7 +3689,7 @@
       </p:sp>
       <p:sp>
         <p:nvSpPr>
-          <p:cNvPr id="50" name="Text 48"/>
+          <p:cNvPr id="54" name="Text 52"/>
           <p:cNvSpPr txBox="1"/>
           <p:nvPr/>
         </p:nvSpPr>
@@ -3648,7 +3728,7 @@
       </p:sp>
       <p:sp>
         <p:nvSpPr>
-          <p:cNvPr id="51" name="Text 49"/>
+          <p:cNvPr id="55" name="Text 53"/>
           <p:cNvSpPr txBox="1"/>
           <p:nvPr/>
         </p:nvSpPr>
@@ -3687,7 +3767,7 @@
       </p:sp>
       <p:sp>
         <p:nvSpPr>
-          <p:cNvPr id="52" name="Text 50"/>
+          <p:cNvPr id="56" name="Text 54"/>
           <p:cNvSpPr txBox="1"/>
           <p:nvPr/>
         </p:nvSpPr>
@@ -3726,14 +3806,14 @@
       </p:sp>
       <p:sp>
         <p:nvSpPr>
-          <p:cNvPr id="53" name="Text 51"/>
+          <p:cNvPr id="57" name="Text 55"/>
           <p:cNvSpPr txBox="1"/>
           <p:nvPr/>
         </p:nvSpPr>
         <p:spPr>
           <a:xfrm>
             <a:off x="4416552" y="2167128"/>
-            <a:ext cx="1673352" cy="345643"/>
+            <a:ext cx="1673352" cy="314221"/>
           </a:xfrm>
           <a:prstGeom prst="rect">
             <a:avLst/>
@@ -3765,14 +3845,14 @@
       </p:sp>
       <p:sp>
         <p:nvSpPr>
-          <p:cNvPr id="54" name="Text 52"/>
+          <p:cNvPr id="58" name="Text 56"/>
           <p:cNvSpPr txBox="1"/>
           <p:nvPr/>
         </p:nvSpPr>
         <p:spPr>
           <a:xfrm>
             <a:off x="6108192" y="2167128"/>
-            <a:ext cx="731520" cy="345643"/>
+            <a:ext cx="731520" cy="314221"/>
           </a:xfrm>
           <a:prstGeom prst="rect">
             <a:avLst/>
@@ -3804,14 +3884,14 @@
       </p:sp>
       <p:sp>
         <p:nvSpPr>
-          <p:cNvPr id="55" name="Text 53"/>
+          <p:cNvPr id="59" name="Text 57"/>
           <p:cNvSpPr txBox="1"/>
           <p:nvPr/>
         </p:nvSpPr>
         <p:spPr>
           <a:xfrm>
             <a:off x="6858000" y="2167128"/>
-            <a:ext cx="914400" cy="345643"/>
+            <a:ext cx="914400" cy="314221"/>
           </a:xfrm>
           <a:prstGeom prst="rect">
             <a:avLst/>
@@ -3843,14 +3923,34 @@
       </p:sp>
       <p:sp>
         <p:nvSpPr>
-          <p:cNvPr id="56" name="Text 54"/>
-          <p:cNvSpPr txBox="1"/>
-          <p:nvPr/>
-        </p:nvSpPr>
-        <p:spPr>
-          <a:xfrm>
-            <a:off x="4416552" y="2512771"/>
-            <a:ext cx="1673352" cy="345643"/>
+          <p:cNvPr id="60" name="Shape 58"/>
+          <p:cNvSpPr/>
+          <p:nvPr/>
+        </p:nvSpPr>
+        <p:spPr>
+          <a:xfrm>
+            <a:off x="7818120" y="2203704"/>
+            <a:ext cx="54864" cy="241069"/>
+          </a:xfrm>
+          <a:prstGeom prst="rect">
+            <a:avLst/>
+          </a:prstGeom>
+          <a:solidFill>
+            <a:srgbClr val="12A566"/>
+          </a:solidFill>
+          <a:ln/>
+        </p:spPr>
+      </p:sp>
+      <p:sp>
+        <p:nvSpPr>
+          <p:cNvPr id="61" name="Text 59"/>
+          <p:cNvSpPr txBox="1"/>
+          <p:nvPr/>
+        </p:nvSpPr>
+        <p:spPr>
+          <a:xfrm>
+            <a:off x="4416552" y="2481349"/>
+            <a:ext cx="1673352" cy="314221"/>
           </a:xfrm>
           <a:prstGeom prst="rect">
             <a:avLst/>
@@ -3882,14 +3982,14 @@
       </p:sp>
       <p:sp>
         <p:nvSpPr>
-          <p:cNvPr id="57" name="Text 55"/>
-          <p:cNvSpPr txBox="1"/>
-          <p:nvPr/>
-        </p:nvSpPr>
-        <p:spPr>
-          <a:xfrm>
-            <a:off x="6108192" y="2512771"/>
-            <a:ext cx="731520" cy="345643"/>
+          <p:cNvPr id="62" name="Text 60"/>
+          <p:cNvSpPr txBox="1"/>
+          <p:nvPr/>
+        </p:nvSpPr>
+        <p:spPr>
+          <a:xfrm>
+            <a:off x="6108192" y="2481349"/>
+            <a:ext cx="731520" cy="314221"/>
           </a:xfrm>
           <a:prstGeom prst="rect">
             <a:avLst/>
@@ -3921,14 +4021,14 @@
       </p:sp>
       <p:sp>
         <p:nvSpPr>
-          <p:cNvPr id="58" name="Text 56"/>
-          <p:cNvSpPr txBox="1"/>
-          <p:nvPr/>
-        </p:nvSpPr>
-        <p:spPr>
-          <a:xfrm>
-            <a:off x="6858000" y="2512771"/>
-            <a:ext cx="914400" cy="345643"/>
+          <p:cNvPr id="63" name="Text 61"/>
+          <p:cNvSpPr txBox="1"/>
+          <p:nvPr/>
+        </p:nvSpPr>
+        <p:spPr>
+          <a:xfrm>
+            <a:off x="6858000" y="2481349"/>
+            <a:ext cx="914400" cy="314221"/>
           </a:xfrm>
           <a:prstGeom prst="rect">
             <a:avLst/>
@@ -3960,14 +4060,34 @@
       </p:sp>
       <p:sp>
         <p:nvSpPr>
-          <p:cNvPr id="59" name="Text 57"/>
-          <p:cNvSpPr txBox="1"/>
-          <p:nvPr/>
-        </p:nvSpPr>
-        <p:spPr>
-          <a:xfrm>
-            <a:off x="4416552" y="2858414"/>
-            <a:ext cx="1673352" cy="345643"/>
+          <p:cNvPr id="64" name="Shape 62"/>
+          <p:cNvSpPr/>
+          <p:nvPr/>
+        </p:nvSpPr>
+        <p:spPr>
+          <a:xfrm>
+            <a:off x="7818120" y="2517925"/>
+            <a:ext cx="54864" cy="241069"/>
+          </a:xfrm>
+          <a:prstGeom prst="rect">
+            <a:avLst/>
+          </a:prstGeom>
+          <a:solidFill>
+            <a:srgbClr val="12A566"/>
+          </a:solidFill>
+          <a:ln/>
+        </p:spPr>
+      </p:sp>
+      <p:sp>
+        <p:nvSpPr>
+          <p:cNvPr id="65" name="Text 63"/>
+          <p:cNvSpPr txBox="1"/>
+          <p:nvPr/>
+        </p:nvSpPr>
+        <p:spPr>
+          <a:xfrm>
+            <a:off x="4416552" y="2795570"/>
+            <a:ext cx="1673352" cy="314221"/>
           </a:xfrm>
           <a:prstGeom prst="rect">
             <a:avLst/>
@@ -3999,14 +4119,14 @@
       </p:sp>
       <p:sp>
         <p:nvSpPr>
-          <p:cNvPr id="60" name="Text 58"/>
-          <p:cNvSpPr txBox="1"/>
-          <p:nvPr/>
-        </p:nvSpPr>
-        <p:spPr>
-          <a:xfrm>
-            <a:off x="6108192" y="2858414"/>
-            <a:ext cx="731520" cy="345643"/>
+          <p:cNvPr id="66" name="Text 64"/>
+          <p:cNvSpPr txBox="1"/>
+          <p:nvPr/>
+        </p:nvSpPr>
+        <p:spPr>
+          <a:xfrm>
+            <a:off x="6108192" y="2795570"/>
+            <a:ext cx="731520" cy="314221"/>
           </a:xfrm>
           <a:prstGeom prst="rect">
             <a:avLst/>
@@ -4038,14 +4158,14 @@
       </p:sp>
       <p:sp>
         <p:nvSpPr>
-          <p:cNvPr id="61" name="Text 59"/>
-          <p:cNvSpPr txBox="1"/>
-          <p:nvPr/>
-        </p:nvSpPr>
-        <p:spPr>
-          <a:xfrm>
-            <a:off x="6858000" y="2858414"/>
-            <a:ext cx="914400" cy="345643"/>
+          <p:cNvPr id="67" name="Text 65"/>
+          <p:cNvSpPr txBox="1"/>
+          <p:nvPr/>
+        </p:nvSpPr>
+        <p:spPr>
+          <a:xfrm>
+            <a:off x="6858000" y="2795570"/>
+            <a:ext cx="914400" cy="314221"/>
           </a:xfrm>
           <a:prstGeom prst="rect">
             <a:avLst/>
@@ -4070,240 +4190,6 @@
                 <a:cs typeface="Inter" pitchFamily="34" charset="-120"/>
               </a:rPr>
               <a:t>1,030</a:t>
-            </a:r>
-            <a:endParaRPr lang="en-US" sz="1200" dirty="0"/>
-          </a:p>
-        </p:txBody>
-      </p:sp>
-      <p:sp>
-        <p:nvSpPr>
-          <p:cNvPr id="62" name="Text 60"/>
-          <p:cNvSpPr txBox="1"/>
-          <p:nvPr/>
-        </p:nvSpPr>
-        <p:spPr>
-          <a:xfrm>
-            <a:off x="4416552" y="3204058"/>
-            <a:ext cx="1673352" cy="345643"/>
-          </a:xfrm>
-          <a:prstGeom prst="rect">
-            <a:avLst/>
-          </a:prstGeom>
-          <a:noFill/>
-          <a:ln/>
-        </p:spPr>
-        <p:txBody>
-          <a:bodyPr wrap="square" lIns="0" tIns="0" rIns="0" bIns="0" rtlCol="0" anchor="ctr"/>
-          <a:lstStyle/>
-          <a:p>
-            <a:pPr indent="0" marL="0">
-              <a:buNone/>
-            </a:pPr>
-            <a:r>
-              <a:rPr lang="en-US" sz="1300" dirty="0">
-                <a:solidFill>
-                  <a:srgbClr val="1A1A1A"/>
-                </a:solidFill>
-                <a:latin typeface="Inter" pitchFamily="34" charset="0"/>
-                <a:ea typeface="Inter" pitchFamily="34" charset="-122"/>
-                <a:cs typeface="Inter" pitchFamily="34" charset="-120"/>
-              </a:rPr>
-              <a:t>Toyota Flagstaff</a:t>
-            </a:r>
-            <a:endParaRPr lang="en-US" sz="1300" dirty="0"/>
-          </a:p>
-        </p:txBody>
-      </p:sp>
-      <p:sp>
-        <p:nvSpPr>
-          <p:cNvPr id="63" name="Text 61"/>
-          <p:cNvSpPr txBox="1"/>
-          <p:nvPr/>
-        </p:nvSpPr>
-        <p:spPr>
-          <a:xfrm>
-            <a:off x="6108192" y="3204058"/>
-            <a:ext cx="731520" cy="345643"/>
-          </a:xfrm>
-          <a:prstGeom prst="rect">
-            <a:avLst/>
-          </a:prstGeom>
-          <a:noFill/>
-          <a:ln/>
-        </p:spPr>
-        <p:txBody>
-          <a:bodyPr wrap="square" lIns="0" tIns="0" rIns="0" bIns="0" rtlCol="0" anchor="ctr"/>
-          <a:lstStyle/>
-          <a:p>
-            <a:pPr algn="r" indent="0" marL="0">
-              <a:buNone/>
-            </a:pPr>
-            <a:r>
-              <a:rPr lang="en-US" sz="1300" b="1" dirty="0">
-                <a:solidFill>
-                  <a:srgbClr val="0B7A4A"/>
-                </a:solidFill>
-                <a:latin typeface="Inter" pitchFamily="34" charset="0"/>
-                <a:ea typeface="Inter" pitchFamily="34" charset="-122"/>
-                <a:cs typeface="Inter" pitchFamily="34" charset="-120"/>
-              </a:rPr>
-              <a:t>57.3%</a:t>
-            </a:r>
-            <a:endParaRPr lang="en-US" sz="1300" dirty="0"/>
-          </a:p>
-        </p:txBody>
-      </p:sp>
-      <p:sp>
-        <p:nvSpPr>
-          <p:cNvPr id="64" name="Text 62"/>
-          <p:cNvSpPr txBox="1"/>
-          <p:nvPr/>
-        </p:nvSpPr>
-        <p:spPr>
-          <a:xfrm>
-            <a:off x="6858000" y="3204058"/>
-            <a:ext cx="914400" cy="345643"/>
-          </a:xfrm>
-          <a:prstGeom prst="rect">
-            <a:avLst/>
-          </a:prstGeom>
-          <a:noFill/>
-          <a:ln/>
-        </p:spPr>
-        <p:txBody>
-          <a:bodyPr wrap="square" lIns="0" tIns="0" rIns="0" bIns="0" rtlCol="0" anchor="ctr"/>
-          <a:lstStyle/>
-          <a:p>
-            <a:pPr algn="r" indent="0" marL="0">
-              <a:buNone/>
-            </a:pPr>
-            <a:r>
-              <a:rPr lang="en-US" sz="1200" dirty="0">
-                <a:solidFill>
-                  <a:srgbClr val="595959"/>
-                </a:solidFill>
-                <a:latin typeface="Inter" pitchFamily="34" charset="0"/>
-                <a:ea typeface="Inter" pitchFamily="34" charset="-122"/>
-                <a:cs typeface="Inter" pitchFamily="34" charset="-120"/>
-              </a:rPr>
-              <a:t>696</a:t>
-            </a:r>
-            <a:endParaRPr lang="en-US" sz="1200" dirty="0"/>
-          </a:p>
-        </p:txBody>
-      </p:sp>
-      <p:sp>
-        <p:nvSpPr>
-          <p:cNvPr id="65" name="Text 63"/>
-          <p:cNvSpPr txBox="1"/>
-          <p:nvPr/>
-        </p:nvSpPr>
-        <p:spPr>
-          <a:xfrm>
-            <a:off x="4416552" y="3549701"/>
-            <a:ext cx="1673352" cy="345643"/>
-          </a:xfrm>
-          <a:prstGeom prst="rect">
-            <a:avLst/>
-          </a:prstGeom>
-          <a:noFill/>
-          <a:ln/>
-        </p:spPr>
-        <p:txBody>
-          <a:bodyPr wrap="square" lIns="0" tIns="0" rIns="0" bIns="0" rtlCol="0" anchor="ctr"/>
-          <a:lstStyle/>
-          <a:p>
-            <a:pPr indent="0" marL="0">
-              <a:buNone/>
-            </a:pPr>
-            <a:r>
-              <a:rPr lang="en-US" sz="1300" dirty="0">
-                <a:solidFill>
-                  <a:srgbClr val="1A1A1A"/>
-                </a:solidFill>
-                <a:latin typeface="Inter" pitchFamily="34" charset="0"/>
-                <a:ea typeface="Inter" pitchFamily="34" charset="-122"/>
-                <a:cs typeface="Inter" pitchFamily="34" charset="-120"/>
-              </a:rPr>
-              <a:t>Audi Reno Tahoe</a:t>
-            </a:r>
-            <a:endParaRPr lang="en-US" sz="1300" dirty="0"/>
-          </a:p>
-        </p:txBody>
-      </p:sp>
-      <p:sp>
-        <p:nvSpPr>
-          <p:cNvPr id="66" name="Text 64"/>
-          <p:cNvSpPr txBox="1"/>
-          <p:nvPr/>
-        </p:nvSpPr>
-        <p:spPr>
-          <a:xfrm>
-            <a:off x="6108192" y="3549701"/>
-            <a:ext cx="731520" cy="345643"/>
-          </a:xfrm>
-          <a:prstGeom prst="rect">
-            <a:avLst/>
-          </a:prstGeom>
-          <a:noFill/>
-          <a:ln/>
-        </p:spPr>
-        <p:txBody>
-          <a:bodyPr wrap="square" lIns="0" tIns="0" rIns="0" bIns="0" rtlCol="0" anchor="ctr"/>
-          <a:lstStyle/>
-          <a:p>
-            <a:pPr algn="r" indent="0" marL="0">
-              <a:buNone/>
-            </a:pPr>
-            <a:r>
-              <a:rPr lang="en-US" sz="1300" b="1" dirty="0">
-                <a:solidFill>
-                  <a:srgbClr val="0B7A4A"/>
-                </a:solidFill>
-                <a:latin typeface="Inter" pitchFamily="34" charset="0"/>
-                <a:ea typeface="Inter" pitchFamily="34" charset="-122"/>
-                <a:cs typeface="Inter" pitchFamily="34" charset="-120"/>
-              </a:rPr>
-              <a:t>54.2%</a:t>
-            </a:r>
-            <a:endParaRPr lang="en-US" sz="1300" dirty="0"/>
-          </a:p>
-        </p:txBody>
-      </p:sp>
-      <p:sp>
-        <p:nvSpPr>
-          <p:cNvPr id="67" name="Text 65"/>
-          <p:cNvSpPr txBox="1"/>
-          <p:nvPr/>
-        </p:nvSpPr>
-        <p:spPr>
-          <a:xfrm>
-            <a:off x="6858000" y="3549701"/>
-            <a:ext cx="914400" cy="345643"/>
-          </a:xfrm>
-          <a:prstGeom prst="rect">
-            <a:avLst/>
-          </a:prstGeom>
-          <a:noFill/>
-          <a:ln/>
-        </p:spPr>
-        <p:txBody>
-          <a:bodyPr wrap="square" lIns="0" tIns="0" rIns="0" bIns="0" rtlCol="0" anchor="ctr"/>
-          <a:lstStyle/>
-          <a:p>
-            <a:pPr algn="r" indent="0" marL="0">
-              <a:buNone/>
-            </a:pPr>
-            <a:r>
-              <a:rPr lang="en-US" sz="1200" dirty="0">
-                <a:solidFill>
-                  <a:srgbClr val="595959"/>
-                </a:solidFill>
-                <a:latin typeface="Inter" pitchFamily="34" charset="0"/>
-                <a:ea typeface="Inter" pitchFamily="34" charset="-122"/>
-                <a:cs typeface="Inter" pitchFamily="34" charset="-120"/>
-              </a:rPr>
-              <a:t>1,171</a:t>
             </a:r>
             <a:endParaRPr lang="en-US" sz="1200" dirty="0"/>
           </a:p>
@@ -4317,7 +4203,281 @@
         </p:nvSpPr>
         <p:spPr>
           <a:xfrm>
-            <a:off x="4416552" y="3913632"/>
+            <a:off x="7818120" y="2832146"/>
+            <a:ext cx="54864" cy="241069"/>
+          </a:xfrm>
+          <a:prstGeom prst="rect">
+            <a:avLst/>
+          </a:prstGeom>
+          <a:solidFill>
+            <a:srgbClr val="12A566"/>
+          </a:solidFill>
+          <a:ln/>
+        </p:spPr>
+      </p:sp>
+      <p:sp>
+        <p:nvSpPr>
+          <p:cNvPr id="69" name="Text 67"/>
+          <p:cNvSpPr txBox="1"/>
+          <p:nvPr/>
+        </p:nvSpPr>
+        <p:spPr>
+          <a:xfrm>
+            <a:off x="4416552" y="3109791"/>
+            <a:ext cx="1673352" cy="314221"/>
+          </a:xfrm>
+          <a:prstGeom prst="rect">
+            <a:avLst/>
+          </a:prstGeom>
+          <a:noFill/>
+          <a:ln/>
+        </p:spPr>
+        <p:txBody>
+          <a:bodyPr wrap="square" lIns="0" tIns="0" rIns="0" bIns="0" rtlCol="0" anchor="ctr"/>
+          <a:lstStyle/>
+          <a:p>
+            <a:pPr indent="0" marL="0">
+              <a:buNone/>
+            </a:pPr>
+            <a:r>
+              <a:rPr lang="en-US" sz="1300" dirty="0">
+                <a:solidFill>
+                  <a:srgbClr val="1A1A1A"/>
+                </a:solidFill>
+                <a:latin typeface="Inter" pitchFamily="34" charset="0"/>
+                <a:ea typeface="Inter" pitchFamily="34" charset="-122"/>
+                <a:cs typeface="Inter" pitchFamily="34" charset="-120"/>
+              </a:rPr>
+              <a:t>Toyota Flagstaff</a:t>
+            </a:r>
+            <a:endParaRPr lang="en-US" sz="1300" dirty="0"/>
+          </a:p>
+        </p:txBody>
+      </p:sp>
+      <p:sp>
+        <p:nvSpPr>
+          <p:cNvPr id="70" name="Text 68"/>
+          <p:cNvSpPr txBox="1"/>
+          <p:nvPr/>
+        </p:nvSpPr>
+        <p:spPr>
+          <a:xfrm>
+            <a:off x="6108192" y="3109791"/>
+            <a:ext cx="731520" cy="314221"/>
+          </a:xfrm>
+          <a:prstGeom prst="rect">
+            <a:avLst/>
+          </a:prstGeom>
+          <a:noFill/>
+          <a:ln/>
+        </p:spPr>
+        <p:txBody>
+          <a:bodyPr wrap="square" lIns="0" tIns="0" rIns="0" bIns="0" rtlCol="0" anchor="ctr"/>
+          <a:lstStyle/>
+          <a:p>
+            <a:pPr algn="r" indent="0" marL="0">
+              <a:buNone/>
+            </a:pPr>
+            <a:r>
+              <a:rPr lang="en-US" sz="1300" b="1" dirty="0">
+                <a:solidFill>
+                  <a:srgbClr val="0B7A4A"/>
+                </a:solidFill>
+                <a:latin typeface="Inter" pitchFamily="34" charset="0"/>
+                <a:ea typeface="Inter" pitchFamily="34" charset="-122"/>
+                <a:cs typeface="Inter" pitchFamily="34" charset="-120"/>
+              </a:rPr>
+              <a:t>57.3%</a:t>
+            </a:r>
+            <a:endParaRPr lang="en-US" sz="1300" dirty="0"/>
+          </a:p>
+        </p:txBody>
+      </p:sp>
+      <p:sp>
+        <p:nvSpPr>
+          <p:cNvPr id="71" name="Text 69"/>
+          <p:cNvSpPr txBox="1"/>
+          <p:nvPr/>
+        </p:nvSpPr>
+        <p:spPr>
+          <a:xfrm>
+            <a:off x="6858000" y="3109791"/>
+            <a:ext cx="914400" cy="314221"/>
+          </a:xfrm>
+          <a:prstGeom prst="rect">
+            <a:avLst/>
+          </a:prstGeom>
+          <a:noFill/>
+          <a:ln/>
+        </p:spPr>
+        <p:txBody>
+          <a:bodyPr wrap="square" lIns="0" tIns="0" rIns="0" bIns="0" rtlCol="0" anchor="ctr"/>
+          <a:lstStyle/>
+          <a:p>
+            <a:pPr algn="r" indent="0" marL="0">
+              <a:buNone/>
+            </a:pPr>
+            <a:r>
+              <a:rPr lang="en-US" sz="1200" dirty="0">
+                <a:solidFill>
+                  <a:srgbClr val="595959"/>
+                </a:solidFill>
+                <a:latin typeface="Inter" pitchFamily="34" charset="0"/>
+                <a:ea typeface="Inter" pitchFamily="34" charset="-122"/>
+                <a:cs typeface="Inter" pitchFamily="34" charset="-120"/>
+              </a:rPr>
+              <a:t>696</a:t>
+            </a:r>
+            <a:endParaRPr lang="en-US" sz="1200" dirty="0"/>
+          </a:p>
+        </p:txBody>
+      </p:sp>
+      <p:sp>
+        <p:nvSpPr>
+          <p:cNvPr id="72" name="Shape 70"/>
+          <p:cNvSpPr/>
+          <p:nvPr/>
+        </p:nvSpPr>
+        <p:spPr>
+          <a:xfrm>
+            <a:off x="7818120" y="3146367"/>
+            <a:ext cx="54864" cy="241069"/>
+          </a:xfrm>
+          <a:prstGeom prst="rect">
+            <a:avLst/>
+          </a:prstGeom>
+          <a:solidFill>
+            <a:srgbClr val="12A566"/>
+          </a:solidFill>
+          <a:ln/>
+        </p:spPr>
+      </p:sp>
+      <p:sp>
+        <p:nvSpPr>
+          <p:cNvPr id="73" name="Text 71"/>
+          <p:cNvSpPr txBox="1"/>
+          <p:nvPr/>
+        </p:nvSpPr>
+        <p:spPr>
+          <a:xfrm>
+            <a:off x="4416552" y="3424012"/>
+            <a:ext cx="1673352" cy="314221"/>
+          </a:xfrm>
+          <a:prstGeom prst="rect">
+            <a:avLst/>
+          </a:prstGeom>
+          <a:noFill/>
+          <a:ln/>
+        </p:spPr>
+        <p:txBody>
+          <a:bodyPr wrap="square" lIns="0" tIns="0" rIns="0" bIns="0" rtlCol="0" anchor="ctr"/>
+          <a:lstStyle/>
+          <a:p>
+            <a:pPr indent="0" marL="0">
+              <a:buNone/>
+            </a:pPr>
+            <a:r>
+              <a:rPr lang="en-US" sz="1300" dirty="0">
+                <a:solidFill>
+                  <a:srgbClr val="1A1A1A"/>
+                </a:solidFill>
+                <a:latin typeface="Inter" pitchFamily="34" charset="0"/>
+                <a:ea typeface="Inter" pitchFamily="34" charset="-122"/>
+                <a:cs typeface="Inter" pitchFamily="34" charset="-120"/>
+              </a:rPr>
+              <a:t>Audi Reno Tahoe</a:t>
+            </a:r>
+            <a:endParaRPr lang="en-US" sz="1300" dirty="0"/>
+          </a:p>
+        </p:txBody>
+      </p:sp>
+      <p:sp>
+        <p:nvSpPr>
+          <p:cNvPr id="74" name="Text 72"/>
+          <p:cNvSpPr txBox="1"/>
+          <p:nvPr/>
+        </p:nvSpPr>
+        <p:spPr>
+          <a:xfrm>
+            <a:off x="6108192" y="3424012"/>
+            <a:ext cx="731520" cy="314221"/>
+          </a:xfrm>
+          <a:prstGeom prst="rect">
+            <a:avLst/>
+          </a:prstGeom>
+          <a:noFill/>
+          <a:ln/>
+        </p:spPr>
+        <p:txBody>
+          <a:bodyPr wrap="square" lIns="0" tIns="0" rIns="0" bIns="0" rtlCol="0" anchor="ctr"/>
+          <a:lstStyle/>
+          <a:p>
+            <a:pPr algn="r" indent="0" marL="0">
+              <a:buNone/>
+            </a:pPr>
+            <a:r>
+              <a:rPr lang="en-US" sz="1300" b="1" dirty="0">
+                <a:solidFill>
+                  <a:srgbClr val="0B7A4A"/>
+                </a:solidFill>
+                <a:latin typeface="Inter" pitchFamily="34" charset="0"/>
+                <a:ea typeface="Inter" pitchFamily="34" charset="-122"/>
+                <a:cs typeface="Inter" pitchFamily="34" charset="-120"/>
+              </a:rPr>
+              <a:t>54.2%</a:t>
+            </a:r>
+            <a:endParaRPr lang="en-US" sz="1300" dirty="0"/>
+          </a:p>
+        </p:txBody>
+      </p:sp>
+      <p:sp>
+        <p:nvSpPr>
+          <p:cNvPr id="75" name="Text 73"/>
+          <p:cNvSpPr txBox="1"/>
+          <p:nvPr/>
+        </p:nvSpPr>
+        <p:spPr>
+          <a:xfrm>
+            <a:off x="6858000" y="3424012"/>
+            <a:ext cx="914400" cy="314221"/>
+          </a:xfrm>
+          <a:prstGeom prst="rect">
+            <a:avLst/>
+          </a:prstGeom>
+          <a:noFill/>
+          <a:ln/>
+        </p:spPr>
+        <p:txBody>
+          <a:bodyPr wrap="square" lIns="0" tIns="0" rIns="0" bIns="0" rtlCol="0" anchor="ctr"/>
+          <a:lstStyle/>
+          <a:p>
+            <a:pPr algn="r" indent="0" marL="0">
+              <a:buNone/>
+            </a:pPr>
+            <a:r>
+              <a:rPr lang="en-US" sz="1200" dirty="0">
+                <a:solidFill>
+                  <a:srgbClr val="595959"/>
+                </a:solidFill>
+                <a:latin typeface="Inter" pitchFamily="34" charset="0"/>
+                <a:ea typeface="Inter" pitchFamily="34" charset="-122"/>
+                <a:cs typeface="Inter" pitchFamily="34" charset="-120"/>
+              </a:rPr>
+              <a:t>1,171</a:t>
+            </a:r>
+            <a:endParaRPr lang="en-US" sz="1200" dirty="0"/>
+          </a:p>
+        </p:txBody>
+      </p:sp>
+      <p:sp>
+        <p:nvSpPr>
+          <p:cNvPr id="76" name="Shape 74"/>
+          <p:cNvSpPr/>
+          <p:nvPr/>
+        </p:nvSpPr>
+        <p:spPr>
+          <a:xfrm>
+            <a:off x="4416552" y="4070743"/>
             <a:ext cx="3355848" cy="22860"/>
           </a:xfrm>
           <a:prstGeom prst="rect">
@@ -4331,13 +4491,13 @@
       </p:sp>
       <p:sp>
         <p:nvSpPr>
-          <p:cNvPr id="69" name="Text 67"/>
-          <p:cNvSpPr txBox="1"/>
-          <p:nvPr/>
-        </p:nvSpPr>
-        <p:spPr>
-          <a:xfrm>
-            <a:off x="4416552" y="3941064"/>
+          <p:cNvPr id="77" name="Text 75"/>
+          <p:cNvSpPr txBox="1"/>
+          <p:nvPr/>
+        </p:nvSpPr>
+        <p:spPr>
+          <a:xfrm>
+            <a:off x="4416552" y="4098175"/>
             <a:ext cx="1828800" cy="219456"/>
           </a:xfrm>
           <a:prstGeom prst="rect">
@@ -4370,13 +4530,13 @@
       </p:sp>
       <p:sp>
         <p:nvSpPr>
-          <p:cNvPr id="70" name="Text 68"/>
-          <p:cNvSpPr txBox="1"/>
-          <p:nvPr/>
-        </p:nvSpPr>
-        <p:spPr>
-          <a:xfrm>
-            <a:off x="6108192" y="3941064"/>
+          <p:cNvPr id="78" name="Text 76"/>
+          <p:cNvSpPr txBox="1"/>
+          <p:nvPr/>
+        </p:nvSpPr>
+        <p:spPr>
+          <a:xfrm>
+            <a:off x="6108192" y="4098175"/>
             <a:ext cx="731520" cy="219456"/>
           </a:xfrm>
           <a:prstGeom prst="rect">
@@ -4409,13 +4569,13 @@
       </p:sp>
       <p:sp>
         <p:nvSpPr>
-          <p:cNvPr id="71" name="Text 69"/>
-          <p:cNvSpPr txBox="1"/>
-          <p:nvPr/>
-        </p:nvSpPr>
-        <p:spPr>
-          <a:xfrm>
-            <a:off x="6858000" y="3941064"/>
+          <p:cNvPr id="79" name="Text 77"/>
+          <p:cNvSpPr txBox="1"/>
+          <p:nvPr/>
+        </p:nvSpPr>
+        <p:spPr>
+          <a:xfrm>
+            <a:off x="6858000" y="4098175"/>
             <a:ext cx="914400" cy="219456"/>
           </a:xfrm>
           <a:prstGeom prst="rect">
@@ -4448,14 +4608,14 @@
       </p:sp>
       <p:sp>
         <p:nvSpPr>
-          <p:cNvPr id="72" name="Text 70"/>
-          <p:cNvSpPr txBox="1"/>
-          <p:nvPr/>
-        </p:nvSpPr>
-        <p:spPr>
-          <a:xfrm>
-            <a:off x="4416552" y="4169664"/>
-            <a:ext cx="1673352" cy="345643"/>
+          <p:cNvPr id="80" name="Text 78"/>
+          <p:cNvSpPr txBox="1"/>
+          <p:nvPr/>
+        </p:nvSpPr>
+        <p:spPr>
+          <a:xfrm>
+            <a:off x="4416552" y="4326775"/>
+            <a:ext cx="1673352" cy="314221"/>
           </a:xfrm>
           <a:prstGeom prst="rect">
             <a:avLst/>
@@ -4487,14 +4647,14 @@
       </p:sp>
       <p:sp>
         <p:nvSpPr>
-          <p:cNvPr id="73" name="Text 71"/>
-          <p:cNvSpPr txBox="1"/>
-          <p:nvPr/>
-        </p:nvSpPr>
-        <p:spPr>
-          <a:xfrm>
-            <a:off x="6108192" y="4169664"/>
-            <a:ext cx="731520" cy="345643"/>
+          <p:cNvPr id="81" name="Text 79"/>
+          <p:cNvSpPr txBox="1"/>
+          <p:nvPr/>
+        </p:nvSpPr>
+        <p:spPr>
+          <a:xfrm>
+            <a:off x="6108192" y="4326775"/>
+            <a:ext cx="731520" cy="314221"/>
           </a:xfrm>
           <a:prstGeom prst="rect">
             <a:avLst/>
@@ -4526,14 +4686,14 @@
       </p:sp>
       <p:sp>
         <p:nvSpPr>
-          <p:cNvPr id="74" name="Text 72"/>
-          <p:cNvSpPr txBox="1"/>
-          <p:nvPr/>
-        </p:nvSpPr>
-        <p:spPr>
-          <a:xfrm>
-            <a:off x="6858000" y="4169664"/>
-            <a:ext cx="914400" cy="345643"/>
+          <p:cNvPr id="82" name="Text 80"/>
+          <p:cNvSpPr txBox="1"/>
+          <p:nvPr/>
+        </p:nvSpPr>
+        <p:spPr>
+          <a:xfrm>
+            <a:off x="6858000" y="4326775"/>
+            <a:ext cx="914400" cy="314221"/>
           </a:xfrm>
           <a:prstGeom prst="rect">
             <a:avLst/>
@@ -4565,14 +4725,14 @@
       </p:sp>
       <p:sp>
         <p:nvSpPr>
-          <p:cNvPr id="75" name="Text 73"/>
-          <p:cNvSpPr txBox="1"/>
-          <p:nvPr/>
-        </p:nvSpPr>
-        <p:spPr>
-          <a:xfrm>
-            <a:off x="4416552" y="4515307"/>
-            <a:ext cx="1673352" cy="345643"/>
+          <p:cNvPr id="83" name="Text 81"/>
+          <p:cNvSpPr txBox="1"/>
+          <p:nvPr/>
+        </p:nvSpPr>
+        <p:spPr>
+          <a:xfrm>
+            <a:off x="4416552" y="4640996"/>
+            <a:ext cx="1673352" cy="314221"/>
           </a:xfrm>
           <a:prstGeom prst="rect">
             <a:avLst/>
@@ -4604,14 +4764,14 @@
       </p:sp>
       <p:sp>
         <p:nvSpPr>
-          <p:cNvPr id="76" name="Text 74"/>
-          <p:cNvSpPr txBox="1"/>
-          <p:nvPr/>
-        </p:nvSpPr>
-        <p:spPr>
-          <a:xfrm>
-            <a:off x="6108192" y="4515307"/>
-            <a:ext cx="731520" cy="345643"/>
+          <p:cNvPr id="84" name="Text 82"/>
+          <p:cNvSpPr txBox="1"/>
+          <p:nvPr/>
+        </p:nvSpPr>
+        <p:spPr>
+          <a:xfrm>
+            <a:off x="6108192" y="4640996"/>
+            <a:ext cx="731520" cy="314221"/>
           </a:xfrm>
           <a:prstGeom prst="rect">
             <a:avLst/>
@@ -4643,14 +4803,14 @@
       </p:sp>
       <p:sp>
         <p:nvSpPr>
-          <p:cNvPr id="77" name="Text 75"/>
-          <p:cNvSpPr txBox="1"/>
-          <p:nvPr/>
-        </p:nvSpPr>
-        <p:spPr>
-          <a:xfrm>
-            <a:off x="6858000" y="4515307"/>
-            <a:ext cx="914400" cy="345643"/>
+          <p:cNvPr id="85" name="Text 83"/>
+          <p:cNvSpPr txBox="1"/>
+          <p:nvPr/>
+        </p:nvSpPr>
+        <p:spPr>
+          <a:xfrm>
+            <a:off x="6858000" y="4640996"/>
+            <a:ext cx="914400" cy="314221"/>
           </a:xfrm>
           <a:prstGeom prst="rect">
             <a:avLst/>
@@ -4682,14 +4842,14 @@
       </p:sp>
       <p:sp>
         <p:nvSpPr>
-          <p:cNvPr id="78" name="Text 76"/>
-          <p:cNvSpPr txBox="1"/>
-          <p:nvPr/>
-        </p:nvSpPr>
-        <p:spPr>
-          <a:xfrm>
-            <a:off x="4416552" y="4860950"/>
-            <a:ext cx="1673352" cy="345643"/>
+          <p:cNvPr id="86" name="Text 84"/>
+          <p:cNvSpPr txBox="1"/>
+          <p:nvPr/>
+        </p:nvSpPr>
+        <p:spPr>
+          <a:xfrm>
+            <a:off x="4416552" y="4955217"/>
+            <a:ext cx="1673352" cy="314221"/>
           </a:xfrm>
           <a:prstGeom prst="rect">
             <a:avLst/>
@@ -4721,14 +4881,14 @@
       </p:sp>
       <p:sp>
         <p:nvSpPr>
-          <p:cNvPr id="79" name="Text 77"/>
-          <p:cNvSpPr txBox="1"/>
-          <p:nvPr/>
-        </p:nvSpPr>
-        <p:spPr>
-          <a:xfrm>
-            <a:off x="6108192" y="4860950"/>
-            <a:ext cx="731520" cy="345643"/>
+          <p:cNvPr id="87" name="Text 85"/>
+          <p:cNvSpPr txBox="1"/>
+          <p:nvPr/>
+        </p:nvSpPr>
+        <p:spPr>
+          <a:xfrm>
+            <a:off x="6108192" y="4955217"/>
+            <a:ext cx="731520" cy="314221"/>
           </a:xfrm>
           <a:prstGeom prst="rect">
             <a:avLst/>
@@ -4760,14 +4920,14 @@
       </p:sp>
       <p:sp>
         <p:nvSpPr>
-          <p:cNvPr id="80" name="Text 78"/>
-          <p:cNvSpPr txBox="1"/>
-          <p:nvPr/>
-        </p:nvSpPr>
-        <p:spPr>
-          <a:xfrm>
-            <a:off x="6858000" y="4860950"/>
-            <a:ext cx="914400" cy="345643"/>
+          <p:cNvPr id="88" name="Text 86"/>
+          <p:cNvSpPr txBox="1"/>
+          <p:nvPr/>
+        </p:nvSpPr>
+        <p:spPr>
+          <a:xfrm>
+            <a:off x="6858000" y="4955217"/>
+            <a:ext cx="914400" cy="314221"/>
           </a:xfrm>
           <a:prstGeom prst="rect">
             <a:avLst/>
@@ -4799,14 +4959,14 @@
       </p:sp>
       <p:sp>
         <p:nvSpPr>
-          <p:cNvPr id="81" name="Text 79"/>
-          <p:cNvSpPr txBox="1"/>
-          <p:nvPr/>
-        </p:nvSpPr>
-        <p:spPr>
-          <a:xfrm>
-            <a:off x="4416552" y="5206594"/>
-            <a:ext cx="1673352" cy="345643"/>
+          <p:cNvPr id="89" name="Text 87"/>
+          <p:cNvSpPr txBox="1"/>
+          <p:nvPr/>
+        </p:nvSpPr>
+        <p:spPr>
+          <a:xfrm>
+            <a:off x="4416552" y="5269438"/>
+            <a:ext cx="1673352" cy="314221"/>
           </a:xfrm>
           <a:prstGeom prst="rect">
             <a:avLst/>
@@ -4838,14 +4998,14 @@
       </p:sp>
       <p:sp>
         <p:nvSpPr>
-          <p:cNvPr id="82" name="Text 80"/>
-          <p:cNvSpPr txBox="1"/>
-          <p:nvPr/>
-        </p:nvSpPr>
-        <p:spPr>
-          <a:xfrm>
-            <a:off x="6108192" y="5206594"/>
-            <a:ext cx="731520" cy="345643"/>
+          <p:cNvPr id="90" name="Text 88"/>
+          <p:cNvSpPr txBox="1"/>
+          <p:nvPr/>
+        </p:nvSpPr>
+        <p:spPr>
+          <a:xfrm>
+            <a:off x="6108192" y="5269438"/>
+            <a:ext cx="731520" cy="314221"/>
           </a:xfrm>
           <a:prstGeom prst="rect">
             <a:avLst/>
@@ -4877,14 +5037,14 @@
       </p:sp>
       <p:sp>
         <p:nvSpPr>
-          <p:cNvPr id="83" name="Text 81"/>
-          <p:cNvSpPr txBox="1"/>
-          <p:nvPr/>
-        </p:nvSpPr>
-        <p:spPr>
-          <a:xfrm>
-            <a:off x="6858000" y="5206594"/>
-            <a:ext cx="914400" cy="345643"/>
+          <p:cNvPr id="91" name="Text 89"/>
+          <p:cNvSpPr txBox="1"/>
+          <p:nvPr/>
+        </p:nvSpPr>
+        <p:spPr>
+          <a:xfrm>
+            <a:off x="6858000" y="5269438"/>
+            <a:ext cx="914400" cy="314221"/>
           </a:xfrm>
           <a:prstGeom prst="rect">
             <a:avLst/>
@@ -4916,14 +5076,14 @@
       </p:sp>
       <p:sp>
         <p:nvSpPr>
-          <p:cNvPr id="84" name="Text 82"/>
-          <p:cNvSpPr txBox="1"/>
-          <p:nvPr/>
-        </p:nvSpPr>
-        <p:spPr>
-          <a:xfrm>
-            <a:off x="4416552" y="5552237"/>
-            <a:ext cx="1673352" cy="345643"/>
+          <p:cNvPr id="92" name="Text 90"/>
+          <p:cNvSpPr txBox="1"/>
+          <p:nvPr/>
+        </p:nvSpPr>
+        <p:spPr>
+          <a:xfrm>
+            <a:off x="4416552" y="5583659"/>
+            <a:ext cx="1673352" cy="314221"/>
           </a:xfrm>
           <a:prstGeom prst="rect">
             <a:avLst/>
@@ -4955,14 +5115,14 @@
       </p:sp>
       <p:sp>
         <p:nvSpPr>
-          <p:cNvPr id="85" name="Text 83"/>
-          <p:cNvSpPr txBox="1"/>
-          <p:nvPr/>
-        </p:nvSpPr>
-        <p:spPr>
-          <a:xfrm>
-            <a:off x="6108192" y="5552237"/>
-            <a:ext cx="731520" cy="345643"/>
+          <p:cNvPr id="93" name="Text 91"/>
+          <p:cNvSpPr txBox="1"/>
+          <p:nvPr/>
+        </p:nvSpPr>
+        <p:spPr>
+          <a:xfrm>
+            <a:off x="6108192" y="5583659"/>
+            <a:ext cx="731520" cy="314221"/>
           </a:xfrm>
           <a:prstGeom prst="rect">
             <a:avLst/>
@@ -4994,14 +5154,14 @@
       </p:sp>
       <p:sp>
         <p:nvSpPr>
-          <p:cNvPr id="86" name="Text 84"/>
-          <p:cNvSpPr txBox="1"/>
-          <p:nvPr/>
-        </p:nvSpPr>
-        <p:spPr>
-          <a:xfrm>
-            <a:off x="6858000" y="5552237"/>
-            <a:ext cx="914400" cy="345643"/>
+          <p:cNvPr id="94" name="Text 92"/>
+          <p:cNvSpPr txBox="1"/>
+          <p:nvPr/>
+        </p:nvSpPr>
+        <p:spPr>
+          <a:xfrm>
+            <a:off x="6858000" y="5583659"/>
+            <a:ext cx="914400" cy="314221"/>
           </a:xfrm>
           <a:prstGeom prst="rect">
             <a:avLst/>
@@ -5033,7 +5193,7 @@
       </p:sp>
       <p:sp>
         <p:nvSpPr>
-          <p:cNvPr id="87" name="Shape 85"/>
+          <p:cNvPr id="95" name="Shape 93"/>
           <p:cNvSpPr/>
           <p:nvPr/>
         </p:nvSpPr>
@@ -5053,7 +5213,7 @@
       </p:sp>
       <p:sp>
         <p:nvSpPr>
-          <p:cNvPr id="88" name="Text 86"/>
+          <p:cNvPr id="96" name="Text 94"/>
           <p:cNvSpPr txBox="1"/>
           <p:nvPr/>
         </p:nvSpPr>
@@ -5092,7 +5252,7 @@
       </p:sp>
       <p:sp>
         <p:nvSpPr>
-          <p:cNvPr id="89" name="Text 87"/>
+          <p:cNvPr id="97" name="Text 95"/>
           <p:cNvSpPr txBox="1"/>
           <p:nvPr/>
         </p:nvSpPr>
@@ -5131,7 +5291,7 @@
       </p:sp>
       <p:sp>
         <p:nvSpPr>
-          <p:cNvPr id="90" name="Shape 88"/>
+          <p:cNvPr id="98" name="Shape 96"/>
           <p:cNvSpPr/>
           <p:nvPr/>
         </p:nvSpPr>
@@ -5151,7 +5311,7 @@
       </p:sp>
       <p:sp>
         <p:nvSpPr>
-          <p:cNvPr id="91" name="Text 89"/>
+          <p:cNvPr id="99" name="Text 97"/>
           <p:cNvSpPr txBox="1"/>
           <p:nvPr/>
         </p:nvSpPr>
@@ -5182,7 +5342,7 @@
                 <a:ea typeface="Inter" pitchFamily="34" charset="-122"/>
                 <a:cs typeface="Inter" pitchFamily="34" charset="-120"/>
               </a:rPr>
-              <a:t>TOP 5</a:t>
+              <a:t>AT 100% (6)</a:t>
             </a:r>
             <a:endParaRPr lang="en-US" sz="1400" dirty="0"/>
           </a:p>
@@ -5190,7 +5350,7 @@
       </p:sp>
       <p:sp>
         <p:nvSpPr>
-          <p:cNvPr id="92" name="Text 90"/>
+          <p:cNvPr id="100" name="Text 98"/>
           <p:cNvSpPr txBox="1"/>
           <p:nvPr/>
         </p:nvSpPr>
@@ -5229,7 +5389,7 @@
       </p:sp>
       <p:sp>
         <p:nvSpPr>
-          <p:cNvPr id="93" name="Text 91"/>
+          <p:cNvPr id="101" name="Text 99"/>
           <p:cNvSpPr txBox="1"/>
           <p:nvPr/>
         </p:nvSpPr>
@@ -5268,14 +5428,14 @@
       </p:sp>
       <p:sp>
         <p:nvSpPr>
-          <p:cNvPr id="94" name="Text 92"/>
+          <p:cNvPr id="102" name="Text 100"/>
           <p:cNvSpPr txBox="1"/>
           <p:nvPr/>
         </p:nvSpPr>
         <p:spPr>
           <a:xfrm>
             <a:off x="8211312" y="2167128"/>
-            <a:ext cx="1673352" cy="345643"/>
+            <a:ext cx="1673352" cy="314221"/>
           </a:xfrm>
           <a:prstGeom prst="rect">
             <a:avLst/>
@@ -5307,14 +5467,14 @@
       </p:sp>
       <p:sp>
         <p:nvSpPr>
-          <p:cNvPr id="95" name="Text 93"/>
+          <p:cNvPr id="103" name="Text 101"/>
           <p:cNvSpPr txBox="1"/>
           <p:nvPr/>
         </p:nvSpPr>
         <p:spPr>
           <a:xfrm>
             <a:off x="9902952" y="2167128"/>
-            <a:ext cx="731520" cy="345643"/>
+            <a:ext cx="731520" cy="314221"/>
           </a:xfrm>
           <a:prstGeom prst="rect">
             <a:avLst/>
@@ -5346,14 +5506,14 @@
       </p:sp>
       <p:sp>
         <p:nvSpPr>
-          <p:cNvPr id="96" name="Text 94"/>
+          <p:cNvPr id="104" name="Text 102"/>
           <p:cNvSpPr txBox="1"/>
           <p:nvPr/>
         </p:nvSpPr>
         <p:spPr>
           <a:xfrm>
             <a:off x="10652760" y="2167128"/>
-            <a:ext cx="914400" cy="345643"/>
+            <a:ext cx="914400" cy="314221"/>
           </a:xfrm>
           <a:prstGeom prst="rect">
             <a:avLst/>
@@ -5385,14 +5545,14 @@
       </p:sp>
       <p:sp>
         <p:nvSpPr>
-          <p:cNvPr id="97" name="Text 95"/>
-          <p:cNvSpPr txBox="1"/>
-          <p:nvPr/>
-        </p:nvSpPr>
-        <p:spPr>
-          <a:xfrm>
-            <a:off x="8211312" y="2512771"/>
-            <a:ext cx="1673352" cy="345643"/>
+          <p:cNvPr id="105" name="Text 103"/>
+          <p:cNvSpPr txBox="1"/>
+          <p:nvPr/>
+        </p:nvSpPr>
+        <p:spPr>
+          <a:xfrm>
+            <a:off x="8211312" y="2481349"/>
+            <a:ext cx="1673352" cy="314221"/>
           </a:xfrm>
           <a:prstGeom prst="rect">
             <a:avLst/>
@@ -5424,14 +5584,14 @@
       </p:sp>
       <p:sp>
         <p:nvSpPr>
-          <p:cNvPr id="98" name="Text 96"/>
-          <p:cNvSpPr txBox="1"/>
-          <p:nvPr/>
-        </p:nvSpPr>
-        <p:spPr>
-          <a:xfrm>
-            <a:off x="9902952" y="2512771"/>
-            <a:ext cx="731520" cy="345643"/>
+          <p:cNvPr id="106" name="Text 104"/>
+          <p:cNvSpPr txBox="1"/>
+          <p:nvPr/>
+        </p:nvSpPr>
+        <p:spPr>
+          <a:xfrm>
+            <a:off x="9902952" y="2481349"/>
+            <a:ext cx="731520" cy="314221"/>
           </a:xfrm>
           <a:prstGeom prst="rect">
             <a:avLst/>
@@ -5463,14 +5623,14 @@
       </p:sp>
       <p:sp>
         <p:nvSpPr>
-          <p:cNvPr id="99" name="Text 97"/>
-          <p:cNvSpPr txBox="1"/>
-          <p:nvPr/>
-        </p:nvSpPr>
-        <p:spPr>
-          <a:xfrm>
-            <a:off x="10652760" y="2512771"/>
-            <a:ext cx="914400" cy="345643"/>
+          <p:cNvPr id="107" name="Text 105"/>
+          <p:cNvSpPr txBox="1"/>
+          <p:nvPr/>
+        </p:nvSpPr>
+        <p:spPr>
+          <a:xfrm>
+            <a:off x="10652760" y="2481349"/>
+            <a:ext cx="914400" cy="314221"/>
           </a:xfrm>
           <a:prstGeom prst="rect">
             <a:avLst/>
@@ -5502,14 +5662,14 @@
       </p:sp>
       <p:sp>
         <p:nvSpPr>
-          <p:cNvPr id="100" name="Text 98"/>
-          <p:cNvSpPr txBox="1"/>
-          <p:nvPr/>
-        </p:nvSpPr>
-        <p:spPr>
-          <a:xfrm>
-            <a:off x="8211312" y="2858414"/>
-            <a:ext cx="1673352" cy="345643"/>
+          <p:cNvPr id="108" name="Text 106"/>
+          <p:cNvSpPr txBox="1"/>
+          <p:nvPr/>
+        </p:nvSpPr>
+        <p:spPr>
+          <a:xfrm>
+            <a:off x="8211312" y="2795570"/>
+            <a:ext cx="1673352" cy="314221"/>
           </a:xfrm>
           <a:prstGeom prst="rect">
             <a:avLst/>
@@ -5541,14 +5701,14 @@
       </p:sp>
       <p:sp>
         <p:nvSpPr>
-          <p:cNvPr id="101" name="Text 99"/>
-          <p:cNvSpPr txBox="1"/>
-          <p:nvPr/>
-        </p:nvSpPr>
-        <p:spPr>
-          <a:xfrm>
-            <a:off x="9902952" y="2858414"/>
-            <a:ext cx="731520" cy="345643"/>
+          <p:cNvPr id="109" name="Text 107"/>
+          <p:cNvSpPr txBox="1"/>
+          <p:nvPr/>
+        </p:nvSpPr>
+        <p:spPr>
+          <a:xfrm>
+            <a:off x="9902952" y="2795570"/>
+            <a:ext cx="731520" cy="314221"/>
           </a:xfrm>
           <a:prstGeom prst="rect">
             <a:avLst/>
@@ -5580,14 +5740,14 @@
       </p:sp>
       <p:sp>
         <p:nvSpPr>
-          <p:cNvPr id="102" name="Text 100"/>
-          <p:cNvSpPr txBox="1"/>
-          <p:nvPr/>
-        </p:nvSpPr>
-        <p:spPr>
-          <a:xfrm>
-            <a:off x="10652760" y="2858414"/>
-            <a:ext cx="914400" cy="345643"/>
+          <p:cNvPr id="110" name="Text 108"/>
+          <p:cNvSpPr txBox="1"/>
+          <p:nvPr/>
+        </p:nvSpPr>
+        <p:spPr>
+          <a:xfrm>
+            <a:off x="10652760" y="2795570"/>
+            <a:ext cx="914400" cy="314221"/>
           </a:xfrm>
           <a:prstGeom prst="rect">
             <a:avLst/>
@@ -5619,14 +5779,14 @@
       </p:sp>
       <p:sp>
         <p:nvSpPr>
-          <p:cNvPr id="103" name="Text 101"/>
-          <p:cNvSpPr txBox="1"/>
-          <p:nvPr/>
-        </p:nvSpPr>
-        <p:spPr>
-          <a:xfrm>
-            <a:off x="8211312" y="3204058"/>
-            <a:ext cx="1673352" cy="345643"/>
+          <p:cNvPr id="111" name="Text 109"/>
+          <p:cNvSpPr txBox="1"/>
+          <p:nvPr/>
+        </p:nvSpPr>
+        <p:spPr>
+          <a:xfrm>
+            <a:off x="8211312" y="3109791"/>
+            <a:ext cx="1673352" cy="314221"/>
           </a:xfrm>
           <a:prstGeom prst="rect">
             <a:avLst/>
@@ -5658,14 +5818,14 @@
       </p:sp>
       <p:sp>
         <p:nvSpPr>
-          <p:cNvPr id="104" name="Text 102"/>
-          <p:cNvSpPr txBox="1"/>
-          <p:nvPr/>
-        </p:nvSpPr>
-        <p:spPr>
-          <a:xfrm>
-            <a:off x="9902952" y="3204058"/>
-            <a:ext cx="731520" cy="345643"/>
+          <p:cNvPr id="112" name="Text 110"/>
+          <p:cNvSpPr txBox="1"/>
+          <p:nvPr/>
+        </p:nvSpPr>
+        <p:spPr>
+          <a:xfrm>
+            <a:off x="9902952" y="3109791"/>
+            <a:ext cx="731520" cy="314221"/>
           </a:xfrm>
           <a:prstGeom prst="rect">
             <a:avLst/>
@@ -5697,14 +5857,14 @@
       </p:sp>
       <p:sp>
         <p:nvSpPr>
-          <p:cNvPr id="105" name="Text 103"/>
-          <p:cNvSpPr txBox="1"/>
-          <p:nvPr/>
-        </p:nvSpPr>
-        <p:spPr>
-          <a:xfrm>
-            <a:off x="10652760" y="3204058"/>
-            <a:ext cx="914400" cy="345643"/>
+          <p:cNvPr id="113" name="Text 111"/>
+          <p:cNvSpPr txBox="1"/>
+          <p:nvPr/>
+        </p:nvSpPr>
+        <p:spPr>
+          <a:xfrm>
+            <a:off x="10652760" y="3109791"/>
+            <a:ext cx="914400" cy="314221"/>
           </a:xfrm>
           <a:prstGeom prst="rect">
             <a:avLst/>
@@ -5736,14 +5896,14 @@
       </p:sp>
       <p:sp>
         <p:nvSpPr>
-          <p:cNvPr id="106" name="Text 104"/>
-          <p:cNvSpPr txBox="1"/>
-          <p:nvPr/>
-        </p:nvSpPr>
-        <p:spPr>
-          <a:xfrm>
-            <a:off x="8211312" y="3549701"/>
-            <a:ext cx="1673352" cy="345643"/>
+          <p:cNvPr id="114" name="Text 112"/>
+          <p:cNvSpPr txBox="1"/>
+          <p:nvPr/>
+        </p:nvSpPr>
+        <p:spPr>
+          <a:xfrm>
+            <a:off x="8211312" y="3424012"/>
+            <a:ext cx="1673352" cy="314221"/>
           </a:xfrm>
           <a:prstGeom prst="rect">
             <a:avLst/>
@@ -5775,14 +5935,14 @@
       </p:sp>
       <p:sp>
         <p:nvSpPr>
-          <p:cNvPr id="107" name="Text 105"/>
-          <p:cNvSpPr txBox="1"/>
-          <p:nvPr/>
-        </p:nvSpPr>
-        <p:spPr>
-          <a:xfrm>
-            <a:off x="9902952" y="3549701"/>
-            <a:ext cx="731520" cy="345643"/>
+          <p:cNvPr id="115" name="Text 113"/>
+          <p:cNvSpPr txBox="1"/>
+          <p:nvPr/>
+        </p:nvSpPr>
+        <p:spPr>
+          <a:xfrm>
+            <a:off x="9902952" y="3424012"/>
+            <a:ext cx="731520" cy="314221"/>
           </a:xfrm>
           <a:prstGeom prst="rect">
             <a:avLst/>
@@ -5814,14 +5974,14 @@
       </p:sp>
       <p:sp>
         <p:nvSpPr>
-          <p:cNvPr id="108" name="Text 106"/>
-          <p:cNvSpPr txBox="1"/>
-          <p:nvPr/>
-        </p:nvSpPr>
-        <p:spPr>
-          <a:xfrm>
-            <a:off x="10652760" y="3549701"/>
-            <a:ext cx="914400" cy="345643"/>
+          <p:cNvPr id="116" name="Text 114"/>
+          <p:cNvSpPr txBox="1"/>
+          <p:nvPr/>
+        </p:nvSpPr>
+        <p:spPr>
+          <a:xfrm>
+            <a:off x="10652760" y="3424012"/>
+            <a:ext cx="914400" cy="314221"/>
           </a:xfrm>
           <a:prstGeom prst="rect">
             <a:avLst/>
@@ -5853,13 +6013,130 @@
       </p:sp>
       <p:sp>
         <p:nvSpPr>
-          <p:cNvPr id="109" name="Shape 107"/>
+          <p:cNvPr id="117" name="Text 115"/>
+          <p:cNvSpPr txBox="1"/>
+          <p:nvPr/>
+        </p:nvSpPr>
+        <p:spPr>
+          <a:xfrm>
+            <a:off x="8211312" y="3738233"/>
+            <a:ext cx="1673352" cy="314221"/>
+          </a:xfrm>
+          <a:prstGeom prst="rect">
+            <a:avLst/>
+          </a:prstGeom>
+          <a:noFill/>
+          <a:ln/>
+        </p:spPr>
+        <p:txBody>
+          <a:bodyPr wrap="square" lIns="0" tIns="0" rIns="0" bIns="0" rtlCol="0" anchor="ctr"/>
+          <a:lstStyle/>
+          <a:p>
+            <a:pPr indent="0" marL="0">
+              <a:buNone/>
+            </a:pPr>
+            <a:r>
+              <a:rPr lang="en-US" sz="1300" dirty="0">
+                <a:solidFill>
+                  <a:srgbClr val="1A1A1A"/>
+                </a:solidFill>
+                <a:latin typeface="Inter" pitchFamily="34" charset="0"/>
+                <a:ea typeface="Inter" pitchFamily="34" charset="-122"/>
+                <a:cs typeface="Inter" pitchFamily="34" charset="-120"/>
+              </a:rPr>
+              <a:t>Acura</a:t>
+            </a:r>
+            <a:endParaRPr lang="en-US" sz="1300" dirty="0"/>
+          </a:p>
+        </p:txBody>
+      </p:sp>
+      <p:sp>
+        <p:nvSpPr>
+          <p:cNvPr id="118" name="Text 116"/>
+          <p:cNvSpPr txBox="1"/>
+          <p:nvPr/>
+        </p:nvSpPr>
+        <p:spPr>
+          <a:xfrm>
+            <a:off x="9902952" y="3738233"/>
+            <a:ext cx="731520" cy="314221"/>
+          </a:xfrm>
+          <a:prstGeom prst="rect">
+            <a:avLst/>
+          </a:prstGeom>
+          <a:noFill/>
+          <a:ln/>
+        </p:spPr>
+        <p:txBody>
+          <a:bodyPr wrap="square" lIns="0" tIns="0" rIns="0" bIns="0" rtlCol="0" anchor="ctr"/>
+          <a:lstStyle/>
+          <a:p>
+            <a:pPr algn="r" indent="0" marL="0">
+              <a:buNone/>
+            </a:pPr>
+            <a:r>
+              <a:rPr lang="en-US" sz="1300" b="1" dirty="0">
+                <a:solidFill>
+                  <a:srgbClr val="0B7A4A"/>
+                </a:solidFill>
+                <a:latin typeface="Inter" pitchFamily="34" charset="0"/>
+                <a:ea typeface="Inter" pitchFamily="34" charset="-122"/>
+                <a:cs typeface="Inter" pitchFamily="34" charset="-120"/>
+              </a:rPr>
+              <a:t>100.0%</a:t>
+            </a:r>
+            <a:endParaRPr lang="en-US" sz="1300" dirty="0"/>
+          </a:p>
+        </p:txBody>
+      </p:sp>
+      <p:sp>
+        <p:nvSpPr>
+          <p:cNvPr id="119" name="Text 117"/>
+          <p:cNvSpPr txBox="1"/>
+          <p:nvPr/>
+        </p:nvSpPr>
+        <p:spPr>
+          <a:xfrm>
+            <a:off x="10652760" y="3738233"/>
+            <a:ext cx="914400" cy="314221"/>
+          </a:xfrm>
+          <a:prstGeom prst="rect">
+            <a:avLst/>
+          </a:prstGeom>
+          <a:noFill/>
+          <a:ln/>
+        </p:spPr>
+        <p:txBody>
+          <a:bodyPr wrap="square" lIns="0" tIns="0" rIns="0" bIns="0" rtlCol="0" anchor="ctr"/>
+          <a:lstStyle/>
+          <a:p>
+            <a:pPr algn="r" indent="0" marL="0">
+              <a:buNone/>
+            </a:pPr>
+            <a:r>
+              <a:rPr lang="en-US" sz="1200" dirty="0">
+                <a:solidFill>
+                  <a:srgbClr val="595959"/>
+                </a:solidFill>
+                <a:latin typeface="Inter" pitchFamily="34" charset="0"/>
+                <a:ea typeface="Inter" pitchFamily="34" charset="-122"/>
+                <a:cs typeface="Inter" pitchFamily="34" charset="-120"/>
+              </a:rPr>
+              <a:t>0</a:t>
+            </a:r>
+            <a:endParaRPr lang="en-US" sz="1200" dirty="0"/>
+          </a:p>
+        </p:txBody>
+      </p:sp>
+      <p:sp>
+        <p:nvSpPr>
+          <p:cNvPr id="120" name="Shape 118"/>
           <p:cNvSpPr/>
           <p:nvPr/>
         </p:nvSpPr>
         <p:spPr>
           <a:xfrm>
-            <a:off x="8211312" y="3913632"/>
+            <a:off x="8211312" y="4070743"/>
             <a:ext cx="3355848" cy="22860"/>
           </a:xfrm>
           <a:prstGeom prst="rect">
@@ -5873,13 +6150,13 @@
       </p:sp>
       <p:sp>
         <p:nvSpPr>
-          <p:cNvPr id="110" name="Text 108"/>
-          <p:cNvSpPr txBox="1"/>
-          <p:nvPr/>
-        </p:nvSpPr>
-        <p:spPr>
-          <a:xfrm>
-            <a:off x="8211312" y="3941064"/>
+          <p:cNvPr id="121" name="Text 119"/>
+          <p:cNvSpPr txBox="1"/>
+          <p:nvPr/>
+        </p:nvSpPr>
+        <p:spPr>
+          <a:xfrm>
+            <a:off x="8211312" y="4098175"/>
             <a:ext cx="1828800" cy="219456"/>
           </a:xfrm>
           <a:prstGeom prst="rect">
@@ -5912,13 +6189,13 @@
       </p:sp>
       <p:sp>
         <p:nvSpPr>
-          <p:cNvPr id="111" name="Text 109"/>
-          <p:cNvSpPr txBox="1"/>
-          <p:nvPr/>
-        </p:nvSpPr>
-        <p:spPr>
-          <a:xfrm>
-            <a:off x="9902952" y="3941064"/>
+          <p:cNvPr id="122" name="Text 120"/>
+          <p:cNvSpPr txBox="1"/>
+          <p:nvPr/>
+        </p:nvSpPr>
+        <p:spPr>
+          <a:xfrm>
+            <a:off x="9902952" y="4098175"/>
             <a:ext cx="731520" cy="219456"/>
           </a:xfrm>
           <a:prstGeom prst="rect">
@@ -5951,13 +6228,13 @@
       </p:sp>
       <p:sp>
         <p:nvSpPr>
-          <p:cNvPr id="112" name="Text 110"/>
-          <p:cNvSpPr txBox="1"/>
-          <p:nvPr/>
-        </p:nvSpPr>
-        <p:spPr>
-          <a:xfrm>
-            <a:off x="10652760" y="3941064"/>
+          <p:cNvPr id="123" name="Text 121"/>
+          <p:cNvSpPr txBox="1"/>
+          <p:nvPr/>
+        </p:nvSpPr>
+        <p:spPr>
+          <a:xfrm>
+            <a:off x="10652760" y="4098175"/>
             <a:ext cx="914400" cy="219456"/>
           </a:xfrm>
           <a:prstGeom prst="rect">
@@ -5990,14 +6267,14 @@
       </p:sp>
       <p:sp>
         <p:nvSpPr>
-          <p:cNvPr id="113" name="Text 111"/>
-          <p:cNvSpPr txBox="1"/>
-          <p:nvPr/>
-        </p:nvSpPr>
-        <p:spPr>
-          <a:xfrm>
-            <a:off x="8211312" y="4169664"/>
-            <a:ext cx="1673352" cy="345643"/>
+          <p:cNvPr id="124" name="Text 122"/>
+          <p:cNvSpPr txBox="1"/>
+          <p:nvPr/>
+        </p:nvSpPr>
+        <p:spPr>
+          <a:xfrm>
+            <a:off x="8211312" y="4326775"/>
+            <a:ext cx="1673352" cy="314221"/>
           </a:xfrm>
           <a:prstGeom prst="rect">
             <a:avLst/>
@@ -6029,14 +6306,14 @@
       </p:sp>
       <p:sp>
         <p:nvSpPr>
-          <p:cNvPr id="114" name="Text 112"/>
-          <p:cNvSpPr txBox="1"/>
-          <p:nvPr/>
-        </p:nvSpPr>
-        <p:spPr>
-          <a:xfrm>
-            <a:off x="9902952" y="4169664"/>
-            <a:ext cx="731520" cy="345643"/>
+          <p:cNvPr id="125" name="Text 123"/>
+          <p:cNvSpPr txBox="1"/>
+          <p:nvPr/>
+        </p:nvSpPr>
+        <p:spPr>
+          <a:xfrm>
+            <a:off x="9902952" y="4326775"/>
+            <a:ext cx="731520" cy="314221"/>
           </a:xfrm>
           <a:prstGeom prst="rect">
             <a:avLst/>
@@ -6068,14 +6345,14 @@
       </p:sp>
       <p:sp>
         <p:nvSpPr>
-          <p:cNvPr id="115" name="Text 113"/>
-          <p:cNvSpPr txBox="1"/>
-          <p:nvPr/>
-        </p:nvSpPr>
-        <p:spPr>
-          <a:xfrm>
-            <a:off x="10652760" y="4169664"/>
-            <a:ext cx="914400" cy="345643"/>
+          <p:cNvPr id="126" name="Text 124"/>
+          <p:cNvSpPr txBox="1"/>
+          <p:nvPr/>
+        </p:nvSpPr>
+        <p:spPr>
+          <a:xfrm>
+            <a:off x="10652760" y="4326775"/>
+            <a:ext cx="914400" cy="314221"/>
           </a:xfrm>
           <a:prstGeom prst="rect">
             <a:avLst/>
@@ -6107,14 +6384,14 @@
       </p:sp>
       <p:sp>
         <p:nvSpPr>
-          <p:cNvPr id="116" name="Text 114"/>
-          <p:cNvSpPr txBox="1"/>
-          <p:nvPr/>
-        </p:nvSpPr>
-        <p:spPr>
-          <a:xfrm>
-            <a:off x="8211312" y="4515307"/>
-            <a:ext cx="1673352" cy="345643"/>
+          <p:cNvPr id="127" name="Text 125"/>
+          <p:cNvSpPr txBox="1"/>
+          <p:nvPr/>
+        </p:nvSpPr>
+        <p:spPr>
+          <a:xfrm>
+            <a:off x="8211312" y="4640996"/>
+            <a:ext cx="1673352" cy="314221"/>
           </a:xfrm>
           <a:prstGeom prst="rect">
             <a:avLst/>
@@ -6146,14 +6423,14 @@
       </p:sp>
       <p:sp>
         <p:nvSpPr>
-          <p:cNvPr id="117" name="Text 115"/>
-          <p:cNvSpPr txBox="1"/>
-          <p:nvPr/>
-        </p:nvSpPr>
-        <p:spPr>
-          <a:xfrm>
-            <a:off x="9902952" y="4515307"/>
-            <a:ext cx="731520" cy="345643"/>
+          <p:cNvPr id="128" name="Text 126"/>
+          <p:cNvSpPr txBox="1"/>
+          <p:nvPr/>
+        </p:nvSpPr>
+        <p:spPr>
+          <a:xfrm>
+            <a:off x="9902952" y="4640996"/>
+            <a:ext cx="731520" cy="314221"/>
           </a:xfrm>
           <a:prstGeom prst="rect">
             <a:avLst/>
@@ -6185,14 +6462,14 @@
       </p:sp>
       <p:sp>
         <p:nvSpPr>
-          <p:cNvPr id="118" name="Text 116"/>
-          <p:cNvSpPr txBox="1"/>
-          <p:nvPr/>
-        </p:nvSpPr>
-        <p:spPr>
-          <a:xfrm>
-            <a:off x="10652760" y="4515307"/>
-            <a:ext cx="914400" cy="345643"/>
+          <p:cNvPr id="129" name="Text 127"/>
+          <p:cNvSpPr txBox="1"/>
+          <p:nvPr/>
+        </p:nvSpPr>
+        <p:spPr>
+          <a:xfrm>
+            <a:off x="10652760" y="4640996"/>
+            <a:ext cx="914400" cy="314221"/>
           </a:xfrm>
           <a:prstGeom prst="rect">
             <a:avLst/>
@@ -6224,14 +6501,14 @@
       </p:sp>
       <p:sp>
         <p:nvSpPr>
-          <p:cNvPr id="119" name="Text 117"/>
-          <p:cNvSpPr txBox="1"/>
-          <p:nvPr/>
-        </p:nvSpPr>
-        <p:spPr>
-          <a:xfrm>
-            <a:off x="8211312" y="4860950"/>
-            <a:ext cx="1673352" cy="345643"/>
+          <p:cNvPr id="130" name="Text 128"/>
+          <p:cNvSpPr txBox="1"/>
+          <p:nvPr/>
+        </p:nvSpPr>
+        <p:spPr>
+          <a:xfrm>
+            <a:off x="8211312" y="4955217"/>
+            <a:ext cx="1673352" cy="314221"/>
           </a:xfrm>
           <a:prstGeom prst="rect">
             <a:avLst/>
@@ -6263,14 +6540,14 @@
       </p:sp>
       <p:sp>
         <p:nvSpPr>
-          <p:cNvPr id="120" name="Text 118"/>
-          <p:cNvSpPr txBox="1"/>
-          <p:nvPr/>
-        </p:nvSpPr>
-        <p:spPr>
-          <a:xfrm>
-            <a:off x="9902952" y="4860950"/>
-            <a:ext cx="731520" cy="345643"/>
+          <p:cNvPr id="131" name="Text 129"/>
+          <p:cNvSpPr txBox="1"/>
+          <p:nvPr/>
+        </p:nvSpPr>
+        <p:spPr>
+          <a:xfrm>
+            <a:off x="9902952" y="4955217"/>
+            <a:ext cx="731520" cy="314221"/>
           </a:xfrm>
           <a:prstGeom prst="rect">
             <a:avLst/>
@@ -6302,14 +6579,14 @@
       </p:sp>
       <p:sp>
         <p:nvSpPr>
-          <p:cNvPr id="121" name="Text 119"/>
-          <p:cNvSpPr txBox="1"/>
-          <p:nvPr/>
-        </p:nvSpPr>
-        <p:spPr>
-          <a:xfrm>
-            <a:off x="10652760" y="4860950"/>
-            <a:ext cx="914400" cy="345643"/>
+          <p:cNvPr id="132" name="Text 130"/>
+          <p:cNvSpPr txBox="1"/>
+          <p:nvPr/>
+        </p:nvSpPr>
+        <p:spPr>
+          <a:xfrm>
+            <a:off x="10652760" y="4955217"/>
+            <a:ext cx="914400" cy="314221"/>
           </a:xfrm>
           <a:prstGeom prst="rect">
             <a:avLst/>
@@ -6341,14 +6618,14 @@
       </p:sp>
       <p:sp>
         <p:nvSpPr>
-          <p:cNvPr id="122" name="Text 120"/>
-          <p:cNvSpPr txBox="1"/>
-          <p:nvPr/>
-        </p:nvSpPr>
-        <p:spPr>
-          <a:xfrm>
-            <a:off x="8211312" y="5206594"/>
-            <a:ext cx="1673352" cy="345643"/>
+          <p:cNvPr id="133" name="Text 131"/>
+          <p:cNvSpPr txBox="1"/>
+          <p:nvPr/>
+        </p:nvSpPr>
+        <p:spPr>
+          <a:xfrm>
+            <a:off x="8211312" y="5269438"/>
+            <a:ext cx="1673352" cy="314221"/>
           </a:xfrm>
           <a:prstGeom prst="rect">
             <a:avLst/>
@@ -6380,14 +6657,14 @@
       </p:sp>
       <p:sp>
         <p:nvSpPr>
-          <p:cNvPr id="123" name="Text 121"/>
-          <p:cNvSpPr txBox="1"/>
-          <p:nvPr/>
-        </p:nvSpPr>
-        <p:spPr>
-          <a:xfrm>
-            <a:off x="9902952" y="5206594"/>
-            <a:ext cx="731520" cy="345643"/>
+          <p:cNvPr id="134" name="Text 132"/>
+          <p:cNvSpPr txBox="1"/>
+          <p:nvPr/>
+        </p:nvSpPr>
+        <p:spPr>
+          <a:xfrm>
+            <a:off x="9902952" y="5269438"/>
+            <a:ext cx="731520" cy="314221"/>
           </a:xfrm>
           <a:prstGeom prst="rect">
             <a:avLst/>
@@ -6419,14 +6696,14 @@
       </p:sp>
       <p:sp>
         <p:nvSpPr>
-          <p:cNvPr id="124" name="Text 122"/>
-          <p:cNvSpPr txBox="1"/>
-          <p:nvPr/>
-        </p:nvSpPr>
-        <p:spPr>
-          <a:xfrm>
-            <a:off x="10652760" y="5206594"/>
-            <a:ext cx="914400" cy="345643"/>
+          <p:cNvPr id="135" name="Text 133"/>
+          <p:cNvSpPr txBox="1"/>
+          <p:nvPr/>
+        </p:nvSpPr>
+        <p:spPr>
+          <a:xfrm>
+            <a:off x="10652760" y="5269438"/>
+            <a:ext cx="914400" cy="314221"/>
           </a:xfrm>
           <a:prstGeom prst="rect">
             <a:avLst/>
@@ -6458,14 +6735,14 @@
       </p:sp>
       <p:sp>
         <p:nvSpPr>
-          <p:cNvPr id="125" name="Text 123"/>
-          <p:cNvSpPr txBox="1"/>
-          <p:nvPr/>
-        </p:nvSpPr>
-        <p:spPr>
-          <a:xfrm>
-            <a:off x="8211312" y="5552237"/>
-            <a:ext cx="1673352" cy="345643"/>
+          <p:cNvPr id="136" name="Text 134"/>
+          <p:cNvSpPr txBox="1"/>
+          <p:nvPr/>
+        </p:nvSpPr>
+        <p:spPr>
+          <a:xfrm>
+            <a:off x="8211312" y="5583659"/>
+            <a:ext cx="1673352" cy="314221"/>
           </a:xfrm>
           <a:prstGeom prst="rect">
             <a:avLst/>
@@ -6497,14 +6774,14 @@
       </p:sp>
       <p:sp>
         <p:nvSpPr>
-          <p:cNvPr id="126" name="Text 124"/>
-          <p:cNvSpPr txBox="1"/>
-          <p:nvPr/>
-        </p:nvSpPr>
-        <p:spPr>
-          <a:xfrm>
-            <a:off x="9902952" y="5552237"/>
-            <a:ext cx="731520" cy="345643"/>
+          <p:cNvPr id="137" name="Text 135"/>
+          <p:cNvSpPr txBox="1"/>
+          <p:nvPr/>
+        </p:nvSpPr>
+        <p:spPr>
+          <a:xfrm>
+            <a:off x="9902952" y="5583659"/>
+            <a:ext cx="731520" cy="314221"/>
           </a:xfrm>
           <a:prstGeom prst="rect">
             <a:avLst/>
@@ -6536,14 +6813,14 @@
       </p:sp>
       <p:sp>
         <p:nvSpPr>
-          <p:cNvPr id="127" name="Text 125"/>
-          <p:cNvSpPr txBox="1"/>
-          <p:nvPr/>
-        </p:nvSpPr>
-        <p:spPr>
-          <a:xfrm>
-            <a:off x="10652760" y="5552237"/>
-            <a:ext cx="914400" cy="345643"/>
+          <p:cNvPr id="138" name="Text 136"/>
+          <p:cNvSpPr txBox="1"/>
+          <p:nvPr/>
+        </p:nvSpPr>
+        <p:spPr>
+          <a:xfrm>
+            <a:off x="10652760" y="5583659"/>
+            <a:ext cx="914400" cy="314221"/>
           </a:xfrm>
           <a:prstGeom prst="rect">
             <a:avLst/>
@@ -6575,7 +6852,7 @@
       </p:sp>
       <p:sp>
         <p:nvSpPr>
-          <p:cNvPr id="128" name="Shape 126"/>
+          <p:cNvPr id="139" name="Shape 137"/>
           <p:cNvSpPr/>
           <p:nvPr/>
         </p:nvSpPr>
@@ -6595,7 +6872,7 @@
       </p:sp>
       <p:sp>
         <p:nvSpPr>
-          <p:cNvPr id="129" name="Text 127"/>
+          <p:cNvPr id="140" name="Text 138"/>
           <p:cNvSpPr txBox="1"/>
           <p:nvPr/>
         </p:nvSpPr>

</xml_diff>

<commit_message>
Phone preview: red bar for stores in more than one bottom 5
Co-Authored-By: Claude Opus 5.5 <noreply@anthropic.com>
Claude-Session: https://claude.ai/code/session_01Xa4nFVxuQGXmHARGph9WhS
</commit_message>
<xml_diff>
--- a/day2-deck/decks/Phone Handling - Preview.pptx
+++ b/day2-deck/decks/Phone Handling - Preview.pptx
@@ -591,7 +591,7 @@
           <a:p>
             <a:r>
               <a:rPr lang="en-US" dirty="0"/>
-              <a:t>Source: Flai voice AI dashboard, Service view, standings export, Jul 26 - Oct 26, 2026 (93 days). Flai's location names (26 with calls). Pickup rate and resolution as Flai reports them. Flai's estimated savings, revenue and profit are not used. Green bar: the store is in more than one top list. Ranked among the 23 locations with 300+ calls (Subaru St George, Land Rover Henderson, Jaguar Land Rover Las Vegas have fewer). Honda Spokane shows no calls in the period.Talk track: the voice AI answers every call, books what it can and hands the rest to the store. What happens next is ours: someone has to pick up the transfer, and every callback has to be closed. A store that doesn't pick up is sending a customer it already has to voicemail.
+              <a:t>Source: Flai voice AI dashboard, Service view, standings export, Jul 26 - Oct 26, 2026 (93 days). Flai's location names (26 with calls). Pickup rate and resolution as Flai reports them. Flai's estimated savings, revenue and profit are not used. Green bar: the store is in more than one top list; red bar: in more than one bottom 5. Ranked among the 23 locations with 300+ calls (Subaru St George, Land Rover Henderson, Jaguar Land Rover Las Vegas have fewer). Honda Spokane shows no calls in the period.Talk track: the voice AI answers every call, books what it can and hands the rest to the store. What happens next is ours: someone has to pick up the transfer, and every callback has to be closed. A store that doesn't pick up is sending a customer it already has to voicemail.
 Definitions to confirm against Flai: pickup rate is read as the share of transferred calls a person picked up; resolution as the share of callback requests closed. Resolve time in the export runs to weeks at some locations and is not shown.</a:t>
             </a:r>
             <a:endParaRPr lang="en-US" dirty="0"/>
@@ -3103,7 +3103,27 @@
       </p:sp>
       <p:sp>
         <p:nvSpPr>
-          <p:cNvPr id="38" name="Text 36"/>
+          <p:cNvPr id="38" name="Shape 36"/>
+          <p:cNvSpPr/>
+          <p:nvPr/>
+        </p:nvSpPr>
+        <p:spPr>
+          <a:xfrm>
+            <a:off x="4023360" y="4363351"/>
+            <a:ext cx="54864" cy="241069"/>
+          </a:xfrm>
+          <a:prstGeom prst="rect">
+            <a:avLst/>
+          </a:prstGeom>
+          <a:solidFill>
+            <a:srgbClr val="C2352F"/>
+          </a:solidFill>
+          <a:ln/>
+        </p:spPr>
+      </p:sp>
+      <p:sp>
+        <p:nvSpPr>
+          <p:cNvPr id="39" name="Text 37"/>
           <p:cNvSpPr txBox="1"/>
           <p:nvPr/>
         </p:nvSpPr>
@@ -3142,7 +3162,7 @@
       </p:sp>
       <p:sp>
         <p:nvSpPr>
-          <p:cNvPr id="39" name="Text 37"/>
+          <p:cNvPr id="40" name="Text 38"/>
           <p:cNvSpPr txBox="1"/>
           <p:nvPr/>
         </p:nvSpPr>
@@ -3181,7 +3201,7 @@
       </p:sp>
       <p:sp>
         <p:nvSpPr>
-          <p:cNvPr id="40" name="Text 38"/>
+          <p:cNvPr id="41" name="Text 39"/>
           <p:cNvSpPr txBox="1"/>
           <p:nvPr/>
         </p:nvSpPr>
@@ -3220,7 +3240,27 @@
       </p:sp>
       <p:sp>
         <p:nvSpPr>
-          <p:cNvPr id="41" name="Text 39"/>
+          <p:cNvPr id="42" name="Shape 40"/>
+          <p:cNvSpPr/>
+          <p:nvPr/>
+        </p:nvSpPr>
+        <p:spPr>
+          <a:xfrm>
+            <a:off x="4023360" y="4677572"/>
+            <a:ext cx="54864" cy="241069"/>
+          </a:xfrm>
+          <a:prstGeom prst="rect">
+            <a:avLst/>
+          </a:prstGeom>
+          <a:solidFill>
+            <a:srgbClr val="C2352F"/>
+          </a:solidFill>
+          <a:ln/>
+        </p:spPr>
+      </p:sp>
+      <p:sp>
+        <p:nvSpPr>
+          <p:cNvPr id="43" name="Text 41"/>
           <p:cNvSpPr txBox="1"/>
           <p:nvPr/>
         </p:nvSpPr>
@@ -3259,7 +3299,7 @@
       </p:sp>
       <p:sp>
         <p:nvSpPr>
-          <p:cNvPr id="42" name="Text 40"/>
+          <p:cNvPr id="44" name="Text 42"/>
           <p:cNvSpPr txBox="1"/>
           <p:nvPr/>
         </p:nvSpPr>
@@ -3298,7 +3338,7 @@
       </p:sp>
       <p:sp>
         <p:nvSpPr>
-          <p:cNvPr id="43" name="Text 41"/>
+          <p:cNvPr id="45" name="Text 43"/>
           <p:cNvSpPr txBox="1"/>
           <p:nvPr/>
         </p:nvSpPr>
@@ -3337,7 +3377,7 @@
       </p:sp>
       <p:sp>
         <p:nvSpPr>
-          <p:cNvPr id="44" name="Text 42"/>
+          <p:cNvPr id="46" name="Text 44"/>
           <p:cNvSpPr txBox="1"/>
           <p:nvPr/>
         </p:nvSpPr>
@@ -3376,7 +3416,7 @@
       </p:sp>
       <p:sp>
         <p:nvSpPr>
-          <p:cNvPr id="45" name="Text 43"/>
+          <p:cNvPr id="47" name="Text 45"/>
           <p:cNvSpPr txBox="1"/>
           <p:nvPr/>
         </p:nvSpPr>
@@ -3415,7 +3455,7 @@
       </p:sp>
       <p:sp>
         <p:nvSpPr>
-          <p:cNvPr id="46" name="Text 44"/>
+          <p:cNvPr id="48" name="Text 46"/>
           <p:cNvSpPr txBox="1"/>
           <p:nvPr/>
         </p:nvSpPr>
@@ -3454,7 +3494,27 @@
       </p:sp>
       <p:sp>
         <p:nvSpPr>
-          <p:cNvPr id="47" name="Text 45"/>
+          <p:cNvPr id="49" name="Shape 47"/>
+          <p:cNvSpPr/>
+          <p:nvPr/>
+        </p:nvSpPr>
+        <p:spPr>
+          <a:xfrm>
+            <a:off x="4023360" y="5306014"/>
+            <a:ext cx="54864" cy="241069"/>
+          </a:xfrm>
+          <a:prstGeom prst="rect">
+            <a:avLst/>
+          </a:prstGeom>
+          <a:solidFill>
+            <a:srgbClr val="C2352F"/>
+          </a:solidFill>
+          <a:ln/>
+        </p:spPr>
+      </p:sp>
+      <p:sp>
+        <p:nvSpPr>
+          <p:cNvPr id="50" name="Text 48"/>
           <p:cNvSpPr txBox="1"/>
           <p:nvPr/>
         </p:nvSpPr>
@@ -3493,7 +3553,7 @@
       </p:sp>
       <p:sp>
         <p:nvSpPr>
-          <p:cNvPr id="48" name="Text 46"/>
+          <p:cNvPr id="51" name="Text 49"/>
           <p:cNvSpPr txBox="1"/>
           <p:nvPr/>
         </p:nvSpPr>
@@ -3532,7 +3592,7 @@
       </p:sp>
       <p:sp>
         <p:nvSpPr>
-          <p:cNvPr id="49" name="Text 47"/>
+          <p:cNvPr id="52" name="Text 50"/>
           <p:cNvSpPr txBox="1"/>
           <p:nvPr/>
         </p:nvSpPr>
@@ -3571,7 +3631,27 @@
       </p:sp>
       <p:sp>
         <p:nvSpPr>
-          <p:cNvPr id="50" name="Shape 48"/>
+          <p:cNvPr id="53" name="Shape 51"/>
+          <p:cNvSpPr/>
+          <p:nvPr/>
+        </p:nvSpPr>
+        <p:spPr>
+          <a:xfrm>
+            <a:off x="4023360" y="5620235"/>
+            <a:ext cx="54864" cy="241069"/>
+          </a:xfrm>
+          <a:prstGeom prst="rect">
+            <a:avLst/>
+          </a:prstGeom>
+          <a:solidFill>
+            <a:srgbClr val="C2352F"/>
+          </a:solidFill>
+          <a:ln/>
+        </p:spPr>
+      </p:sp>
+      <p:sp>
+        <p:nvSpPr>
+          <p:cNvPr id="54" name="Shape 52"/>
           <p:cNvSpPr/>
           <p:nvPr/>
         </p:nvSpPr>
@@ -3591,7 +3671,7 @@
       </p:sp>
       <p:sp>
         <p:nvSpPr>
-          <p:cNvPr id="51" name="Text 49"/>
+          <p:cNvPr id="55" name="Text 53"/>
           <p:cNvSpPr txBox="1"/>
           <p:nvPr/>
         </p:nvSpPr>
@@ -3630,7 +3710,7 @@
       </p:sp>
       <p:sp>
         <p:nvSpPr>
-          <p:cNvPr id="52" name="Text 50"/>
+          <p:cNvPr id="56" name="Text 54"/>
           <p:cNvSpPr txBox="1"/>
           <p:nvPr/>
         </p:nvSpPr>
@@ -3669,7 +3749,7 @@
       </p:sp>
       <p:sp>
         <p:nvSpPr>
-          <p:cNvPr id="53" name="Shape 51"/>
+          <p:cNvPr id="57" name="Shape 55"/>
           <p:cNvSpPr/>
           <p:nvPr/>
         </p:nvSpPr>
@@ -3689,7 +3769,7 @@
       </p:sp>
       <p:sp>
         <p:nvSpPr>
-          <p:cNvPr id="54" name="Text 52"/>
+          <p:cNvPr id="58" name="Text 56"/>
           <p:cNvSpPr txBox="1"/>
           <p:nvPr/>
         </p:nvSpPr>
@@ -3728,7 +3808,7 @@
       </p:sp>
       <p:sp>
         <p:nvSpPr>
-          <p:cNvPr id="55" name="Text 53"/>
+          <p:cNvPr id="59" name="Text 57"/>
           <p:cNvSpPr txBox="1"/>
           <p:nvPr/>
         </p:nvSpPr>
@@ -3767,7 +3847,7 @@
       </p:sp>
       <p:sp>
         <p:nvSpPr>
-          <p:cNvPr id="56" name="Text 54"/>
+          <p:cNvPr id="60" name="Text 58"/>
           <p:cNvSpPr txBox="1"/>
           <p:nvPr/>
         </p:nvSpPr>
@@ -3806,7 +3886,7 @@
       </p:sp>
       <p:sp>
         <p:nvSpPr>
-          <p:cNvPr id="57" name="Text 55"/>
+          <p:cNvPr id="61" name="Text 59"/>
           <p:cNvSpPr txBox="1"/>
           <p:nvPr/>
         </p:nvSpPr>
@@ -3845,7 +3925,7 @@
       </p:sp>
       <p:sp>
         <p:nvSpPr>
-          <p:cNvPr id="58" name="Text 56"/>
+          <p:cNvPr id="62" name="Text 60"/>
           <p:cNvSpPr txBox="1"/>
           <p:nvPr/>
         </p:nvSpPr>
@@ -3884,7 +3964,7 @@
       </p:sp>
       <p:sp>
         <p:nvSpPr>
-          <p:cNvPr id="59" name="Text 57"/>
+          <p:cNvPr id="63" name="Text 61"/>
           <p:cNvSpPr txBox="1"/>
           <p:nvPr/>
         </p:nvSpPr>
@@ -3923,7 +4003,7 @@
       </p:sp>
       <p:sp>
         <p:nvSpPr>
-          <p:cNvPr id="60" name="Shape 58"/>
+          <p:cNvPr id="64" name="Shape 62"/>
           <p:cNvSpPr/>
           <p:nvPr/>
         </p:nvSpPr>
@@ -3943,7 +4023,7 @@
       </p:sp>
       <p:sp>
         <p:nvSpPr>
-          <p:cNvPr id="61" name="Text 59"/>
+          <p:cNvPr id="65" name="Text 63"/>
           <p:cNvSpPr txBox="1"/>
           <p:nvPr/>
         </p:nvSpPr>
@@ -3982,7 +4062,7 @@
       </p:sp>
       <p:sp>
         <p:nvSpPr>
-          <p:cNvPr id="62" name="Text 60"/>
+          <p:cNvPr id="66" name="Text 64"/>
           <p:cNvSpPr txBox="1"/>
           <p:nvPr/>
         </p:nvSpPr>
@@ -4021,7 +4101,7 @@
       </p:sp>
       <p:sp>
         <p:nvSpPr>
-          <p:cNvPr id="63" name="Text 61"/>
+          <p:cNvPr id="67" name="Text 65"/>
           <p:cNvSpPr txBox="1"/>
           <p:nvPr/>
         </p:nvSpPr>
@@ -4060,7 +4140,7 @@
       </p:sp>
       <p:sp>
         <p:nvSpPr>
-          <p:cNvPr id="64" name="Shape 62"/>
+          <p:cNvPr id="68" name="Shape 66"/>
           <p:cNvSpPr/>
           <p:nvPr/>
         </p:nvSpPr>
@@ -4080,7 +4160,7 @@
       </p:sp>
       <p:sp>
         <p:nvSpPr>
-          <p:cNvPr id="65" name="Text 63"/>
+          <p:cNvPr id="69" name="Text 67"/>
           <p:cNvSpPr txBox="1"/>
           <p:nvPr/>
         </p:nvSpPr>
@@ -4119,7 +4199,7 @@
       </p:sp>
       <p:sp>
         <p:nvSpPr>
-          <p:cNvPr id="66" name="Text 64"/>
+          <p:cNvPr id="70" name="Text 68"/>
           <p:cNvSpPr txBox="1"/>
           <p:nvPr/>
         </p:nvSpPr>
@@ -4158,7 +4238,7 @@
       </p:sp>
       <p:sp>
         <p:nvSpPr>
-          <p:cNvPr id="67" name="Text 65"/>
+          <p:cNvPr id="71" name="Text 69"/>
           <p:cNvSpPr txBox="1"/>
           <p:nvPr/>
         </p:nvSpPr>
@@ -4197,7 +4277,7 @@
       </p:sp>
       <p:sp>
         <p:nvSpPr>
-          <p:cNvPr id="68" name="Shape 66"/>
+          <p:cNvPr id="72" name="Shape 70"/>
           <p:cNvSpPr/>
           <p:nvPr/>
         </p:nvSpPr>
@@ -4217,7 +4297,7 @@
       </p:sp>
       <p:sp>
         <p:nvSpPr>
-          <p:cNvPr id="69" name="Text 67"/>
+          <p:cNvPr id="73" name="Text 71"/>
           <p:cNvSpPr txBox="1"/>
           <p:nvPr/>
         </p:nvSpPr>
@@ -4256,7 +4336,7 @@
       </p:sp>
       <p:sp>
         <p:nvSpPr>
-          <p:cNvPr id="70" name="Text 68"/>
+          <p:cNvPr id="74" name="Text 72"/>
           <p:cNvSpPr txBox="1"/>
           <p:nvPr/>
         </p:nvSpPr>
@@ -4295,7 +4375,7 @@
       </p:sp>
       <p:sp>
         <p:nvSpPr>
-          <p:cNvPr id="71" name="Text 69"/>
+          <p:cNvPr id="75" name="Text 73"/>
           <p:cNvSpPr txBox="1"/>
           <p:nvPr/>
         </p:nvSpPr>
@@ -4334,7 +4414,7 @@
       </p:sp>
       <p:sp>
         <p:nvSpPr>
-          <p:cNvPr id="72" name="Shape 70"/>
+          <p:cNvPr id="76" name="Shape 74"/>
           <p:cNvSpPr/>
           <p:nvPr/>
         </p:nvSpPr>
@@ -4354,7 +4434,7 @@
       </p:sp>
       <p:sp>
         <p:nvSpPr>
-          <p:cNvPr id="73" name="Text 71"/>
+          <p:cNvPr id="77" name="Text 75"/>
           <p:cNvSpPr txBox="1"/>
           <p:nvPr/>
         </p:nvSpPr>
@@ -4393,7 +4473,7 @@
       </p:sp>
       <p:sp>
         <p:nvSpPr>
-          <p:cNvPr id="74" name="Text 72"/>
+          <p:cNvPr id="78" name="Text 76"/>
           <p:cNvSpPr txBox="1"/>
           <p:nvPr/>
         </p:nvSpPr>
@@ -4432,7 +4512,7 @@
       </p:sp>
       <p:sp>
         <p:nvSpPr>
-          <p:cNvPr id="75" name="Text 73"/>
+          <p:cNvPr id="79" name="Text 77"/>
           <p:cNvSpPr txBox="1"/>
           <p:nvPr/>
         </p:nvSpPr>
@@ -4471,7 +4551,7 @@
       </p:sp>
       <p:sp>
         <p:nvSpPr>
-          <p:cNvPr id="76" name="Shape 74"/>
+          <p:cNvPr id="80" name="Shape 78"/>
           <p:cNvSpPr/>
           <p:nvPr/>
         </p:nvSpPr>
@@ -4491,7 +4571,7 @@
       </p:sp>
       <p:sp>
         <p:nvSpPr>
-          <p:cNvPr id="77" name="Text 75"/>
+          <p:cNvPr id="81" name="Text 79"/>
           <p:cNvSpPr txBox="1"/>
           <p:nvPr/>
         </p:nvSpPr>
@@ -4530,7 +4610,7 @@
       </p:sp>
       <p:sp>
         <p:nvSpPr>
-          <p:cNvPr id="78" name="Text 76"/>
+          <p:cNvPr id="82" name="Text 80"/>
           <p:cNvSpPr txBox="1"/>
           <p:nvPr/>
         </p:nvSpPr>
@@ -4569,7 +4649,7 @@
       </p:sp>
       <p:sp>
         <p:nvSpPr>
-          <p:cNvPr id="79" name="Text 77"/>
+          <p:cNvPr id="83" name="Text 81"/>
           <p:cNvSpPr txBox="1"/>
           <p:nvPr/>
         </p:nvSpPr>
@@ -4608,7 +4688,7 @@
       </p:sp>
       <p:sp>
         <p:nvSpPr>
-          <p:cNvPr id="80" name="Text 78"/>
+          <p:cNvPr id="84" name="Text 82"/>
           <p:cNvSpPr txBox="1"/>
           <p:nvPr/>
         </p:nvSpPr>
@@ -4647,7 +4727,7 @@
       </p:sp>
       <p:sp>
         <p:nvSpPr>
-          <p:cNvPr id="81" name="Text 79"/>
+          <p:cNvPr id="85" name="Text 83"/>
           <p:cNvSpPr txBox="1"/>
           <p:nvPr/>
         </p:nvSpPr>
@@ -4686,7 +4766,7 @@
       </p:sp>
       <p:sp>
         <p:nvSpPr>
-          <p:cNvPr id="82" name="Text 80"/>
+          <p:cNvPr id="86" name="Text 84"/>
           <p:cNvSpPr txBox="1"/>
           <p:nvPr/>
         </p:nvSpPr>
@@ -4725,7 +4805,27 @@
       </p:sp>
       <p:sp>
         <p:nvSpPr>
-          <p:cNvPr id="83" name="Text 81"/>
+          <p:cNvPr id="87" name="Shape 85"/>
+          <p:cNvSpPr/>
+          <p:nvPr/>
+        </p:nvSpPr>
+        <p:spPr>
+          <a:xfrm>
+            <a:off x="7818120" y="4363351"/>
+            <a:ext cx="54864" cy="241069"/>
+          </a:xfrm>
+          <a:prstGeom prst="rect">
+            <a:avLst/>
+          </a:prstGeom>
+          <a:solidFill>
+            <a:srgbClr val="C2352F"/>
+          </a:solidFill>
+          <a:ln/>
+        </p:spPr>
+      </p:sp>
+      <p:sp>
+        <p:nvSpPr>
+          <p:cNvPr id="88" name="Text 86"/>
           <p:cNvSpPr txBox="1"/>
           <p:nvPr/>
         </p:nvSpPr>
@@ -4764,7 +4864,7 @@
       </p:sp>
       <p:sp>
         <p:nvSpPr>
-          <p:cNvPr id="84" name="Text 82"/>
+          <p:cNvPr id="89" name="Text 87"/>
           <p:cNvSpPr txBox="1"/>
           <p:nvPr/>
         </p:nvSpPr>
@@ -4803,7 +4903,7 @@
       </p:sp>
       <p:sp>
         <p:nvSpPr>
-          <p:cNvPr id="85" name="Text 83"/>
+          <p:cNvPr id="90" name="Text 88"/>
           <p:cNvSpPr txBox="1"/>
           <p:nvPr/>
         </p:nvSpPr>
@@ -4842,7 +4942,7 @@
       </p:sp>
       <p:sp>
         <p:nvSpPr>
-          <p:cNvPr id="86" name="Text 84"/>
+          <p:cNvPr id="91" name="Text 89"/>
           <p:cNvSpPr txBox="1"/>
           <p:nvPr/>
         </p:nvSpPr>
@@ -4881,7 +4981,7 @@
       </p:sp>
       <p:sp>
         <p:nvSpPr>
-          <p:cNvPr id="87" name="Text 85"/>
+          <p:cNvPr id="92" name="Text 90"/>
           <p:cNvSpPr txBox="1"/>
           <p:nvPr/>
         </p:nvSpPr>
@@ -4920,7 +5020,7 @@
       </p:sp>
       <p:sp>
         <p:nvSpPr>
-          <p:cNvPr id="88" name="Text 86"/>
+          <p:cNvPr id="93" name="Text 91"/>
           <p:cNvSpPr txBox="1"/>
           <p:nvPr/>
         </p:nvSpPr>
@@ -4959,7 +5059,7 @@
       </p:sp>
       <p:sp>
         <p:nvSpPr>
-          <p:cNvPr id="89" name="Text 87"/>
+          <p:cNvPr id="94" name="Text 92"/>
           <p:cNvSpPr txBox="1"/>
           <p:nvPr/>
         </p:nvSpPr>
@@ -4998,7 +5098,7 @@
       </p:sp>
       <p:sp>
         <p:nvSpPr>
-          <p:cNvPr id="90" name="Text 88"/>
+          <p:cNvPr id="95" name="Text 93"/>
           <p:cNvSpPr txBox="1"/>
           <p:nvPr/>
         </p:nvSpPr>
@@ -5037,7 +5137,7 @@
       </p:sp>
       <p:sp>
         <p:nvSpPr>
-          <p:cNvPr id="91" name="Text 89"/>
+          <p:cNvPr id="96" name="Text 94"/>
           <p:cNvSpPr txBox="1"/>
           <p:nvPr/>
         </p:nvSpPr>
@@ -5076,7 +5176,27 @@
       </p:sp>
       <p:sp>
         <p:nvSpPr>
-          <p:cNvPr id="92" name="Text 90"/>
+          <p:cNvPr id="97" name="Shape 95"/>
+          <p:cNvSpPr/>
+          <p:nvPr/>
+        </p:nvSpPr>
+        <p:spPr>
+          <a:xfrm>
+            <a:off x="7818120" y="5306014"/>
+            <a:ext cx="54864" cy="241069"/>
+          </a:xfrm>
+          <a:prstGeom prst="rect">
+            <a:avLst/>
+          </a:prstGeom>
+          <a:solidFill>
+            <a:srgbClr val="C2352F"/>
+          </a:solidFill>
+          <a:ln/>
+        </p:spPr>
+      </p:sp>
+      <p:sp>
+        <p:nvSpPr>
+          <p:cNvPr id="98" name="Text 96"/>
           <p:cNvSpPr txBox="1"/>
           <p:nvPr/>
         </p:nvSpPr>
@@ -5115,7 +5235,7 @@
       </p:sp>
       <p:sp>
         <p:nvSpPr>
-          <p:cNvPr id="93" name="Text 91"/>
+          <p:cNvPr id="99" name="Text 97"/>
           <p:cNvSpPr txBox="1"/>
           <p:nvPr/>
         </p:nvSpPr>
@@ -5154,7 +5274,7 @@
       </p:sp>
       <p:sp>
         <p:nvSpPr>
-          <p:cNvPr id="94" name="Text 92"/>
+          <p:cNvPr id="100" name="Text 98"/>
           <p:cNvSpPr txBox="1"/>
           <p:nvPr/>
         </p:nvSpPr>
@@ -5193,7 +5313,27 @@
       </p:sp>
       <p:sp>
         <p:nvSpPr>
-          <p:cNvPr id="95" name="Shape 93"/>
+          <p:cNvPr id="101" name="Shape 99"/>
+          <p:cNvSpPr/>
+          <p:nvPr/>
+        </p:nvSpPr>
+        <p:spPr>
+          <a:xfrm>
+            <a:off x="7818120" y="5620235"/>
+            <a:ext cx="54864" cy="241069"/>
+          </a:xfrm>
+          <a:prstGeom prst="rect">
+            <a:avLst/>
+          </a:prstGeom>
+          <a:solidFill>
+            <a:srgbClr val="C2352F"/>
+          </a:solidFill>
+          <a:ln/>
+        </p:spPr>
+      </p:sp>
+      <p:sp>
+        <p:nvSpPr>
+          <p:cNvPr id="102" name="Shape 100"/>
           <p:cNvSpPr/>
           <p:nvPr/>
         </p:nvSpPr>
@@ -5213,7 +5353,7 @@
       </p:sp>
       <p:sp>
         <p:nvSpPr>
-          <p:cNvPr id="96" name="Text 94"/>
+          <p:cNvPr id="103" name="Text 101"/>
           <p:cNvSpPr txBox="1"/>
           <p:nvPr/>
         </p:nvSpPr>
@@ -5252,7 +5392,7 @@
       </p:sp>
       <p:sp>
         <p:nvSpPr>
-          <p:cNvPr id="97" name="Text 95"/>
+          <p:cNvPr id="104" name="Text 102"/>
           <p:cNvSpPr txBox="1"/>
           <p:nvPr/>
         </p:nvSpPr>
@@ -5291,7 +5431,7 @@
       </p:sp>
       <p:sp>
         <p:nvSpPr>
-          <p:cNvPr id="98" name="Shape 96"/>
+          <p:cNvPr id="105" name="Shape 103"/>
           <p:cNvSpPr/>
           <p:nvPr/>
         </p:nvSpPr>
@@ -5311,7 +5451,7 @@
       </p:sp>
       <p:sp>
         <p:nvSpPr>
-          <p:cNvPr id="99" name="Text 97"/>
+          <p:cNvPr id="106" name="Text 104"/>
           <p:cNvSpPr txBox="1"/>
           <p:nvPr/>
         </p:nvSpPr>
@@ -5350,7 +5490,7 @@
       </p:sp>
       <p:sp>
         <p:nvSpPr>
-          <p:cNvPr id="100" name="Text 98"/>
+          <p:cNvPr id="107" name="Text 105"/>
           <p:cNvSpPr txBox="1"/>
           <p:nvPr/>
         </p:nvSpPr>
@@ -5389,7 +5529,7 @@
       </p:sp>
       <p:sp>
         <p:nvSpPr>
-          <p:cNvPr id="101" name="Text 99"/>
+          <p:cNvPr id="108" name="Text 106"/>
           <p:cNvSpPr txBox="1"/>
           <p:nvPr/>
         </p:nvSpPr>
@@ -5428,7 +5568,7 @@
       </p:sp>
       <p:sp>
         <p:nvSpPr>
-          <p:cNvPr id="102" name="Text 100"/>
+          <p:cNvPr id="109" name="Text 107"/>
           <p:cNvSpPr txBox="1"/>
           <p:nvPr/>
         </p:nvSpPr>
@@ -5467,7 +5607,7 @@
       </p:sp>
       <p:sp>
         <p:nvSpPr>
-          <p:cNvPr id="103" name="Text 101"/>
+          <p:cNvPr id="110" name="Text 108"/>
           <p:cNvSpPr txBox="1"/>
           <p:nvPr/>
         </p:nvSpPr>
@@ -5506,7 +5646,7 @@
       </p:sp>
       <p:sp>
         <p:nvSpPr>
-          <p:cNvPr id="104" name="Text 102"/>
+          <p:cNvPr id="111" name="Text 109"/>
           <p:cNvSpPr txBox="1"/>
           <p:nvPr/>
         </p:nvSpPr>
@@ -5545,7 +5685,7 @@
       </p:sp>
       <p:sp>
         <p:nvSpPr>
-          <p:cNvPr id="105" name="Text 103"/>
+          <p:cNvPr id="112" name="Text 110"/>
           <p:cNvSpPr txBox="1"/>
           <p:nvPr/>
         </p:nvSpPr>
@@ -5584,7 +5724,7 @@
       </p:sp>
       <p:sp>
         <p:nvSpPr>
-          <p:cNvPr id="106" name="Text 104"/>
+          <p:cNvPr id="113" name="Text 111"/>
           <p:cNvSpPr txBox="1"/>
           <p:nvPr/>
         </p:nvSpPr>
@@ -5623,7 +5763,7 @@
       </p:sp>
       <p:sp>
         <p:nvSpPr>
-          <p:cNvPr id="107" name="Text 105"/>
+          <p:cNvPr id="114" name="Text 112"/>
           <p:cNvSpPr txBox="1"/>
           <p:nvPr/>
         </p:nvSpPr>
@@ -5662,7 +5802,7 @@
       </p:sp>
       <p:sp>
         <p:nvSpPr>
-          <p:cNvPr id="108" name="Text 106"/>
+          <p:cNvPr id="115" name="Text 113"/>
           <p:cNvSpPr txBox="1"/>
           <p:nvPr/>
         </p:nvSpPr>
@@ -5701,7 +5841,7 @@
       </p:sp>
       <p:sp>
         <p:nvSpPr>
-          <p:cNvPr id="109" name="Text 107"/>
+          <p:cNvPr id="116" name="Text 114"/>
           <p:cNvSpPr txBox="1"/>
           <p:nvPr/>
         </p:nvSpPr>
@@ -5740,7 +5880,7 @@
       </p:sp>
       <p:sp>
         <p:nvSpPr>
-          <p:cNvPr id="110" name="Text 108"/>
+          <p:cNvPr id="117" name="Text 115"/>
           <p:cNvSpPr txBox="1"/>
           <p:nvPr/>
         </p:nvSpPr>
@@ -5779,7 +5919,7 @@
       </p:sp>
       <p:sp>
         <p:nvSpPr>
-          <p:cNvPr id="111" name="Text 109"/>
+          <p:cNvPr id="118" name="Text 116"/>
           <p:cNvSpPr txBox="1"/>
           <p:nvPr/>
         </p:nvSpPr>
@@ -5818,7 +5958,7 @@
       </p:sp>
       <p:sp>
         <p:nvSpPr>
-          <p:cNvPr id="112" name="Text 110"/>
+          <p:cNvPr id="119" name="Text 117"/>
           <p:cNvSpPr txBox="1"/>
           <p:nvPr/>
         </p:nvSpPr>
@@ -5857,7 +5997,7 @@
       </p:sp>
       <p:sp>
         <p:nvSpPr>
-          <p:cNvPr id="113" name="Text 111"/>
+          <p:cNvPr id="120" name="Text 118"/>
           <p:cNvSpPr txBox="1"/>
           <p:nvPr/>
         </p:nvSpPr>
@@ -5896,7 +6036,7 @@
       </p:sp>
       <p:sp>
         <p:nvSpPr>
-          <p:cNvPr id="114" name="Text 112"/>
+          <p:cNvPr id="121" name="Text 119"/>
           <p:cNvSpPr txBox="1"/>
           <p:nvPr/>
         </p:nvSpPr>
@@ -5935,7 +6075,7 @@
       </p:sp>
       <p:sp>
         <p:nvSpPr>
-          <p:cNvPr id="115" name="Text 113"/>
+          <p:cNvPr id="122" name="Text 120"/>
           <p:cNvSpPr txBox="1"/>
           <p:nvPr/>
         </p:nvSpPr>
@@ -5974,7 +6114,7 @@
       </p:sp>
       <p:sp>
         <p:nvSpPr>
-          <p:cNvPr id="116" name="Text 114"/>
+          <p:cNvPr id="123" name="Text 121"/>
           <p:cNvSpPr txBox="1"/>
           <p:nvPr/>
         </p:nvSpPr>
@@ -6013,7 +6153,7 @@
       </p:sp>
       <p:sp>
         <p:nvSpPr>
-          <p:cNvPr id="117" name="Text 115"/>
+          <p:cNvPr id="124" name="Text 122"/>
           <p:cNvSpPr txBox="1"/>
           <p:nvPr/>
         </p:nvSpPr>
@@ -6052,7 +6192,7 @@
       </p:sp>
       <p:sp>
         <p:nvSpPr>
-          <p:cNvPr id="118" name="Text 116"/>
+          <p:cNvPr id="125" name="Text 123"/>
           <p:cNvSpPr txBox="1"/>
           <p:nvPr/>
         </p:nvSpPr>
@@ -6091,7 +6231,7 @@
       </p:sp>
       <p:sp>
         <p:nvSpPr>
-          <p:cNvPr id="119" name="Text 117"/>
+          <p:cNvPr id="126" name="Text 124"/>
           <p:cNvSpPr txBox="1"/>
           <p:nvPr/>
         </p:nvSpPr>
@@ -6130,7 +6270,7 @@
       </p:sp>
       <p:sp>
         <p:nvSpPr>
-          <p:cNvPr id="120" name="Shape 118"/>
+          <p:cNvPr id="127" name="Shape 125"/>
           <p:cNvSpPr/>
           <p:nvPr/>
         </p:nvSpPr>
@@ -6150,7 +6290,7 @@
       </p:sp>
       <p:sp>
         <p:nvSpPr>
-          <p:cNvPr id="121" name="Text 119"/>
+          <p:cNvPr id="128" name="Text 126"/>
           <p:cNvSpPr txBox="1"/>
           <p:nvPr/>
         </p:nvSpPr>
@@ -6189,7 +6329,7 @@
       </p:sp>
       <p:sp>
         <p:nvSpPr>
-          <p:cNvPr id="122" name="Text 120"/>
+          <p:cNvPr id="129" name="Text 127"/>
           <p:cNvSpPr txBox="1"/>
           <p:nvPr/>
         </p:nvSpPr>
@@ -6228,7 +6368,7 @@
       </p:sp>
       <p:sp>
         <p:nvSpPr>
-          <p:cNvPr id="123" name="Text 121"/>
+          <p:cNvPr id="130" name="Text 128"/>
           <p:cNvSpPr txBox="1"/>
           <p:nvPr/>
         </p:nvSpPr>
@@ -6267,7 +6407,7 @@
       </p:sp>
       <p:sp>
         <p:nvSpPr>
-          <p:cNvPr id="124" name="Text 122"/>
+          <p:cNvPr id="131" name="Text 129"/>
           <p:cNvSpPr txBox="1"/>
           <p:nvPr/>
         </p:nvSpPr>
@@ -6306,7 +6446,7 @@
       </p:sp>
       <p:sp>
         <p:nvSpPr>
-          <p:cNvPr id="125" name="Text 123"/>
+          <p:cNvPr id="132" name="Text 130"/>
           <p:cNvSpPr txBox="1"/>
           <p:nvPr/>
         </p:nvSpPr>
@@ -6345,7 +6485,7 @@
       </p:sp>
       <p:sp>
         <p:nvSpPr>
-          <p:cNvPr id="126" name="Text 124"/>
+          <p:cNvPr id="133" name="Text 131"/>
           <p:cNvSpPr txBox="1"/>
           <p:nvPr/>
         </p:nvSpPr>
@@ -6384,7 +6524,7 @@
       </p:sp>
       <p:sp>
         <p:nvSpPr>
-          <p:cNvPr id="127" name="Text 125"/>
+          <p:cNvPr id="134" name="Text 132"/>
           <p:cNvSpPr txBox="1"/>
           <p:nvPr/>
         </p:nvSpPr>
@@ -6423,7 +6563,7 @@
       </p:sp>
       <p:sp>
         <p:nvSpPr>
-          <p:cNvPr id="128" name="Text 126"/>
+          <p:cNvPr id="135" name="Text 133"/>
           <p:cNvSpPr txBox="1"/>
           <p:nvPr/>
         </p:nvSpPr>
@@ -6462,7 +6602,7 @@
       </p:sp>
       <p:sp>
         <p:nvSpPr>
-          <p:cNvPr id="129" name="Text 127"/>
+          <p:cNvPr id="136" name="Text 134"/>
           <p:cNvSpPr txBox="1"/>
           <p:nvPr/>
         </p:nvSpPr>
@@ -6501,7 +6641,7 @@
       </p:sp>
       <p:sp>
         <p:nvSpPr>
-          <p:cNvPr id="130" name="Text 128"/>
+          <p:cNvPr id="137" name="Text 135"/>
           <p:cNvSpPr txBox="1"/>
           <p:nvPr/>
         </p:nvSpPr>
@@ -6540,7 +6680,7 @@
       </p:sp>
       <p:sp>
         <p:nvSpPr>
-          <p:cNvPr id="131" name="Text 129"/>
+          <p:cNvPr id="138" name="Text 136"/>
           <p:cNvSpPr txBox="1"/>
           <p:nvPr/>
         </p:nvSpPr>
@@ -6579,7 +6719,7 @@
       </p:sp>
       <p:sp>
         <p:nvSpPr>
-          <p:cNvPr id="132" name="Text 130"/>
+          <p:cNvPr id="139" name="Text 137"/>
           <p:cNvSpPr txBox="1"/>
           <p:nvPr/>
         </p:nvSpPr>
@@ -6618,7 +6758,27 @@
       </p:sp>
       <p:sp>
         <p:nvSpPr>
-          <p:cNvPr id="133" name="Text 131"/>
+          <p:cNvPr id="140" name="Shape 138"/>
+          <p:cNvSpPr/>
+          <p:nvPr/>
+        </p:nvSpPr>
+        <p:spPr>
+          <a:xfrm>
+            <a:off x="11612880" y="4991793"/>
+            <a:ext cx="54864" cy="241069"/>
+          </a:xfrm>
+          <a:prstGeom prst="rect">
+            <a:avLst/>
+          </a:prstGeom>
+          <a:solidFill>
+            <a:srgbClr val="C2352F"/>
+          </a:solidFill>
+          <a:ln/>
+        </p:spPr>
+      </p:sp>
+      <p:sp>
+        <p:nvSpPr>
+          <p:cNvPr id="141" name="Text 139"/>
           <p:cNvSpPr txBox="1"/>
           <p:nvPr/>
         </p:nvSpPr>
@@ -6657,7 +6817,7 @@
       </p:sp>
       <p:sp>
         <p:nvSpPr>
-          <p:cNvPr id="134" name="Text 132"/>
+          <p:cNvPr id="142" name="Text 140"/>
           <p:cNvSpPr txBox="1"/>
           <p:nvPr/>
         </p:nvSpPr>
@@ -6696,7 +6856,7 @@
       </p:sp>
       <p:sp>
         <p:nvSpPr>
-          <p:cNvPr id="135" name="Text 133"/>
+          <p:cNvPr id="143" name="Text 141"/>
           <p:cNvSpPr txBox="1"/>
           <p:nvPr/>
         </p:nvSpPr>
@@ -6735,7 +6895,27 @@
       </p:sp>
       <p:sp>
         <p:nvSpPr>
-          <p:cNvPr id="136" name="Text 134"/>
+          <p:cNvPr id="144" name="Shape 142"/>
+          <p:cNvSpPr/>
+          <p:nvPr/>
+        </p:nvSpPr>
+        <p:spPr>
+          <a:xfrm>
+            <a:off x="11612880" y="5306014"/>
+            <a:ext cx="54864" cy="241069"/>
+          </a:xfrm>
+          <a:prstGeom prst="rect">
+            <a:avLst/>
+          </a:prstGeom>
+          <a:solidFill>
+            <a:srgbClr val="C2352F"/>
+          </a:solidFill>
+          <a:ln/>
+        </p:spPr>
+      </p:sp>
+      <p:sp>
+        <p:nvSpPr>
+          <p:cNvPr id="145" name="Text 143"/>
           <p:cNvSpPr txBox="1"/>
           <p:nvPr/>
         </p:nvSpPr>
@@ -6774,7 +6954,7 @@
       </p:sp>
       <p:sp>
         <p:nvSpPr>
-          <p:cNvPr id="137" name="Text 135"/>
+          <p:cNvPr id="146" name="Text 144"/>
           <p:cNvSpPr txBox="1"/>
           <p:nvPr/>
         </p:nvSpPr>
@@ -6813,7 +6993,7 @@
       </p:sp>
       <p:sp>
         <p:nvSpPr>
-          <p:cNvPr id="138" name="Text 136"/>
+          <p:cNvPr id="147" name="Text 145"/>
           <p:cNvSpPr txBox="1"/>
           <p:nvPr/>
         </p:nvSpPr>
@@ -6852,7 +7032,7 @@
       </p:sp>
       <p:sp>
         <p:nvSpPr>
-          <p:cNvPr id="139" name="Shape 137"/>
+          <p:cNvPr id="148" name="Shape 146"/>
           <p:cNvSpPr/>
           <p:nvPr/>
         </p:nvSpPr>
@@ -6872,7 +7052,7 @@
       </p:sp>
       <p:sp>
         <p:nvSpPr>
-          <p:cNvPr id="140" name="Text 138"/>
+          <p:cNvPr id="149" name="Text 147"/>
           <p:cNvSpPr txBox="1"/>
           <p:nvPr/>
         </p:nvSpPr>

</xml_diff>